<commit_message>
Added vid and report work
</commit_message>
<xml_diff>
--- a/Documentation/Weekly Report/week12/CMSC-4920-Week12-Group2.pptx
+++ b/Documentation/Weekly Report/week12/CMSC-4920-Week12-Group2.pptx
@@ -5,7 +5,7 @@
     <p:sldMasterId id="2147483648" r:id="rId1"/>
   </p:sldMasterIdLst>
   <p:notesMasterIdLst>
-    <p:notesMasterId r:id="rId10"/>
+    <p:notesMasterId r:id="rId11"/>
   </p:notesMasterIdLst>
   <p:sldIdLst>
     <p:sldId id="256" r:id="rId2"/>
@@ -13,9 +13,10 @@
     <p:sldId id="265" r:id="rId4"/>
     <p:sldId id="266" r:id="rId5"/>
     <p:sldId id="258" r:id="rId6"/>
-    <p:sldId id="264" r:id="rId7"/>
-    <p:sldId id="259" r:id="rId8"/>
-    <p:sldId id="260" r:id="rId9"/>
+    <p:sldId id="272" r:id="rId7"/>
+    <p:sldId id="264" r:id="rId8"/>
+    <p:sldId id="259" r:id="rId9"/>
+    <p:sldId id="260" r:id="rId10"/>
   </p:sldIdLst>
   <p:sldSz cx="12192000" cy="6858000"/>
   <p:notesSz cx="6858000" cy="9144000"/>
@@ -125,14 +126,136 @@
 <file path=ppt/revisionInfo.xml><?xml version="1.0" encoding="utf-8"?>
 <p1510:revInfo xmlns:a="http://schemas.openxmlformats.org/drawingml/2006/main" xmlns:r="http://schemas.openxmlformats.org/officeDocument/2006/relationships" xmlns:p1510="http://schemas.microsoft.com/office/powerpoint/2015/10/main">
   <p1510:revLst>
-    <p1510:client id="{06411FC2-7443-4BF5-B8F4-5EEEE928CA1B}" v="1" dt="2026-03-29T13:00:01.797"/>
-    <p1510:client id="{77306D07-9C8A-416F-9B20-89AAB5815DA9}" v="2" dt="2026-03-30T01:09:55.841"/>
+    <p1510:client id="{C9738FE7-D6DF-4424-AB5E-DBD3476A8FE7}" v="3" dt="2026-04-04T21:42:41.900"/>
   </p1510:revLst>
 </p1510:revInfo>
 </file>
 
 <file path=ppt/changesInfos/changesInfo1.xml><?xml version="1.0" encoding="utf-8"?>
 <pc:chgInfo xmlns:a="http://schemas.openxmlformats.org/drawingml/2006/main" xmlns:r="http://schemas.openxmlformats.org/officeDocument/2006/relationships" xmlns:ac="http://schemas.microsoft.com/office/drawing/2013/main/command" xmlns:pc="http://schemas.microsoft.com/office/powerpoint/2013/main/command">
+  <pc:docChgLst>
+    <pc:chgData name="John Gerega" userId="bd3e1e46fb6a714b" providerId="LiveId" clId="{45F0C402-C550-4C82-B31D-5B32217A5E94}"/>
+    <pc:docChg chg="undo custSel addSld delSld modSld">
+      <pc:chgData name="John Gerega" userId="bd3e1e46fb6a714b" providerId="LiveId" clId="{45F0C402-C550-4C82-B31D-5B32217A5E94}" dt="2026-04-04T21:43:59.122" v="3258" actId="20577"/>
+      <pc:docMkLst>
+        <pc:docMk/>
+      </pc:docMkLst>
+      <pc:sldChg chg="modSp mod">
+        <pc:chgData name="John Gerega" userId="bd3e1e46fb6a714b" providerId="LiveId" clId="{45F0C402-C550-4C82-B31D-5B32217A5E94}" dt="2026-03-29T13:00:56.525" v="2636" actId="20577"/>
+        <pc:sldMkLst>
+          <pc:docMk/>
+          <pc:sldMk cId="2561402868" sldId="264"/>
+        </pc:sldMkLst>
+        <pc:spChg chg="mod">
+          <ac:chgData name="John Gerega" userId="bd3e1e46fb6a714b" providerId="LiveId" clId="{45F0C402-C550-4C82-B31D-5B32217A5E94}" dt="2026-03-09T00:42:55.862" v="1001" actId="20577"/>
+          <ac:spMkLst>
+            <pc:docMk/>
+            <pc:sldMk cId="2561402868" sldId="264"/>
+            <ac:spMk id="9" creationId="{D6D36DC8-D9BF-8C26-69EA-ED89E34DB644}"/>
+          </ac:spMkLst>
+        </pc:spChg>
+        <pc:graphicFrameChg chg="mod modGraphic">
+          <ac:chgData name="John Gerega" userId="bd3e1e46fb6a714b" providerId="LiveId" clId="{45F0C402-C550-4C82-B31D-5B32217A5E94}" dt="2026-03-29T13:00:56.525" v="2636" actId="20577"/>
+          <ac:graphicFrameMkLst>
+            <pc:docMk/>
+            <pc:sldMk cId="2561402868" sldId="264"/>
+            <ac:graphicFrameMk id="27" creationId="{D6B93F0B-FEB0-EDAB-CFE1-A57DEFE97FCD}"/>
+          </ac:graphicFrameMkLst>
+        </pc:graphicFrameChg>
+      </pc:sldChg>
+      <pc:sldChg chg="addSp delSp modSp mod">
+        <pc:chgData name="John Gerega" userId="bd3e1e46fb6a714b" providerId="LiveId" clId="{45F0C402-C550-4C82-B31D-5B32217A5E94}" dt="2026-04-04T21:42:06.712" v="2692" actId="20577"/>
+        <pc:sldMkLst>
+          <pc:docMk/>
+          <pc:sldMk cId="2428741132" sldId="265"/>
+        </pc:sldMkLst>
+        <pc:spChg chg="mod">
+          <ac:chgData name="John Gerega" userId="bd3e1e46fb6a714b" providerId="LiveId" clId="{45F0C402-C550-4C82-B31D-5B32217A5E94}" dt="2026-04-04T21:42:06.712" v="2692" actId="20577"/>
+          <ac:spMkLst>
+            <pc:docMk/>
+            <pc:sldMk cId="2428741132" sldId="265"/>
+            <ac:spMk id="8" creationId="{7A067979-B2B3-BD33-28AB-42AF2BBE1977}"/>
+          </ac:spMkLst>
+        </pc:spChg>
+      </pc:sldChg>
+      <pc:sldChg chg="addSp modSp mod">
+        <pc:chgData name="John Gerega" userId="bd3e1e46fb6a714b" providerId="LiveId" clId="{45F0C402-C550-4C82-B31D-5B32217A5E94}" dt="2026-04-04T21:43:59.122" v="3258" actId="20577"/>
+        <pc:sldMkLst>
+          <pc:docMk/>
+          <pc:sldMk cId="3526335932" sldId="266"/>
+        </pc:sldMkLst>
+        <pc:spChg chg="add mod">
+          <ac:chgData name="John Gerega" userId="bd3e1e46fb6a714b" providerId="LiveId" clId="{45F0C402-C550-4C82-B31D-5B32217A5E94}" dt="2026-03-22T16:14:00.248" v="2133" actId="20577"/>
+          <ac:spMkLst>
+            <pc:docMk/>
+            <pc:sldMk cId="3526335932" sldId="266"/>
+            <ac:spMk id="2" creationId="{B95521BC-C5E6-AB41-0BC9-A706E6412C75}"/>
+          </ac:spMkLst>
+        </pc:spChg>
+        <pc:spChg chg="mod">
+          <ac:chgData name="John Gerega" userId="bd3e1e46fb6a714b" providerId="LiveId" clId="{45F0C402-C550-4C82-B31D-5B32217A5E94}" dt="2026-03-09T00:42:40.261" v="1000" actId="20577"/>
+          <ac:spMkLst>
+            <pc:docMk/>
+            <pc:sldMk cId="3526335932" sldId="266"/>
+            <ac:spMk id="3" creationId="{CCDEAB36-867D-95B6-8834-F42C5B9259D0}"/>
+          </ac:spMkLst>
+        </pc:spChg>
+        <pc:spChg chg="mod">
+          <ac:chgData name="John Gerega" userId="bd3e1e46fb6a714b" providerId="LiveId" clId="{45F0C402-C550-4C82-B31D-5B32217A5E94}" dt="2026-04-04T21:43:44.510" v="3160" actId="20577"/>
+          <ac:spMkLst>
+            <pc:docMk/>
+            <pc:sldMk cId="3526335932" sldId="266"/>
+            <ac:spMk id="4" creationId="{86ED9EE4-56A8-6AFD-BE9A-A35D2ABC59A0}"/>
+          </ac:spMkLst>
+        </pc:spChg>
+        <pc:spChg chg="add mod">
+          <ac:chgData name="John Gerega" userId="bd3e1e46fb6a714b" providerId="LiveId" clId="{45F0C402-C550-4C82-B31D-5B32217A5E94}" dt="2026-04-04T21:43:59.122" v="3258" actId="20577"/>
+          <ac:spMkLst>
+            <pc:docMk/>
+            <pc:sldMk cId="3526335932" sldId="266"/>
+            <ac:spMk id="6" creationId="{3B13CF04-9C06-053E-69E2-58CD31C3D276}"/>
+          </ac:spMkLst>
+        </pc:spChg>
+      </pc:sldChg>
+      <pc:sldChg chg="new del">
+        <pc:chgData name="John Gerega" userId="bd3e1e46fb6a714b" providerId="LiveId" clId="{45F0C402-C550-4C82-B31D-5B32217A5E94}" dt="2026-04-04T21:41:51.178" v="2647" actId="47"/>
+        <pc:sldMkLst>
+          <pc:docMk/>
+          <pc:sldMk cId="4231616159" sldId="267"/>
+        </pc:sldMkLst>
+      </pc:sldChg>
+      <pc:sldChg chg="new del">
+        <pc:chgData name="John Gerega" userId="bd3e1e46fb6a714b" providerId="LiveId" clId="{45F0C402-C550-4C82-B31D-5B32217A5E94}" dt="2026-04-04T21:40:29.924" v="2639" actId="2696"/>
+        <pc:sldMkLst>
+          <pc:docMk/>
+          <pc:sldMk cId="2457171460" sldId="268"/>
+        </pc:sldMkLst>
+      </pc:sldChg>
+      <pc:sldChg chg="addSp delSp modSp add mod delAnim modAnim">
+        <pc:chgData name="John Gerega" userId="bd3e1e46fb6a714b" providerId="LiveId" clId="{45F0C402-C550-4C82-B31D-5B32217A5E94}" dt="2026-04-04T21:41:40.956" v="2646" actId="14100"/>
+        <pc:sldMkLst>
+          <pc:docMk/>
+          <pc:sldMk cId="2282075488" sldId="272"/>
+        </pc:sldMkLst>
+        <pc:picChg chg="add mod">
+          <ac:chgData name="John Gerega" userId="bd3e1e46fb6a714b" providerId="LiveId" clId="{45F0C402-C550-4C82-B31D-5B32217A5E94}" dt="2026-04-04T21:41:40.956" v="2646" actId="14100"/>
+          <ac:picMkLst>
+            <pc:docMk/>
+            <pc:sldMk cId="2282075488" sldId="272"/>
+            <ac:picMk id="3" creationId="{E59A6658-36B8-AE97-C67F-8DC16AF87712}"/>
+          </ac:picMkLst>
+        </pc:picChg>
+        <pc:picChg chg="del">
+          <ac:chgData name="John Gerega" userId="bd3e1e46fb6a714b" providerId="LiveId" clId="{45F0C402-C550-4C82-B31D-5B32217A5E94}" dt="2026-04-04T21:41:17.826" v="2641" actId="478"/>
+          <ac:picMkLst>
+            <pc:docMk/>
+            <pc:sldMk cId="2282075488" sldId="272"/>
+            <ac:picMk id="5" creationId="{AD0A49AD-572F-1BD3-B96A-4F6CEBD54DC1}"/>
+          </ac:picMkLst>
+        </pc:picChg>
+      </pc:sldChg>
+    </pc:docChg>
+  </pc:docChgLst>
   <pc:docChgLst>
     <pc:chgData name="Margo Bonal" userId="18c9fa0f-b53d-478b-9dc0-6ad88786c19f" providerId="ADAL" clId="{93D479E5-F67F-4B8A-A78F-A0B574A116B6}"/>
     <pc:docChg chg="undo custSel addSld delSld modSld">
@@ -198,163 +321,6 @@
             <pc:docMk/>
             <pc:sldMk cId="3526335932" sldId="266"/>
             <ac:spMk id="4" creationId="{86ED9EE4-56A8-6AFD-BE9A-A35D2ABC59A0}"/>
-          </ac:spMkLst>
-        </pc:spChg>
-      </pc:sldChg>
-      <pc:sldChg chg="addSp delSp modSp new mod setBg modAnim">
-        <pc:chgData name="Margo Bonal" userId="18c9fa0f-b53d-478b-9dc0-6ad88786c19f" providerId="ADAL" clId="{93D479E5-F67F-4B8A-A78F-A0B574A116B6}" dt="2026-03-30T01:09:55.841" v="967"/>
-        <pc:sldMkLst>
-          <pc:docMk/>
-          <pc:sldMk cId="2282075488" sldId="272"/>
-        </pc:sldMkLst>
-        <pc:spChg chg="mod">
-          <ac:chgData name="Margo Bonal" userId="18c9fa0f-b53d-478b-9dc0-6ad88786c19f" providerId="ADAL" clId="{93D479E5-F67F-4B8A-A78F-A0B574A116B6}" dt="2026-03-30T01:09:17.696" v="964" actId="1076"/>
-          <ac:spMkLst>
-            <pc:docMk/>
-            <pc:sldMk cId="2282075488" sldId="272"/>
-            <ac:spMk id="2" creationId="{C074B1A4-0C15-D874-CBCA-1FB85D3E881D}"/>
-          </ac:spMkLst>
-        </pc:spChg>
-        <pc:spChg chg="del mod">
-          <ac:chgData name="Margo Bonal" userId="18c9fa0f-b53d-478b-9dc0-6ad88786c19f" providerId="ADAL" clId="{93D479E5-F67F-4B8A-A78F-A0B574A116B6}" dt="2026-03-30T01:09:10.546" v="962" actId="478"/>
-          <ac:spMkLst>
-            <pc:docMk/>
-            <pc:sldMk cId="2282075488" sldId="272"/>
-            <ac:spMk id="3" creationId="{F4E85839-AE79-1611-C032-A927048C8D32}"/>
-          </ac:spMkLst>
-        </pc:spChg>
-        <pc:spChg chg="add">
-          <ac:chgData name="Margo Bonal" userId="18c9fa0f-b53d-478b-9dc0-6ad88786c19f" providerId="ADAL" clId="{93D479E5-F67F-4B8A-A78F-A0B574A116B6}" dt="2026-03-30T01:08:59.596" v="958" actId="26606"/>
-          <ac:spMkLst>
-            <pc:docMk/>
-            <pc:sldMk cId="2282075488" sldId="272"/>
-            <ac:spMk id="9" creationId="{A8384FB5-9ADC-4DDC-881B-597D56F5B15D}"/>
-          </ac:spMkLst>
-        </pc:spChg>
-        <pc:spChg chg="add">
-          <ac:chgData name="Margo Bonal" userId="18c9fa0f-b53d-478b-9dc0-6ad88786c19f" providerId="ADAL" clId="{93D479E5-F67F-4B8A-A78F-A0B574A116B6}" dt="2026-03-30T01:08:59.596" v="958" actId="26606"/>
-          <ac:spMkLst>
-            <pc:docMk/>
-            <pc:sldMk cId="2282075488" sldId="272"/>
-            <ac:spMk id="11" creationId="{1199E1B1-A8C0-4FE8-A5A8-1CB41D69F857}"/>
-          </ac:spMkLst>
-        </pc:spChg>
-        <pc:spChg chg="add">
-          <ac:chgData name="Margo Bonal" userId="18c9fa0f-b53d-478b-9dc0-6ad88786c19f" providerId="ADAL" clId="{93D479E5-F67F-4B8A-A78F-A0B574A116B6}" dt="2026-03-30T01:08:59.596" v="958" actId="26606"/>
-          <ac:spMkLst>
-            <pc:docMk/>
-            <pc:sldMk cId="2282075488" sldId="272"/>
-            <ac:spMk id="13" creationId="{84A8DE83-DE75-4B41-9DB4-A7EC0B0DEC0B}"/>
-          </ac:spMkLst>
-        </pc:spChg>
-        <pc:spChg chg="add">
-          <ac:chgData name="Margo Bonal" userId="18c9fa0f-b53d-478b-9dc0-6ad88786c19f" providerId="ADAL" clId="{93D479E5-F67F-4B8A-A78F-A0B574A116B6}" dt="2026-03-30T01:08:59.596" v="958" actId="26606"/>
-          <ac:spMkLst>
-            <pc:docMk/>
-            <pc:sldMk cId="2282075488" sldId="272"/>
-            <ac:spMk id="15" creationId="{A7009A0A-BEF5-4EAC-AF15-E4F9F002E239}"/>
-          </ac:spMkLst>
-        </pc:spChg>
-        <pc:picChg chg="add del mod">
-          <ac:chgData name="Margo Bonal" userId="18c9fa0f-b53d-478b-9dc0-6ad88786c19f" providerId="ADAL" clId="{93D479E5-F67F-4B8A-A78F-A0B574A116B6}" dt="2026-03-30T01:09:31.322" v="966" actId="478"/>
-          <ac:picMkLst>
-            <pc:docMk/>
-            <pc:sldMk cId="2282075488" sldId="272"/>
-            <ac:picMk id="4" creationId="{4F012FE5-91F7-BF57-0376-41BC4711BDEB}"/>
-          </ac:picMkLst>
-        </pc:picChg>
-        <pc:picChg chg="add mod">
-          <ac:chgData name="Margo Bonal" userId="18c9fa0f-b53d-478b-9dc0-6ad88786c19f" providerId="ADAL" clId="{93D479E5-F67F-4B8A-A78F-A0B574A116B6}" dt="2026-03-30T01:09:55.841" v="967"/>
-          <ac:picMkLst>
-            <pc:docMk/>
-            <pc:sldMk cId="2282075488" sldId="272"/>
-            <ac:picMk id="5" creationId="{AD0A49AD-572F-1BD3-B96A-4F6CEBD54DC1}"/>
-          </ac:picMkLst>
-        </pc:picChg>
-      </pc:sldChg>
-    </pc:docChg>
-  </pc:docChgLst>
-  <pc:docChgLst>
-    <pc:chgData name="John Gerega" userId="bd3e1e46fb6a714b" providerId="LiveId" clId="{45F0C402-C550-4C82-B31D-5B32217A5E94}"/>
-    <pc:docChg chg="undo custSel addSld delSld modSld">
-      <pc:chgData name="John Gerega" userId="bd3e1e46fb6a714b" providerId="LiveId" clId="{45F0C402-C550-4C82-B31D-5B32217A5E94}" dt="2026-03-29T13:00:56.525" v="2636" actId="20577"/>
-      <pc:docMkLst>
-        <pc:docMk/>
-      </pc:docMkLst>
-      <pc:sldChg chg="modSp mod">
-        <pc:chgData name="John Gerega" userId="bd3e1e46fb6a714b" providerId="LiveId" clId="{45F0C402-C550-4C82-B31D-5B32217A5E94}" dt="2026-03-29T13:00:56.525" v="2636" actId="20577"/>
-        <pc:sldMkLst>
-          <pc:docMk/>
-          <pc:sldMk cId="2561402868" sldId="264"/>
-        </pc:sldMkLst>
-        <pc:spChg chg="mod">
-          <ac:chgData name="John Gerega" userId="bd3e1e46fb6a714b" providerId="LiveId" clId="{45F0C402-C550-4C82-B31D-5B32217A5E94}" dt="2026-03-09T00:42:55.862" v="1001" actId="20577"/>
-          <ac:spMkLst>
-            <pc:docMk/>
-            <pc:sldMk cId="2561402868" sldId="264"/>
-            <ac:spMk id="9" creationId="{D6D36DC8-D9BF-8C26-69EA-ED89E34DB644}"/>
-          </ac:spMkLst>
-        </pc:spChg>
-        <pc:graphicFrameChg chg="mod modGraphic">
-          <ac:chgData name="John Gerega" userId="bd3e1e46fb6a714b" providerId="LiveId" clId="{45F0C402-C550-4C82-B31D-5B32217A5E94}" dt="2026-03-29T13:00:56.525" v="2636" actId="20577"/>
-          <ac:graphicFrameMkLst>
-            <pc:docMk/>
-            <pc:sldMk cId="2561402868" sldId="264"/>
-            <ac:graphicFrameMk id="27" creationId="{D6B93F0B-FEB0-EDAB-CFE1-A57DEFE97FCD}"/>
-          </ac:graphicFrameMkLst>
-        </pc:graphicFrameChg>
-      </pc:sldChg>
-      <pc:sldChg chg="addSp delSp modSp mod">
-        <pc:chgData name="John Gerega" userId="bd3e1e46fb6a714b" providerId="LiveId" clId="{45F0C402-C550-4C82-B31D-5B32217A5E94}" dt="2026-03-29T12:59:14.493" v="2160" actId="20577"/>
-        <pc:sldMkLst>
-          <pc:docMk/>
-          <pc:sldMk cId="2428741132" sldId="265"/>
-        </pc:sldMkLst>
-        <pc:spChg chg="mod">
-          <ac:chgData name="John Gerega" userId="bd3e1e46fb6a714b" providerId="LiveId" clId="{45F0C402-C550-4C82-B31D-5B32217A5E94}" dt="2026-03-29T12:59:14.493" v="2160" actId="20577"/>
-          <ac:spMkLst>
-            <pc:docMk/>
-            <pc:sldMk cId="2428741132" sldId="265"/>
-            <ac:spMk id="8" creationId="{7A067979-B2B3-BD33-28AB-42AF2BBE1977}"/>
-          </ac:spMkLst>
-        </pc:spChg>
-      </pc:sldChg>
-      <pc:sldChg chg="addSp modSp mod">
-        <pc:chgData name="John Gerega" userId="bd3e1e46fb6a714b" providerId="LiveId" clId="{45F0C402-C550-4C82-B31D-5B32217A5E94}" dt="2026-03-29T13:00:43.047" v="2618" actId="20577"/>
-        <pc:sldMkLst>
-          <pc:docMk/>
-          <pc:sldMk cId="3526335932" sldId="266"/>
-        </pc:sldMkLst>
-        <pc:spChg chg="add mod">
-          <ac:chgData name="John Gerega" userId="bd3e1e46fb6a714b" providerId="LiveId" clId="{45F0C402-C550-4C82-B31D-5B32217A5E94}" dt="2026-03-22T16:14:00.248" v="2133" actId="20577"/>
-          <ac:spMkLst>
-            <pc:docMk/>
-            <pc:sldMk cId="3526335932" sldId="266"/>
-            <ac:spMk id="2" creationId="{B95521BC-C5E6-AB41-0BC9-A706E6412C75}"/>
-          </ac:spMkLst>
-        </pc:spChg>
-        <pc:spChg chg="mod">
-          <ac:chgData name="John Gerega" userId="bd3e1e46fb6a714b" providerId="LiveId" clId="{45F0C402-C550-4C82-B31D-5B32217A5E94}" dt="2026-03-09T00:42:40.261" v="1000" actId="20577"/>
-          <ac:spMkLst>
-            <pc:docMk/>
-            <pc:sldMk cId="3526335932" sldId="266"/>
-            <ac:spMk id="3" creationId="{CCDEAB36-867D-95B6-8834-F42C5B9259D0}"/>
-          </ac:spMkLst>
-        </pc:spChg>
-        <pc:spChg chg="mod">
-          <ac:chgData name="John Gerega" userId="bd3e1e46fb6a714b" providerId="LiveId" clId="{45F0C402-C550-4C82-B31D-5B32217A5E94}" dt="2026-03-29T12:59:43.711" v="2344" actId="20577"/>
-          <ac:spMkLst>
-            <pc:docMk/>
-            <pc:sldMk cId="3526335932" sldId="266"/>
-            <ac:spMk id="4" creationId="{86ED9EE4-56A8-6AFD-BE9A-A35D2ABC59A0}"/>
-          </ac:spMkLst>
-        </pc:spChg>
-        <pc:spChg chg="add mod">
-          <ac:chgData name="John Gerega" userId="bd3e1e46fb6a714b" providerId="LiveId" clId="{45F0C402-C550-4C82-B31D-5B32217A5E94}" dt="2026-03-29T13:00:43.047" v="2618" actId="20577"/>
-          <ac:spMkLst>
-            <pc:docMk/>
-            <pc:sldMk cId="3526335932" sldId="266"/>
-            <ac:spMk id="6" creationId="{3B13CF04-9C06-053E-69E2-58CD31C3D276}"/>
           </ac:spMkLst>
         </pc:spChg>
       </pc:sldChg>
@@ -427,75 +393,6 @@
             <ac:spMk id="4" creationId="{86ED9EE4-56A8-6AFD-BE9A-A35D2ABC59A0}"/>
           </ac:spMkLst>
         </pc:spChg>
-      </pc:sldChg>
-      <pc:sldChg chg="addSp delSp modSp new mod">
-        <pc:chgData name="Margo Bonal" userId="18c9fa0f-b53d-478b-9dc0-6ad88786c19f" providerId="ADAL" clId="{57E2D5E0-CA32-47BE-A2DC-7B0365E99328}" dt="2026-03-28T15:02:49.042" v="174" actId="14100"/>
-        <pc:sldMkLst>
-          <pc:docMk/>
-          <pc:sldMk cId="2137746370" sldId="267"/>
-        </pc:sldMkLst>
-        <pc:picChg chg="add mod">
-          <ac:chgData name="Margo Bonal" userId="18c9fa0f-b53d-478b-9dc0-6ad88786c19f" providerId="ADAL" clId="{57E2D5E0-CA32-47BE-A2DC-7B0365E99328}" dt="2026-03-28T15:02:49.042" v="174" actId="14100"/>
-          <ac:picMkLst>
-            <pc:docMk/>
-            <pc:sldMk cId="2137746370" sldId="267"/>
-            <ac:picMk id="5" creationId="{E64349BE-F07A-2A10-0BC0-DE99D4D44150}"/>
-          </ac:picMkLst>
-        </pc:picChg>
-      </pc:sldChg>
-      <pc:sldChg chg="addSp delSp modSp new mod ord">
-        <pc:chgData name="Margo Bonal" userId="18c9fa0f-b53d-478b-9dc0-6ad88786c19f" providerId="ADAL" clId="{57E2D5E0-CA32-47BE-A2DC-7B0365E99328}" dt="2026-03-28T15:16:48.747" v="374" actId="9405"/>
-        <pc:sldMkLst>
-          <pc:docMk/>
-          <pc:sldMk cId="522380866" sldId="268"/>
-        </pc:sldMkLst>
-        <pc:picChg chg="add mod">
-          <ac:chgData name="Margo Bonal" userId="18c9fa0f-b53d-478b-9dc0-6ad88786c19f" providerId="ADAL" clId="{57E2D5E0-CA32-47BE-A2DC-7B0365E99328}" dt="2026-03-28T15:15:32.474" v="367" actId="14100"/>
-          <ac:picMkLst>
-            <pc:docMk/>
-            <pc:sldMk cId="522380866" sldId="268"/>
-            <ac:picMk id="5" creationId="{C302D35B-D975-7EDF-68F9-A7B25B25FE30}"/>
-          </ac:picMkLst>
-        </pc:picChg>
-        <pc:inkChg chg="add">
-          <ac:chgData name="Margo Bonal" userId="18c9fa0f-b53d-478b-9dc0-6ad88786c19f" providerId="ADAL" clId="{57E2D5E0-CA32-47BE-A2DC-7B0365E99328}" dt="2026-03-28T15:16:45.009" v="373" actId="9405"/>
-          <ac:inkMkLst>
-            <pc:docMk/>
-            <pc:sldMk cId="522380866" sldId="268"/>
-            <ac:inkMk id="6" creationId="{B65C59D1-2617-62D9-6288-1EF3DA190139}"/>
-          </ac:inkMkLst>
-        </pc:inkChg>
-        <pc:inkChg chg="add">
-          <ac:chgData name="Margo Bonal" userId="18c9fa0f-b53d-478b-9dc0-6ad88786c19f" providerId="ADAL" clId="{57E2D5E0-CA32-47BE-A2DC-7B0365E99328}" dt="2026-03-28T15:16:48.747" v="374" actId="9405"/>
-          <ac:inkMkLst>
-            <pc:docMk/>
-            <pc:sldMk cId="522380866" sldId="268"/>
-            <ac:inkMk id="7" creationId="{516CAB8D-8D09-D1C6-CAEE-97AE5CD2590A}"/>
-          </ac:inkMkLst>
-        </pc:inkChg>
-      </pc:sldChg>
-      <pc:sldChg chg="addSp delSp modSp new mod ord">
-        <pc:chgData name="Margo Bonal" userId="18c9fa0f-b53d-478b-9dc0-6ad88786c19f" providerId="ADAL" clId="{57E2D5E0-CA32-47BE-A2DC-7B0365E99328}" dt="2026-03-28T15:16:37.233" v="372" actId="9405"/>
-        <pc:sldMkLst>
-          <pc:docMk/>
-          <pc:sldMk cId="405284316" sldId="269"/>
-        </pc:sldMkLst>
-        <pc:picChg chg="add mod">
-          <ac:chgData name="Margo Bonal" userId="18c9fa0f-b53d-478b-9dc0-6ad88786c19f" providerId="ADAL" clId="{57E2D5E0-CA32-47BE-A2DC-7B0365E99328}" dt="2026-03-28T15:15:27.255" v="365" actId="14100"/>
-          <ac:picMkLst>
-            <pc:docMk/>
-            <pc:sldMk cId="405284316" sldId="269"/>
-            <ac:picMk id="5" creationId="{F5350F03-A149-BD73-26B9-8766C33D9ABB}"/>
-          </ac:picMkLst>
-        </pc:picChg>
-        <pc:inkChg chg="add">
-          <ac:chgData name="Margo Bonal" userId="18c9fa0f-b53d-478b-9dc0-6ad88786c19f" providerId="ADAL" clId="{57E2D5E0-CA32-47BE-A2DC-7B0365E99328}" dt="2026-03-28T15:16:37.233" v="372" actId="9405"/>
-          <ac:inkMkLst>
-            <pc:docMk/>
-            <pc:sldMk cId="405284316" sldId="269"/>
-            <ac:inkMk id="6" creationId="{C7D73243-445E-0B04-A779-41352EFCFB99}"/>
-          </ac:inkMkLst>
-        </pc:inkChg>
       </pc:sldChg>
     </pc:docChg>
   </pc:docChgLst>
@@ -6395,7 +6292,7 @@
           <a:p>
             <a:fld id="{B1F2A6E6-BB86-4722-837C-048EA2408876}" type="datetimeFigureOut">
               <a:rPr lang="en-US" smtClean="0"/>
-              <a:t>4/2/2026</a:t>
+              <a:t>4/4/2026</a:t>
             </a:fld>
             <a:endParaRPr lang="en-US"/>
           </a:p>
@@ -6809,7 +6706,7 @@
           <a:p>
             <a:fld id="{C882E6FB-EB88-4936-BED9-9E37159958CA}" type="datetimeFigureOut">
               <a:rPr lang="en-US" smtClean="0"/>
-              <a:t>4/2/2026</a:t>
+              <a:t>4/4/2026</a:t>
             </a:fld>
             <a:endParaRPr lang="en-US"/>
           </a:p>
@@ -7007,7 +6904,7 @@
           <a:p>
             <a:fld id="{C882E6FB-EB88-4936-BED9-9E37159958CA}" type="datetimeFigureOut">
               <a:rPr lang="en-US" smtClean="0"/>
-              <a:t>4/2/2026</a:t>
+              <a:t>4/4/2026</a:t>
             </a:fld>
             <a:endParaRPr lang="en-US"/>
           </a:p>
@@ -7215,7 +7112,7 @@
           <a:p>
             <a:fld id="{C882E6FB-EB88-4936-BED9-9E37159958CA}" type="datetimeFigureOut">
               <a:rPr lang="en-US" smtClean="0"/>
-              <a:t>4/2/2026</a:t>
+              <a:t>4/4/2026</a:t>
             </a:fld>
             <a:endParaRPr lang="en-US"/>
           </a:p>
@@ -7413,7 +7310,7 @@
           <a:p>
             <a:fld id="{C882E6FB-EB88-4936-BED9-9E37159958CA}" type="datetimeFigureOut">
               <a:rPr lang="en-US" smtClean="0"/>
-              <a:t>4/2/2026</a:t>
+              <a:t>4/4/2026</a:t>
             </a:fld>
             <a:endParaRPr lang="en-US"/>
           </a:p>
@@ -7688,7 +7585,7 @@
           <a:p>
             <a:fld id="{C882E6FB-EB88-4936-BED9-9E37159958CA}" type="datetimeFigureOut">
               <a:rPr lang="en-US" smtClean="0"/>
-              <a:t>4/2/2026</a:t>
+              <a:t>4/4/2026</a:t>
             </a:fld>
             <a:endParaRPr lang="en-US"/>
           </a:p>
@@ -7953,7 +7850,7 @@
           <a:p>
             <a:fld id="{C882E6FB-EB88-4936-BED9-9E37159958CA}" type="datetimeFigureOut">
               <a:rPr lang="en-US" smtClean="0"/>
-              <a:t>4/2/2026</a:t>
+              <a:t>4/4/2026</a:t>
             </a:fld>
             <a:endParaRPr lang="en-US"/>
           </a:p>
@@ -8365,7 +8262,7 @@
           <a:p>
             <a:fld id="{C882E6FB-EB88-4936-BED9-9E37159958CA}" type="datetimeFigureOut">
               <a:rPr lang="en-US" smtClean="0"/>
-              <a:t>4/2/2026</a:t>
+              <a:t>4/4/2026</a:t>
             </a:fld>
             <a:endParaRPr lang="en-US"/>
           </a:p>
@@ -8506,7 +8403,7 @@
           <a:p>
             <a:fld id="{C882E6FB-EB88-4936-BED9-9E37159958CA}" type="datetimeFigureOut">
               <a:rPr lang="en-US" smtClean="0"/>
-              <a:t>4/2/2026</a:t>
+              <a:t>4/4/2026</a:t>
             </a:fld>
             <a:endParaRPr lang="en-US"/>
           </a:p>
@@ -8619,7 +8516,7 @@
           <a:p>
             <a:fld id="{C882E6FB-EB88-4936-BED9-9E37159958CA}" type="datetimeFigureOut">
               <a:rPr lang="en-US" smtClean="0"/>
-              <a:t>4/2/2026</a:t>
+              <a:t>4/4/2026</a:t>
             </a:fld>
             <a:endParaRPr lang="en-US"/>
           </a:p>
@@ -8930,7 +8827,7 @@
           <a:p>
             <a:fld id="{C882E6FB-EB88-4936-BED9-9E37159958CA}" type="datetimeFigureOut">
               <a:rPr lang="en-US" smtClean="0"/>
-              <a:t>4/2/2026</a:t>
+              <a:t>4/4/2026</a:t>
             </a:fld>
             <a:endParaRPr lang="en-US"/>
           </a:p>
@@ -9218,7 +9115,7 @@
           <a:p>
             <a:fld id="{C882E6FB-EB88-4936-BED9-9E37159958CA}" type="datetimeFigureOut">
               <a:rPr lang="en-US" smtClean="0"/>
-              <a:t>4/2/2026</a:t>
+              <a:t>4/4/2026</a:t>
             </a:fld>
             <a:endParaRPr lang="en-US"/>
           </a:p>
@@ -9459,7 +9356,7 @@
           <a:p>
             <a:fld id="{C882E6FB-EB88-4936-BED9-9E37159958CA}" type="datetimeFigureOut">
               <a:rPr lang="en-US" smtClean="0"/>
-              <a:t>4/2/2026</a:t>
+              <a:t>4/4/2026</a:t>
             </a:fld>
             <a:endParaRPr lang="en-US"/>
           </a:p>
@@ -10958,7 +10855,7 @@
         </p:spPr>
         <p:txBody>
           <a:bodyPr vert="horz" lIns="91440" tIns="45720" rIns="91440" bIns="45720" rtlCol="0">
-            <a:normAutofit/>
+            <a:normAutofit lnSpcReduction="10000"/>
           </a:bodyPr>
           <a:lstStyle>
             <a:lvl1pPr marL="0" indent="0" algn="l" defTabSz="914400" rtl="0" eaLnBrk="1" latinLnBrk="0" hangingPunct="1">
@@ -11206,6 +11103,62 @@
             </a:r>
           </a:p>
           <a:p>
+            <a:pPr marL="800100" lvl="1" indent="-342900">
+              <a:buFont typeface="Arial" panose="020B0604020202020204" pitchFamily="34" charset="0"/>
+              <a:buChar char="•"/>
+            </a:pPr>
+            <a:r>
+              <a:rPr lang="en-US" dirty="0">
+                <a:solidFill>
+                  <a:schemeClr val="tx1"/>
+                </a:solidFill>
+              </a:rPr>
+              <a:t>Invites</a:t>
+            </a:r>
+          </a:p>
+          <a:p>
+            <a:pPr marL="800100" lvl="1" indent="-342900">
+              <a:buFont typeface="Arial" panose="020B0604020202020204" pitchFamily="34" charset="0"/>
+              <a:buChar char="•"/>
+            </a:pPr>
+            <a:r>
+              <a:rPr lang="en-US" dirty="0">
+                <a:solidFill>
+                  <a:schemeClr val="tx1"/>
+                </a:solidFill>
+              </a:rPr>
+              <a:t>Announcements</a:t>
+            </a:r>
+          </a:p>
+          <a:p>
+            <a:pPr marL="800100" lvl="1" indent="-342900">
+              <a:buFont typeface="Arial" panose="020B0604020202020204" pitchFamily="34" charset="0"/>
+              <a:buChar char="•"/>
+            </a:pPr>
+            <a:r>
+              <a:rPr lang="en-US" dirty="0">
+                <a:solidFill>
+                  <a:schemeClr val="tx1"/>
+                </a:solidFill>
+              </a:rPr>
+              <a:t>Schedule</a:t>
+            </a:r>
+          </a:p>
+          <a:p>
+            <a:pPr marL="800100" lvl="1" indent="-342900">
+              <a:buFont typeface="Arial" panose="020B0604020202020204" pitchFamily="34" charset="0"/>
+              <a:buChar char="•"/>
+            </a:pPr>
+            <a:r>
+              <a:rPr lang="en-US" dirty="0">
+                <a:solidFill>
+                  <a:schemeClr val="tx1"/>
+                </a:solidFill>
+              </a:rPr>
+              <a:t>Leaderboard</a:t>
+            </a:r>
+          </a:p>
+          <a:p>
             <a:pPr marL="342900" indent="-342900">
               <a:buFont typeface="Arial" panose="020B0604020202020204" pitchFamily="34" charset="0"/>
               <a:buChar char="•"/>
@@ -11216,21 +11169,8 @@
                   <a:schemeClr val="tx1"/>
                 </a:solidFill>
               </a:rPr>
-              <a:t>Clubs </a:t>
+              <a:t>Clubs Page Progress</a:t>
             </a:r>
-            <a:r>
-              <a:rPr lang="en-US">
-                <a:solidFill>
-                  <a:schemeClr val="tx1"/>
-                </a:solidFill>
-              </a:rPr>
-              <a:t>Page Progress</a:t>
-            </a:r>
-            <a:endParaRPr lang="en-US" dirty="0">
-              <a:solidFill>
-                <a:schemeClr val="tx1"/>
-              </a:solidFill>
-            </a:endParaRPr>
           </a:p>
           <a:p>
             <a:pPr marL="342900" indent="-342900">
@@ -11579,11 +11519,28 @@
               <a:buFont typeface="+mj-lt"/>
               <a:buAutoNum type="arabicPeriod"/>
             </a:pPr>
-            <a:endParaRPr lang="en-US" sz="2000" dirty="0">
-              <a:solidFill>
-                <a:schemeClr val="tx1"/>
-              </a:solidFill>
-            </a:endParaRPr>
+            <a:r>
+              <a:rPr lang="en-US" sz="2000" dirty="0">
+                <a:solidFill>
+                  <a:schemeClr val="tx1"/>
+                </a:solidFill>
+              </a:rPr>
+              <a:t>Coach is included in the team leaderboard. The leaderboard would mainly focus on athletes so we need to remove the coach</a:t>
+            </a:r>
+          </a:p>
+          <a:p>
+            <a:pPr marL="342900" indent="-342900">
+              <a:buFont typeface="+mj-lt"/>
+              <a:buAutoNum type="arabicPeriod"/>
+            </a:pPr>
+            <a:r>
+              <a:rPr lang="en-US" sz="2000" dirty="0">
+                <a:solidFill>
+                  <a:schemeClr val="tx1"/>
+                </a:solidFill>
+              </a:rPr>
+              <a:t>Teams page invites members via username. Coaches have access to all athlete emails so this would be more efficient</a:t>
+            </a:r>
           </a:p>
         </p:txBody>
       </p:sp>
@@ -12574,6 +12531,34 @@
               <a:t>We made a backend check to stop this from happening, and disabled the like button for a users own activities on the front end.</a:t>
             </a:r>
           </a:p>
+          <a:p>
+            <a:pPr marL="342900" indent="-342900">
+              <a:buFont typeface="+mj-lt"/>
+              <a:buAutoNum type="arabicPeriod"/>
+            </a:pPr>
+            <a:r>
+              <a:rPr lang="en-US" sz="2000" dirty="0">
+                <a:solidFill>
+                  <a:schemeClr val="tx1"/>
+                </a:solidFill>
+              </a:rPr>
+              <a:t>Not fixed yet, but will be a simple solution as we will just remove members with the role of coach in the team</a:t>
+            </a:r>
+          </a:p>
+          <a:p>
+            <a:pPr marL="342900" indent="-342900">
+              <a:buFont typeface="+mj-lt"/>
+              <a:buAutoNum type="arabicPeriod"/>
+            </a:pPr>
+            <a:r>
+              <a:rPr lang="en-US" sz="2000" dirty="0">
+                <a:solidFill>
+                  <a:schemeClr val="tx1"/>
+                </a:solidFill>
+              </a:rPr>
+              <a:t>Also not fixed, but would simply just be a query for the user’s email instead of the username</a:t>
+            </a:r>
+          </a:p>
         </p:txBody>
       </p:sp>
     </p:spTree>
@@ -12988,6 +12973,678 @@
     </p:bg>
     <p:spTree>
       <p:nvGrpSpPr>
+        <p:cNvPr id="1" name=""/>
+        <p:cNvGrpSpPr/>
+        <p:nvPr/>
+      </p:nvGrpSpPr>
+      <p:grpSpPr>
+        <a:xfrm>
+          <a:off x="0" y="0"/>
+          <a:ext cx="0" cy="0"/>
+          <a:chOff x="0" y="0"/>
+          <a:chExt cx="0" cy="0"/>
+        </a:xfrm>
+      </p:grpSpPr>
+      <p:sp useBgFill="1">
+        <p:nvSpPr>
+          <p:cNvPr id="9" name="Rectangle 8">
+            <a:extLst>
+              <a:ext uri="{FF2B5EF4-FFF2-40B4-BE49-F238E27FC236}">
+                <a16:creationId xmlns:a16="http://schemas.microsoft.com/office/drawing/2014/main" id="{A8384FB5-9ADC-4DDC-881B-597D56F5B15D}"/>
+              </a:ext>
+              <a:ext uri="{C183D7F6-B498-43B3-948B-1728B52AA6E4}">
+                <adec:decorative xmlns:adec="http://schemas.microsoft.com/office/drawing/2017/decorative" val="1"/>
+              </a:ext>
+            </a:extLst>
+          </p:cNvPr>
+          <p:cNvSpPr>
+            <a:spLocks noGrp="1" noRot="1" noChangeAspect="1" noMove="1" noResize="1" noEditPoints="1" noAdjustHandles="1" noChangeArrowheads="1" noChangeShapeType="1" noTextEdit="1"/>
+          </p:cNvSpPr>
+          <p:nvPr>
+            <p:extLst>
+              <p:ext uri="{386F3935-93C4-4BCD-93E2-E3B085C9AB24}">
+                <p16:designElem xmlns:p16="http://schemas.microsoft.com/office/powerpoint/2015/main" val="1"/>
+              </p:ext>
+            </p:extLst>
+          </p:nvPr>
+        </p:nvSpPr>
+        <p:spPr>
+          <a:xfrm>
+            <a:off x="0" y="0"/>
+            <a:ext cx="12192000" cy="6858000"/>
+          </a:xfrm>
+          <a:prstGeom prst="rect">
+            <a:avLst/>
+          </a:prstGeom>
+          <a:ln w="12700" cap="flat" cmpd="sng" algn="ctr">
+            <a:noFill/>
+            <a:prstDash val="solid"/>
+            <a:miter lim="800000"/>
+          </a:ln>
+          <a:effectLst/>
+          <a:extLst>
+            <a:ext uri="{91240B29-F687-4F45-9708-019B960494DF}">
+              <a14:hiddenLine xmlns:a14="http://schemas.microsoft.com/office/drawing/2010/main" w="12700" cap="flat" cmpd="sng" algn="ctr">
+                <a:solidFill>
+                  <a:schemeClr val="accent1">
+                    <a:shade val="50000"/>
+                  </a:schemeClr>
+                </a:solidFill>
+                <a:prstDash val="solid"/>
+                <a:miter lim="800000"/>
+              </a14:hiddenLine>
+            </a:ext>
+          </a:extLst>
+        </p:spPr>
+        <p:style>
+          <a:lnRef idx="2">
+            <a:schemeClr val="accent1">
+              <a:shade val="50000"/>
+            </a:schemeClr>
+          </a:lnRef>
+          <a:fillRef idx="1">
+            <a:schemeClr val="accent1"/>
+          </a:fillRef>
+          <a:effectRef idx="0">
+            <a:schemeClr val="accent1"/>
+          </a:effectRef>
+          <a:fontRef idx="minor">
+            <a:schemeClr val="lt1"/>
+          </a:fontRef>
+        </p:style>
+        <p:txBody>
+          <a:bodyPr rtlCol="0" anchor="ctr"/>
+          <a:lstStyle/>
+          <a:p>
+            <a:pPr marL="0" marR="0" lvl="0" indent="0" algn="ctr" defTabSz="914400" rtl="0" eaLnBrk="1" fontAlgn="auto" latinLnBrk="0" hangingPunct="1">
+              <a:lnSpc>
+                <a:spcPct val="100000"/>
+              </a:lnSpc>
+              <a:spcBef>
+                <a:spcPts val="0"/>
+              </a:spcBef>
+              <a:spcAft>
+                <a:spcPts val="0"/>
+              </a:spcAft>
+              <a:buClrTx/>
+              <a:buSzTx/>
+              <a:buFontTx/>
+              <a:buNone/>
+              <a:tabLst/>
+              <a:defRPr/>
+            </a:pPr>
+            <a:endParaRPr kumimoji="0" lang="en-US" sz="1800" b="0" i="0" u="none" strike="noStrike" kern="1200" cap="none" spc="0" normalizeH="0" baseline="0" noProof="0">
+              <a:ln>
+                <a:noFill/>
+              </a:ln>
+              <a:solidFill>
+                <a:prstClr val="white"/>
+              </a:solidFill>
+              <a:effectLst/>
+              <a:uLnTx/>
+              <a:uFillTx/>
+              <a:latin typeface="Aptos" panose="02110004020202020204"/>
+              <a:ea typeface="+mn-ea"/>
+              <a:cs typeface="+mn-cs"/>
+            </a:endParaRPr>
+          </a:p>
+        </p:txBody>
+      </p:sp>
+      <p:sp>
+        <p:nvSpPr>
+          <p:cNvPr id="11" name="Rectangle 10">
+            <a:extLst>
+              <a:ext uri="{FF2B5EF4-FFF2-40B4-BE49-F238E27FC236}">
+                <a16:creationId xmlns:a16="http://schemas.microsoft.com/office/drawing/2014/main" id="{1199E1B1-A8C0-4FE8-A5A8-1CB41D69F857}"/>
+              </a:ext>
+              <a:ext uri="{C183D7F6-B498-43B3-948B-1728B52AA6E4}">
+                <adec:decorative xmlns:adec="http://schemas.microsoft.com/office/drawing/2017/decorative" val="1"/>
+              </a:ext>
+            </a:extLst>
+          </p:cNvPr>
+          <p:cNvSpPr>
+            <a:spLocks noGrp="1" noRot="1" noChangeAspect="1" noMove="1" noResize="1" noEditPoints="1" noAdjustHandles="1" noChangeArrowheads="1" noChangeShapeType="1" noTextEdit="1"/>
+          </p:cNvSpPr>
+          <p:nvPr>
+            <p:extLst>
+              <p:ext uri="{386F3935-93C4-4BCD-93E2-E3B085C9AB24}">
+                <p16:designElem xmlns:p16="http://schemas.microsoft.com/office/powerpoint/2015/main" val="1"/>
+              </p:ext>
+            </p:extLst>
+          </p:nvPr>
+        </p:nvSpPr>
+        <p:spPr>
+          <a:xfrm rot="10800000" flipH="1">
+            <a:off x="2" y="0"/>
+            <a:ext cx="12191998" cy="1575955"/>
+          </a:xfrm>
+          <a:prstGeom prst="rect">
+            <a:avLst/>
+          </a:prstGeom>
+          <a:gradFill>
+            <a:gsLst>
+              <a:gs pos="0">
+                <a:srgbClr val="000000">
+                  <a:alpha val="96000"/>
+                </a:srgbClr>
+              </a:gs>
+              <a:gs pos="100000">
+                <a:schemeClr val="accent1">
+                  <a:lumMod val="75000"/>
+                </a:schemeClr>
+              </a:gs>
+            </a:gsLst>
+            <a:lin ang="6000000" scaled="0"/>
+          </a:gradFill>
+          <a:ln>
+            <a:noFill/>
+          </a:ln>
+        </p:spPr>
+        <p:style>
+          <a:lnRef idx="2">
+            <a:schemeClr val="accent1">
+              <a:shade val="50000"/>
+            </a:schemeClr>
+          </a:lnRef>
+          <a:fillRef idx="1">
+            <a:schemeClr val="accent1"/>
+          </a:fillRef>
+          <a:effectRef idx="0">
+            <a:schemeClr val="accent1"/>
+          </a:effectRef>
+          <a:fontRef idx="minor">
+            <a:schemeClr val="lt1"/>
+          </a:fontRef>
+        </p:style>
+        <p:txBody>
+          <a:bodyPr rtlCol="0" anchor="ctr"/>
+          <a:lstStyle/>
+          <a:p>
+            <a:pPr marL="0" marR="0" lvl="0" indent="0" algn="ctr" defTabSz="914400" rtl="0" eaLnBrk="1" fontAlgn="auto" latinLnBrk="0" hangingPunct="1">
+              <a:lnSpc>
+                <a:spcPct val="100000"/>
+              </a:lnSpc>
+              <a:spcBef>
+                <a:spcPts val="0"/>
+              </a:spcBef>
+              <a:spcAft>
+                <a:spcPts val="0"/>
+              </a:spcAft>
+              <a:buClrTx/>
+              <a:buSzTx/>
+              <a:buFontTx/>
+              <a:buNone/>
+              <a:tabLst/>
+              <a:defRPr/>
+            </a:pPr>
+            <a:endParaRPr kumimoji="0" lang="en-US" sz="1800" b="0" i="0" u="none" strike="noStrike" kern="1200" cap="none" spc="0" normalizeH="0" baseline="0" noProof="0">
+              <a:ln>
+                <a:noFill/>
+              </a:ln>
+              <a:solidFill>
+                <a:prstClr val="white"/>
+              </a:solidFill>
+              <a:effectLst/>
+              <a:uLnTx/>
+              <a:uFillTx/>
+              <a:latin typeface="Aptos" panose="02110004020202020204"/>
+              <a:ea typeface="+mn-ea"/>
+              <a:cs typeface="+mn-cs"/>
+            </a:endParaRPr>
+          </a:p>
+        </p:txBody>
+      </p:sp>
+      <p:sp>
+        <p:nvSpPr>
+          <p:cNvPr id="13" name="Rectangle 12">
+            <a:extLst>
+              <a:ext uri="{FF2B5EF4-FFF2-40B4-BE49-F238E27FC236}">
+                <a16:creationId xmlns:a16="http://schemas.microsoft.com/office/drawing/2014/main" id="{84A8DE83-DE75-4B41-9DB4-A7EC0B0DEC0B}"/>
+              </a:ext>
+              <a:ext uri="{C183D7F6-B498-43B3-948B-1728B52AA6E4}">
+                <adec:decorative xmlns:adec="http://schemas.microsoft.com/office/drawing/2017/decorative" val="1"/>
+              </a:ext>
+            </a:extLst>
+          </p:cNvPr>
+          <p:cNvSpPr>
+            <a:spLocks noGrp="1" noRot="1" noChangeAspect="1" noMove="1" noResize="1" noEditPoints="1" noAdjustHandles="1" noChangeArrowheads="1" noChangeShapeType="1" noTextEdit="1"/>
+          </p:cNvSpPr>
+          <p:nvPr>
+            <p:extLst>
+              <p:ext uri="{386F3935-93C4-4BCD-93E2-E3B085C9AB24}">
+                <p16:designElem xmlns:p16="http://schemas.microsoft.com/office/powerpoint/2015/main" val="1"/>
+              </p:ext>
+            </p:extLst>
+          </p:nvPr>
+        </p:nvSpPr>
+        <p:spPr>
+          <a:xfrm>
+            <a:off x="0" y="0"/>
+            <a:ext cx="8128856" cy="1575461"/>
+          </a:xfrm>
+          <a:prstGeom prst="rect">
+            <a:avLst/>
+          </a:prstGeom>
+          <a:gradFill>
+            <a:gsLst>
+              <a:gs pos="0">
+                <a:schemeClr val="accent1">
+                  <a:alpha val="41000"/>
+                </a:schemeClr>
+              </a:gs>
+              <a:gs pos="74000">
+                <a:schemeClr val="accent1">
+                  <a:lumMod val="60000"/>
+                  <a:lumOff val="40000"/>
+                  <a:alpha val="0"/>
+                </a:schemeClr>
+              </a:gs>
+            </a:gsLst>
+            <a:lin ang="8400000" scaled="0"/>
+          </a:gradFill>
+          <a:ln>
+            <a:noFill/>
+          </a:ln>
+        </p:spPr>
+        <p:style>
+          <a:lnRef idx="2">
+            <a:schemeClr val="accent1">
+              <a:shade val="50000"/>
+            </a:schemeClr>
+          </a:lnRef>
+          <a:fillRef idx="1">
+            <a:schemeClr val="accent1"/>
+          </a:fillRef>
+          <a:effectRef idx="0">
+            <a:schemeClr val="accent1"/>
+          </a:effectRef>
+          <a:fontRef idx="minor">
+            <a:schemeClr val="lt1"/>
+          </a:fontRef>
+        </p:style>
+        <p:txBody>
+          <a:bodyPr rtlCol="0" anchor="ctr"/>
+          <a:lstStyle/>
+          <a:p>
+            <a:pPr marL="0" marR="0" lvl="0" indent="0" algn="ctr" defTabSz="914400" rtl="0" eaLnBrk="1" fontAlgn="auto" latinLnBrk="0" hangingPunct="1">
+              <a:lnSpc>
+                <a:spcPct val="100000"/>
+              </a:lnSpc>
+              <a:spcBef>
+                <a:spcPts val="0"/>
+              </a:spcBef>
+              <a:spcAft>
+                <a:spcPts val="0"/>
+              </a:spcAft>
+              <a:buClrTx/>
+              <a:buSzTx/>
+              <a:buFontTx/>
+              <a:buNone/>
+              <a:tabLst/>
+              <a:defRPr/>
+            </a:pPr>
+            <a:endParaRPr kumimoji="0" lang="en-US" sz="1800" b="0" i="0" u="none" strike="noStrike" kern="1200" cap="none" spc="0" normalizeH="0" baseline="0" noProof="0">
+              <a:ln>
+                <a:noFill/>
+              </a:ln>
+              <a:solidFill>
+                <a:prstClr val="white"/>
+              </a:solidFill>
+              <a:effectLst/>
+              <a:uLnTx/>
+              <a:uFillTx/>
+              <a:latin typeface="Aptos" panose="02110004020202020204"/>
+              <a:ea typeface="+mn-ea"/>
+              <a:cs typeface="+mn-cs"/>
+            </a:endParaRPr>
+          </a:p>
+        </p:txBody>
+      </p:sp>
+      <p:sp>
+        <p:nvSpPr>
+          <p:cNvPr id="15" name="Rectangle 14">
+            <a:extLst>
+              <a:ext uri="{FF2B5EF4-FFF2-40B4-BE49-F238E27FC236}">
+                <a16:creationId xmlns:a16="http://schemas.microsoft.com/office/drawing/2014/main" id="{A7009A0A-BEF5-4EAC-AF15-E4F9F002E239}"/>
+              </a:ext>
+              <a:ext uri="{C183D7F6-B498-43B3-948B-1728B52AA6E4}">
+                <adec:decorative xmlns:adec="http://schemas.microsoft.com/office/drawing/2017/decorative" val="1"/>
+              </a:ext>
+            </a:extLst>
+          </p:cNvPr>
+          <p:cNvSpPr>
+            <a:spLocks noGrp="1" noRot="1" noChangeAspect="1" noMove="1" noResize="1" noEditPoints="1" noAdjustHandles="1" noChangeArrowheads="1" noChangeShapeType="1" noTextEdit="1"/>
+          </p:cNvSpPr>
+          <p:nvPr>
+            <p:extLst>
+              <p:ext uri="{386F3935-93C4-4BCD-93E2-E3B085C9AB24}">
+                <p16:designElem xmlns:p16="http://schemas.microsoft.com/office/powerpoint/2015/main" val="1"/>
+              </p:ext>
+            </p:extLst>
+          </p:nvPr>
+        </p:nvSpPr>
+        <p:spPr>
+          <a:xfrm flipH="1">
+            <a:off x="-3" y="-1"/>
+            <a:ext cx="12192002" cy="1574311"/>
+          </a:xfrm>
+          <a:prstGeom prst="rect">
+            <a:avLst/>
+          </a:prstGeom>
+          <a:gradFill>
+            <a:gsLst>
+              <a:gs pos="0">
+                <a:srgbClr val="000000">
+                  <a:alpha val="63000"/>
+                </a:srgbClr>
+              </a:gs>
+              <a:gs pos="78000">
+                <a:schemeClr val="accent1">
+                  <a:alpha val="15000"/>
+                </a:schemeClr>
+              </a:gs>
+            </a:gsLst>
+            <a:lin ang="15600000" scaled="0"/>
+          </a:gradFill>
+          <a:ln>
+            <a:noFill/>
+          </a:ln>
+        </p:spPr>
+        <p:style>
+          <a:lnRef idx="2">
+            <a:schemeClr val="accent1">
+              <a:shade val="50000"/>
+            </a:schemeClr>
+          </a:lnRef>
+          <a:fillRef idx="1">
+            <a:schemeClr val="accent1"/>
+          </a:fillRef>
+          <a:effectRef idx="0">
+            <a:schemeClr val="accent1"/>
+          </a:effectRef>
+          <a:fontRef idx="minor">
+            <a:schemeClr val="lt1"/>
+          </a:fontRef>
+        </p:style>
+        <p:txBody>
+          <a:bodyPr rtlCol="0" anchor="ctr"/>
+          <a:lstStyle/>
+          <a:p>
+            <a:pPr marL="0" marR="0" lvl="0" indent="0" algn="ctr" defTabSz="914400" rtl="0" eaLnBrk="1" fontAlgn="auto" latinLnBrk="0" hangingPunct="1">
+              <a:lnSpc>
+                <a:spcPct val="100000"/>
+              </a:lnSpc>
+              <a:spcBef>
+                <a:spcPts val="0"/>
+              </a:spcBef>
+              <a:spcAft>
+                <a:spcPts val="0"/>
+              </a:spcAft>
+              <a:buClrTx/>
+              <a:buSzTx/>
+              <a:buFontTx/>
+              <a:buNone/>
+              <a:tabLst/>
+              <a:defRPr/>
+            </a:pPr>
+            <a:endParaRPr kumimoji="0" lang="en-US" sz="1800" b="0" i="0" u="none" strike="noStrike" kern="1200" cap="none" spc="0" normalizeH="0" baseline="0" noProof="0">
+              <a:ln>
+                <a:noFill/>
+              </a:ln>
+              <a:solidFill>
+                <a:prstClr val="white"/>
+              </a:solidFill>
+              <a:effectLst/>
+              <a:uLnTx/>
+              <a:uFillTx/>
+              <a:latin typeface="Aptos" panose="02110004020202020204"/>
+              <a:ea typeface="+mn-ea"/>
+              <a:cs typeface="+mn-cs"/>
+            </a:endParaRPr>
+          </a:p>
+        </p:txBody>
+      </p:sp>
+      <p:sp>
+        <p:nvSpPr>
+          <p:cNvPr id="2" name="Title 1">
+            <a:extLst>
+              <a:ext uri="{FF2B5EF4-FFF2-40B4-BE49-F238E27FC236}">
+                <a16:creationId xmlns:a16="http://schemas.microsoft.com/office/drawing/2014/main" id="{C074B1A4-0C15-D874-CBCA-1FB85D3E881D}"/>
+              </a:ext>
+            </a:extLst>
+          </p:cNvPr>
+          <p:cNvSpPr>
+            <a:spLocks noGrp="1"/>
+          </p:cNvSpPr>
+          <p:nvPr>
+            <p:ph type="title"/>
+          </p:nvPr>
+        </p:nvSpPr>
+        <p:spPr>
+          <a:xfrm>
+            <a:off x="4272534" y="84536"/>
+            <a:ext cx="3278835" cy="1159200"/>
+          </a:xfrm>
+        </p:spPr>
+        <p:txBody>
+          <a:bodyPr vert="horz" lIns="91440" tIns="45720" rIns="91440" bIns="45720" rtlCol="0" anchor="ctr">
+            <a:normAutofit/>
+          </a:bodyPr>
+          <a:lstStyle/>
+          <a:p>
+            <a:r>
+              <a:rPr lang="en-US" sz="4000" kern="1200" dirty="0">
+                <a:solidFill>
+                  <a:srgbClr val="FFFFFF"/>
+                </a:solidFill>
+                <a:latin typeface="+mj-lt"/>
+                <a:ea typeface="+mj-ea"/>
+                <a:cs typeface="+mj-cs"/>
+              </a:rPr>
+              <a:t>Teams Page</a:t>
+            </a:r>
+          </a:p>
+        </p:txBody>
+      </p:sp>
+      <p:pic>
+        <p:nvPicPr>
+          <p:cNvPr id="3" name="Inbox">
+            <a:hlinkClick r:id="" action="ppaction://media"/>
+            <a:extLst>
+              <a:ext uri="{FF2B5EF4-FFF2-40B4-BE49-F238E27FC236}">
+                <a16:creationId xmlns:a16="http://schemas.microsoft.com/office/drawing/2014/main" id="{E59A6658-36B8-AE97-C67F-8DC16AF87712}"/>
+              </a:ext>
+            </a:extLst>
+          </p:cNvPr>
+          <p:cNvPicPr>
+            <a:picLocks noChangeAspect="1"/>
+          </p:cNvPicPr>
+          <p:nvPr>
+            <a:videoFile r:link="rId2"/>
+            <p:extLst>
+              <p:ext uri="{DAA4B4D4-6D71-4841-9C94-3DE7FCFB9230}">
+                <p14:media xmlns:p14="http://schemas.microsoft.com/office/powerpoint/2010/main" r:embed="rId1"/>
+              </p:ext>
+            </p:extLst>
+          </p:nvPr>
+        </p:nvPicPr>
+        <p:blipFill>
+          <a:blip r:embed="rId4"/>
+          <a:stretch>
+            <a:fillRect/>
+          </a:stretch>
+        </p:blipFill>
+        <p:spPr>
+          <a:xfrm>
+            <a:off x="0" y="1556741"/>
+            <a:ext cx="12191995" cy="5325775"/>
+          </a:xfrm>
+          <a:prstGeom prst="rect">
+            <a:avLst/>
+          </a:prstGeom>
+        </p:spPr>
+      </p:pic>
+    </p:spTree>
+    <p:extLst>
+      <p:ext uri="{BB962C8B-B14F-4D97-AF65-F5344CB8AC3E}">
+        <p14:creationId xmlns:p14="http://schemas.microsoft.com/office/powerpoint/2010/main" val="2282075488"/>
+      </p:ext>
+    </p:extLst>
+  </p:cSld>
+  <p:clrMapOvr>
+    <a:masterClrMapping/>
+  </p:clrMapOvr>
+  <p:timing>
+    <p:tnLst>
+      <p:par>
+        <p:cTn id="1" dur="indefinite" restart="never" nodeType="tmRoot">
+          <p:childTnLst>
+            <p:seq concurrent="1" nextAc="seek">
+              <p:cTn id="2" dur="indefinite" nodeType="mainSeq">
+                <p:childTnLst>
+                  <p:par>
+                    <p:cTn id="3" fill="hold">
+                      <p:stCondLst>
+                        <p:cond delay="indefinite"/>
+                      </p:stCondLst>
+                      <p:childTnLst>
+                        <p:par>
+                          <p:cTn id="4" fill="hold">
+                            <p:stCondLst>
+                              <p:cond delay="0"/>
+                            </p:stCondLst>
+                            <p:childTnLst>
+                              <p:par>
+                                <p:cTn id="5" presetID="1" presetClass="mediacall" presetSubtype="0" fill="hold" nodeType="clickEffect">
+                                  <p:stCondLst>
+                                    <p:cond delay="0"/>
+                                  </p:stCondLst>
+                                  <p:childTnLst>
+                                    <p:cmd type="call" cmd="playFrom(0.0)">
+                                      <p:cBhvr>
+                                        <p:cTn id="6" dur="119840" fill="hold"/>
+                                        <p:tgtEl>
+                                          <p:spTgt spid="3"/>
+                                        </p:tgtEl>
+                                      </p:cBhvr>
+                                    </p:cmd>
+                                  </p:childTnLst>
+                                </p:cTn>
+                              </p:par>
+                            </p:childTnLst>
+                          </p:cTn>
+                        </p:par>
+                      </p:childTnLst>
+                    </p:cTn>
+                  </p:par>
+                </p:childTnLst>
+              </p:cTn>
+              <p:prevCondLst>
+                <p:cond evt="onPrev" delay="0">
+                  <p:tgtEl>
+                    <p:sldTgt/>
+                  </p:tgtEl>
+                </p:cond>
+              </p:prevCondLst>
+              <p:nextCondLst>
+                <p:cond evt="onNext" delay="0">
+                  <p:tgtEl>
+                    <p:sldTgt/>
+                  </p:tgtEl>
+                </p:cond>
+              </p:nextCondLst>
+            </p:seq>
+            <p:video>
+              <p:cMediaNode vol="80000">
+                <p:cTn id="7" fill="hold" display="0">
+                  <p:stCondLst>
+                    <p:cond delay="indefinite"/>
+                  </p:stCondLst>
+                </p:cTn>
+                <p:tgtEl>
+                  <p:spTgt spid="3"/>
+                </p:tgtEl>
+              </p:cMediaNode>
+            </p:video>
+            <p:seq concurrent="1" nextAc="seek">
+              <p:cTn id="8" restart="whenNotActive" fill="hold" evtFilter="cancelBubble" nodeType="interactiveSeq">
+                <p:stCondLst>
+                  <p:cond evt="onClick" delay="0">
+                    <p:tgtEl>
+                      <p:spTgt spid="3"/>
+                    </p:tgtEl>
+                  </p:cond>
+                </p:stCondLst>
+                <p:endSync evt="end" delay="0">
+                  <p:rtn val="all"/>
+                </p:endSync>
+                <p:childTnLst>
+                  <p:par>
+                    <p:cTn id="9" fill="hold">
+                      <p:stCondLst>
+                        <p:cond delay="0"/>
+                      </p:stCondLst>
+                      <p:childTnLst>
+                        <p:par>
+                          <p:cTn id="10" fill="hold">
+                            <p:stCondLst>
+                              <p:cond delay="0"/>
+                            </p:stCondLst>
+                            <p:childTnLst>
+                              <p:par>
+                                <p:cTn id="11" presetID="2" presetClass="mediacall" presetSubtype="0" fill="hold" nodeType="clickEffect">
+                                  <p:stCondLst>
+                                    <p:cond delay="0"/>
+                                  </p:stCondLst>
+                                  <p:childTnLst>
+                                    <p:cmd type="call" cmd="togglePause">
+                                      <p:cBhvr>
+                                        <p:cTn id="12" dur="1" fill="hold"/>
+                                        <p:tgtEl>
+                                          <p:spTgt spid="3"/>
+                                        </p:tgtEl>
+                                      </p:cBhvr>
+                                    </p:cmd>
+                                  </p:childTnLst>
+                                </p:cTn>
+                              </p:par>
+                            </p:childTnLst>
+                          </p:cTn>
+                        </p:par>
+                      </p:childTnLst>
+                    </p:cTn>
+                  </p:par>
+                </p:childTnLst>
+              </p:cTn>
+              <p:nextCondLst>
+                <p:cond evt="onClick" delay="0">
+                  <p:tgtEl>
+                    <p:spTgt spid="3"/>
+                  </p:tgtEl>
+                </p:cond>
+              </p:nextCondLst>
+            </p:seq>
+          </p:childTnLst>
+        </p:cTn>
+      </p:par>
+    </p:tnLst>
+  </p:timing>
+</p:sld>
+</file>
+
+<file path=ppt/slides/slide7.xml><?xml version="1.0" encoding="utf-8"?>
+<p:sld xmlns:a="http://schemas.openxmlformats.org/drawingml/2006/main" xmlns:r="http://schemas.openxmlformats.org/officeDocument/2006/relationships" xmlns:p="http://schemas.openxmlformats.org/presentationml/2006/main">
+  <p:cSld>
+    <p:bg>
+      <p:bgPr>
+        <a:solidFill>
+          <a:schemeClr val="bg1"/>
+        </a:solidFill>
+        <a:effectLst/>
+      </p:bgPr>
+    </p:bg>
+    <p:spTree>
+      <p:nvGrpSpPr>
         <p:cNvPr id="1" name="">
           <a:extLst>
             <a:ext uri="{FF2B5EF4-FFF2-40B4-BE49-F238E27FC236}">
@@ -13327,7 +13984,7 @@
 </p:sld>
 </file>
 
-<file path=ppt/slides/slide7.xml><?xml version="1.0" encoding="utf-8"?>
+<file path=ppt/slides/slide8.xml><?xml version="1.0" encoding="utf-8"?>
 <p:sld xmlns:a="http://schemas.openxmlformats.org/drawingml/2006/main" xmlns:r="http://schemas.openxmlformats.org/officeDocument/2006/relationships" xmlns:p="http://schemas.openxmlformats.org/presentationml/2006/main">
   <p:cSld>
     <p:bg>
@@ -13715,7 +14372,7 @@
 </p:sld>
 </file>
 
-<file path=ppt/slides/slide8.xml><?xml version="1.0" encoding="utf-8"?>
+<file path=ppt/slides/slide9.xml><?xml version="1.0" encoding="utf-8"?>
 <p:sld xmlns:a="http://schemas.openxmlformats.org/drawingml/2006/main" xmlns:r="http://schemas.openxmlformats.org/officeDocument/2006/relationships" xmlns:p="http://schemas.openxmlformats.org/presentationml/2006/main">
   <p:cSld>
     <p:bg>

</xml_diff>

<commit_message>
add to report, slides, user manual
</commit_message>
<xml_diff>
--- a/Documentation/Weekly Report/week12/CMSC-4920-Week12-Group2.pptx
+++ b/Documentation/Weekly Report/week12/CMSC-4920-Week12-Group2.pptx
@@ -5,18 +5,20 @@
     <p:sldMasterId id="2147483648" r:id="rId1"/>
   </p:sldMasterIdLst>
   <p:notesMasterIdLst>
-    <p:notesMasterId r:id="rId11"/>
+    <p:notesMasterId r:id="rId13"/>
   </p:notesMasterIdLst>
   <p:sldIdLst>
     <p:sldId id="256" r:id="rId2"/>
     <p:sldId id="257" r:id="rId3"/>
     <p:sldId id="265" r:id="rId4"/>
     <p:sldId id="266" r:id="rId5"/>
-    <p:sldId id="258" r:id="rId6"/>
-    <p:sldId id="272" r:id="rId7"/>
-    <p:sldId id="264" r:id="rId8"/>
-    <p:sldId id="259" r:id="rId9"/>
-    <p:sldId id="260" r:id="rId10"/>
+    <p:sldId id="273" r:id="rId6"/>
+    <p:sldId id="258" r:id="rId7"/>
+    <p:sldId id="272" r:id="rId8"/>
+    <p:sldId id="274" r:id="rId9"/>
+    <p:sldId id="264" r:id="rId10"/>
+    <p:sldId id="259" r:id="rId11"/>
+    <p:sldId id="260" r:id="rId12"/>
   </p:sldIdLst>
   <p:sldSz cx="12192000" cy="6858000"/>
   <p:notesSz cx="6858000" cy="9144000"/>
@@ -126,6 +128,7 @@
 <file path=ppt/revisionInfo.xml><?xml version="1.0" encoding="utf-8"?>
 <p1510:revInfo xmlns:a="http://schemas.openxmlformats.org/drawingml/2006/main" xmlns:r="http://schemas.openxmlformats.org/officeDocument/2006/relationships" xmlns:p1510="http://schemas.microsoft.com/office/powerpoint/2015/10/main">
   <p1510:revLst>
+    <p1510:client id="{AA469995-2C85-4A2B-B8F3-46D2FC896B39}" v="1" dt="2026-04-05T12:44:26.228"/>
     <p1510:client id="{C9738FE7-D6DF-4424-AB5E-DBD3476A8FE7}" v="3" dt="2026-04-04T21:42:41.900"/>
   </p1510:revLst>
 </p1510:revInfo>
@@ -259,7 +262,7 @@
   <pc:docChgLst>
     <pc:chgData name="Margo Bonal" userId="18c9fa0f-b53d-478b-9dc0-6ad88786c19f" providerId="ADAL" clId="{93D479E5-F67F-4B8A-A78F-A0B574A116B6}"/>
     <pc:docChg chg="undo custSel addSld delSld modSld">
-      <pc:chgData name="Margo Bonal" userId="18c9fa0f-b53d-478b-9dc0-6ad88786c19f" providerId="ADAL" clId="{93D479E5-F67F-4B8A-A78F-A0B574A116B6}" dt="2026-03-30T01:10:14.587" v="969" actId="14100"/>
+      <pc:chgData name="Margo Bonal" userId="18c9fa0f-b53d-478b-9dc0-6ad88786c19f" providerId="ADAL" clId="{93D479E5-F67F-4B8A-A78F-A0B574A116B6}" dt="2026-04-05T12:47:40.738" v="1057" actId="26606"/>
       <pc:docMkLst>
         <pc:docMk/>
       </pc:docMkLst>
@@ -321,6 +324,188 @@
             <pc:docMk/>
             <pc:sldMk cId="3526335932" sldId="266"/>
             <ac:spMk id="4" creationId="{86ED9EE4-56A8-6AFD-BE9A-A35D2ABC59A0}"/>
+          </ac:spMkLst>
+        </pc:spChg>
+      </pc:sldChg>
+      <pc:sldChg chg="addSp modSp new mod setBg">
+        <pc:chgData name="Margo Bonal" userId="18c9fa0f-b53d-478b-9dc0-6ad88786c19f" providerId="ADAL" clId="{93D479E5-F67F-4B8A-A78F-A0B574A116B6}" dt="2026-04-05T12:47:09.188" v="1035" actId="20577"/>
+        <pc:sldMkLst>
+          <pc:docMk/>
+          <pc:sldMk cId="4265846240" sldId="273"/>
+        </pc:sldMkLst>
+        <pc:spChg chg="mod">
+          <ac:chgData name="Margo Bonal" userId="18c9fa0f-b53d-478b-9dc0-6ad88786c19f" providerId="ADAL" clId="{93D479E5-F67F-4B8A-A78F-A0B574A116B6}" dt="2026-04-05T12:46:30.580" v="1021" actId="1076"/>
+          <ac:spMkLst>
+            <pc:docMk/>
+            <pc:sldMk cId="4265846240" sldId="273"/>
+            <ac:spMk id="2" creationId="{DF831928-2BB9-C45B-9B78-9B9C5E78C657}"/>
+          </ac:spMkLst>
+        </pc:spChg>
+        <pc:spChg chg="mod">
+          <ac:chgData name="Margo Bonal" userId="18c9fa0f-b53d-478b-9dc0-6ad88786c19f" providerId="ADAL" clId="{93D479E5-F67F-4B8A-A78F-A0B574A116B6}" dt="2026-04-05T12:47:09.188" v="1035" actId="20577"/>
+          <ac:spMkLst>
+            <pc:docMk/>
+            <pc:sldMk cId="4265846240" sldId="273"/>
+            <ac:spMk id="3" creationId="{A2C8BFE2-FC98-104F-F2E2-CE52A9F6721A}"/>
+          </ac:spMkLst>
+        </pc:spChg>
+        <pc:spChg chg="add">
+          <ac:chgData name="Margo Bonal" userId="18c9fa0f-b53d-478b-9dc0-6ad88786c19f" providerId="ADAL" clId="{93D479E5-F67F-4B8A-A78F-A0B574A116B6}" dt="2026-04-05T12:46:25.011" v="1017" actId="26606"/>
+          <ac:spMkLst>
+            <pc:docMk/>
+            <pc:sldMk cId="4265846240" sldId="273"/>
+            <ac:spMk id="8" creationId="{46F1F2C8-798B-4CCE-A851-94AFAF350BED}"/>
+          </ac:spMkLst>
+        </pc:spChg>
+        <pc:spChg chg="add">
+          <ac:chgData name="Margo Bonal" userId="18c9fa0f-b53d-478b-9dc0-6ad88786c19f" providerId="ADAL" clId="{93D479E5-F67F-4B8A-A78F-A0B574A116B6}" dt="2026-04-05T12:46:25.011" v="1017" actId="26606"/>
+          <ac:spMkLst>
+            <pc:docMk/>
+            <pc:sldMk cId="4265846240" sldId="273"/>
+            <ac:spMk id="10" creationId="{755E9CD0-04B0-4A3C-B291-AD913379C713}"/>
+          </ac:spMkLst>
+        </pc:spChg>
+        <pc:spChg chg="add">
+          <ac:chgData name="Margo Bonal" userId="18c9fa0f-b53d-478b-9dc0-6ad88786c19f" providerId="ADAL" clId="{93D479E5-F67F-4B8A-A78F-A0B574A116B6}" dt="2026-04-05T12:46:25.011" v="1017" actId="26606"/>
+          <ac:spMkLst>
+            <pc:docMk/>
+            <pc:sldMk cId="4265846240" sldId="273"/>
+            <ac:spMk id="12" creationId="{1DD8BF3B-6066-418C-8D1A-75C5E396FC04}"/>
+          </ac:spMkLst>
+        </pc:spChg>
+        <pc:spChg chg="add">
+          <ac:chgData name="Margo Bonal" userId="18c9fa0f-b53d-478b-9dc0-6ad88786c19f" providerId="ADAL" clId="{93D479E5-F67F-4B8A-A78F-A0B574A116B6}" dt="2026-04-05T12:46:25.011" v="1017" actId="26606"/>
+          <ac:spMkLst>
+            <pc:docMk/>
+            <pc:sldMk cId="4265846240" sldId="273"/>
+            <ac:spMk id="14" creationId="{80BC66F9-7A74-4286-AD22-1174052CC22C}"/>
+          </ac:spMkLst>
+        </pc:spChg>
+        <pc:spChg chg="add">
+          <ac:chgData name="Margo Bonal" userId="18c9fa0f-b53d-478b-9dc0-6ad88786c19f" providerId="ADAL" clId="{93D479E5-F67F-4B8A-A78F-A0B574A116B6}" dt="2026-04-05T12:46:25.011" v="1017" actId="26606"/>
+          <ac:spMkLst>
+            <pc:docMk/>
+            <pc:sldMk cId="4265846240" sldId="273"/>
+            <ac:spMk id="16" creationId="{D8142CC3-2B5C-48E6-9DF0-6C8ACBAF23EF}"/>
+          </ac:spMkLst>
+        </pc:spChg>
+        <pc:spChg chg="add">
+          <ac:chgData name="Margo Bonal" userId="18c9fa0f-b53d-478b-9dc0-6ad88786c19f" providerId="ADAL" clId="{93D479E5-F67F-4B8A-A78F-A0B574A116B6}" dt="2026-04-05T12:46:25.011" v="1017" actId="26606"/>
+          <ac:spMkLst>
+            <pc:docMk/>
+            <pc:sldMk cId="4265846240" sldId="273"/>
+            <ac:spMk id="20" creationId="{46A89C79-8EF3-4AF9-B3D9-59A883F41C83}"/>
+          </ac:spMkLst>
+        </pc:spChg>
+        <pc:spChg chg="add">
+          <ac:chgData name="Margo Bonal" userId="18c9fa0f-b53d-478b-9dc0-6ad88786c19f" providerId="ADAL" clId="{93D479E5-F67F-4B8A-A78F-A0B574A116B6}" dt="2026-04-05T12:46:25.011" v="1017" actId="26606"/>
+          <ac:spMkLst>
+            <pc:docMk/>
+            <pc:sldMk cId="4265846240" sldId="273"/>
+            <ac:spMk id="22" creationId="{EFE5CE34-4543-42E5-B82C-1F3D12422CDD}"/>
+          </ac:spMkLst>
+        </pc:spChg>
+        <pc:spChg chg="add">
+          <ac:chgData name="Margo Bonal" userId="18c9fa0f-b53d-478b-9dc0-6ad88786c19f" providerId="ADAL" clId="{93D479E5-F67F-4B8A-A78F-A0B574A116B6}" dt="2026-04-05T12:46:25.011" v="1017" actId="26606"/>
+          <ac:spMkLst>
+            <pc:docMk/>
+            <pc:sldMk cId="4265846240" sldId="273"/>
+            <ac:spMk id="24" creationId="{72AF41FE-63D7-4695-81D2-66D2510E4486}"/>
+          </ac:spMkLst>
+        </pc:spChg>
+      </pc:sldChg>
+      <pc:sldChg chg="addSp delSp modSp new mod setBg">
+        <pc:chgData name="Margo Bonal" userId="18c9fa0f-b53d-478b-9dc0-6ad88786c19f" providerId="ADAL" clId="{93D479E5-F67F-4B8A-A78F-A0B574A116B6}" dt="2026-04-05T12:47:40.738" v="1057" actId="26606"/>
+        <pc:sldMkLst>
+          <pc:docMk/>
+          <pc:sldMk cId="1221735276" sldId="274"/>
+        </pc:sldMkLst>
+        <pc:spChg chg="mod">
+          <ac:chgData name="Margo Bonal" userId="18c9fa0f-b53d-478b-9dc0-6ad88786c19f" providerId="ADAL" clId="{93D479E5-F67F-4B8A-A78F-A0B574A116B6}" dt="2026-04-05T12:47:40.738" v="1057" actId="26606"/>
+          <ac:spMkLst>
+            <pc:docMk/>
+            <pc:sldMk cId="1221735276" sldId="274"/>
+            <ac:spMk id="2" creationId="{093A71C4-DFA5-A2AF-DF66-B2209A4E3DCD}"/>
+          </ac:spMkLst>
+        </pc:spChg>
+        <pc:spChg chg="del">
+          <ac:chgData name="Margo Bonal" userId="18c9fa0f-b53d-478b-9dc0-6ad88786c19f" providerId="ADAL" clId="{93D479E5-F67F-4B8A-A78F-A0B574A116B6}" dt="2026-04-05T12:47:31.645" v="1054" actId="478"/>
+          <ac:spMkLst>
+            <pc:docMk/>
+            <pc:sldMk cId="1221735276" sldId="274"/>
+            <ac:spMk id="3" creationId="{DA278A54-5E95-6089-F3D9-1FFDB3D98524}"/>
+          </ac:spMkLst>
+        </pc:spChg>
+        <pc:spChg chg="add del">
+          <ac:chgData name="Margo Bonal" userId="18c9fa0f-b53d-478b-9dc0-6ad88786c19f" providerId="ADAL" clId="{93D479E5-F67F-4B8A-A78F-A0B574A116B6}" dt="2026-04-05T12:47:40.714" v="1056" actId="26606"/>
+          <ac:spMkLst>
+            <pc:docMk/>
+            <pc:sldMk cId="1221735276" sldId="274"/>
+            <ac:spMk id="7" creationId="{289ED1AA-8684-4D37-B208-8777E1A7780D}"/>
+          </ac:spMkLst>
+        </pc:spChg>
+        <pc:spChg chg="add del">
+          <ac:chgData name="Margo Bonal" userId="18c9fa0f-b53d-478b-9dc0-6ad88786c19f" providerId="ADAL" clId="{93D479E5-F67F-4B8A-A78F-A0B574A116B6}" dt="2026-04-05T12:47:40.714" v="1056" actId="26606"/>
+          <ac:spMkLst>
+            <pc:docMk/>
+            <pc:sldMk cId="1221735276" sldId="274"/>
+            <ac:spMk id="9" creationId="{4180E01B-B1F4-437C-807D-1C930718EE64}"/>
+          </ac:spMkLst>
+        </pc:spChg>
+        <pc:spChg chg="add del">
+          <ac:chgData name="Margo Bonal" userId="18c9fa0f-b53d-478b-9dc0-6ad88786c19f" providerId="ADAL" clId="{93D479E5-F67F-4B8A-A78F-A0B574A116B6}" dt="2026-04-05T12:47:40.714" v="1056" actId="26606"/>
+          <ac:spMkLst>
+            <pc:docMk/>
+            <pc:sldMk cId="1221735276" sldId="274"/>
+            <ac:spMk id="11" creationId="{41F77738-2AF0-4750-A0C7-F97C2C17590E}"/>
+          </ac:spMkLst>
+        </pc:spChg>
+        <pc:spChg chg="add">
+          <ac:chgData name="Margo Bonal" userId="18c9fa0f-b53d-478b-9dc0-6ad88786c19f" providerId="ADAL" clId="{93D479E5-F67F-4B8A-A78F-A0B574A116B6}" dt="2026-04-05T12:47:40.738" v="1057" actId="26606"/>
+          <ac:spMkLst>
+            <pc:docMk/>
+            <pc:sldMk cId="1221735276" sldId="274"/>
+            <ac:spMk id="13" creationId="{48E405C9-94BE-41DA-928C-DEC9A8550E9F}"/>
+          </ac:spMkLst>
+        </pc:spChg>
+        <pc:spChg chg="add">
+          <ac:chgData name="Margo Bonal" userId="18c9fa0f-b53d-478b-9dc0-6ad88786c19f" providerId="ADAL" clId="{93D479E5-F67F-4B8A-A78F-A0B574A116B6}" dt="2026-04-05T12:47:40.738" v="1057" actId="26606"/>
+          <ac:spMkLst>
+            <pc:docMk/>
+            <pc:sldMk cId="1221735276" sldId="274"/>
+            <ac:spMk id="14" creationId="{D278ADA9-6383-4BDD-80D2-8899A402687B}"/>
+          </ac:spMkLst>
+        </pc:spChg>
+        <pc:spChg chg="add">
+          <ac:chgData name="Margo Bonal" userId="18c9fa0f-b53d-478b-9dc0-6ad88786c19f" providerId="ADAL" clId="{93D479E5-F67F-4B8A-A78F-A0B574A116B6}" dt="2026-04-05T12:47:40.738" v="1057" actId="26606"/>
+          <ac:spMkLst>
+            <pc:docMk/>
+            <pc:sldMk cId="1221735276" sldId="274"/>
+            <ac:spMk id="15" creationId="{D2091A72-D5BB-42AC-8FD3-F7747D90861E}"/>
+          </ac:spMkLst>
+        </pc:spChg>
+        <pc:spChg chg="add">
+          <ac:chgData name="Margo Bonal" userId="18c9fa0f-b53d-478b-9dc0-6ad88786c19f" providerId="ADAL" clId="{93D479E5-F67F-4B8A-A78F-A0B574A116B6}" dt="2026-04-05T12:47:40.738" v="1057" actId="26606"/>
+          <ac:spMkLst>
+            <pc:docMk/>
+            <pc:sldMk cId="1221735276" sldId="274"/>
+            <ac:spMk id="16" creationId="{484B7147-B0F6-40ED-B5A2-FF72BC8198B6}"/>
+          </ac:spMkLst>
+        </pc:spChg>
+        <pc:spChg chg="add">
+          <ac:chgData name="Margo Bonal" userId="18c9fa0f-b53d-478b-9dc0-6ad88786c19f" providerId="ADAL" clId="{93D479E5-F67F-4B8A-A78F-A0B574A116B6}" dt="2026-04-05T12:47:40.738" v="1057" actId="26606"/>
+          <ac:spMkLst>
+            <pc:docMk/>
+            <pc:sldMk cId="1221735276" sldId="274"/>
+            <ac:spMk id="17" creationId="{6ED12BFC-A737-46AF-8411-481112D54B0C}"/>
+          </ac:spMkLst>
+        </pc:spChg>
+        <pc:spChg chg="add">
+          <ac:chgData name="Margo Bonal" userId="18c9fa0f-b53d-478b-9dc0-6ad88786c19f" providerId="ADAL" clId="{93D479E5-F67F-4B8A-A78F-A0B574A116B6}" dt="2026-04-05T12:47:40.738" v="1057" actId="26606"/>
+          <ac:spMkLst>
+            <pc:docMk/>
+            <pc:sldMk cId="1221735276" sldId="274"/>
+            <ac:spMk id="18" creationId="{B36D2DE0-0628-4A9A-A59D-7BA8B5EB3022}"/>
           </ac:spMkLst>
         </pc:spChg>
       </pc:sldChg>
@@ -6292,7 +6477,7 @@
           <a:p>
             <a:fld id="{B1F2A6E6-BB86-4722-837C-048EA2408876}" type="datetimeFigureOut">
               <a:rPr lang="en-US" smtClean="0"/>
-              <a:t>4/4/2026</a:t>
+              <a:t>4/5/2026</a:t>
             </a:fld>
             <a:endParaRPr lang="en-US"/>
           </a:p>
@@ -6706,7 +6891,7 @@
           <a:p>
             <a:fld id="{C882E6FB-EB88-4936-BED9-9E37159958CA}" type="datetimeFigureOut">
               <a:rPr lang="en-US" smtClean="0"/>
-              <a:t>4/4/2026</a:t>
+              <a:t>4/5/2026</a:t>
             </a:fld>
             <a:endParaRPr lang="en-US"/>
           </a:p>
@@ -6904,7 +7089,7 @@
           <a:p>
             <a:fld id="{C882E6FB-EB88-4936-BED9-9E37159958CA}" type="datetimeFigureOut">
               <a:rPr lang="en-US" smtClean="0"/>
-              <a:t>4/4/2026</a:t>
+              <a:t>4/5/2026</a:t>
             </a:fld>
             <a:endParaRPr lang="en-US"/>
           </a:p>
@@ -7112,7 +7297,7 @@
           <a:p>
             <a:fld id="{C882E6FB-EB88-4936-BED9-9E37159958CA}" type="datetimeFigureOut">
               <a:rPr lang="en-US" smtClean="0"/>
-              <a:t>4/4/2026</a:t>
+              <a:t>4/5/2026</a:t>
             </a:fld>
             <a:endParaRPr lang="en-US"/>
           </a:p>
@@ -7310,7 +7495,7 @@
           <a:p>
             <a:fld id="{C882E6FB-EB88-4936-BED9-9E37159958CA}" type="datetimeFigureOut">
               <a:rPr lang="en-US" smtClean="0"/>
-              <a:t>4/4/2026</a:t>
+              <a:t>4/5/2026</a:t>
             </a:fld>
             <a:endParaRPr lang="en-US"/>
           </a:p>
@@ -7585,7 +7770,7 @@
           <a:p>
             <a:fld id="{C882E6FB-EB88-4936-BED9-9E37159958CA}" type="datetimeFigureOut">
               <a:rPr lang="en-US" smtClean="0"/>
-              <a:t>4/4/2026</a:t>
+              <a:t>4/5/2026</a:t>
             </a:fld>
             <a:endParaRPr lang="en-US"/>
           </a:p>
@@ -7850,7 +8035,7 @@
           <a:p>
             <a:fld id="{C882E6FB-EB88-4936-BED9-9E37159958CA}" type="datetimeFigureOut">
               <a:rPr lang="en-US" smtClean="0"/>
-              <a:t>4/4/2026</a:t>
+              <a:t>4/5/2026</a:t>
             </a:fld>
             <a:endParaRPr lang="en-US"/>
           </a:p>
@@ -8262,7 +8447,7 @@
           <a:p>
             <a:fld id="{C882E6FB-EB88-4936-BED9-9E37159958CA}" type="datetimeFigureOut">
               <a:rPr lang="en-US" smtClean="0"/>
-              <a:t>4/4/2026</a:t>
+              <a:t>4/5/2026</a:t>
             </a:fld>
             <a:endParaRPr lang="en-US"/>
           </a:p>
@@ -8403,7 +8588,7 @@
           <a:p>
             <a:fld id="{C882E6FB-EB88-4936-BED9-9E37159958CA}" type="datetimeFigureOut">
               <a:rPr lang="en-US" smtClean="0"/>
-              <a:t>4/4/2026</a:t>
+              <a:t>4/5/2026</a:t>
             </a:fld>
             <a:endParaRPr lang="en-US"/>
           </a:p>
@@ -8516,7 +8701,7 @@
           <a:p>
             <a:fld id="{C882E6FB-EB88-4936-BED9-9E37159958CA}" type="datetimeFigureOut">
               <a:rPr lang="en-US" smtClean="0"/>
-              <a:t>4/4/2026</a:t>
+              <a:t>4/5/2026</a:t>
             </a:fld>
             <a:endParaRPr lang="en-US"/>
           </a:p>
@@ -8827,7 +9012,7 @@
           <a:p>
             <a:fld id="{C882E6FB-EB88-4936-BED9-9E37159958CA}" type="datetimeFigureOut">
               <a:rPr lang="en-US" smtClean="0"/>
-              <a:t>4/4/2026</a:t>
+              <a:t>4/5/2026</a:t>
             </a:fld>
             <a:endParaRPr lang="en-US"/>
           </a:p>
@@ -9115,7 +9300,7 @@
           <a:p>
             <a:fld id="{C882E6FB-EB88-4936-BED9-9E37159958CA}" type="datetimeFigureOut">
               <a:rPr lang="en-US" smtClean="0"/>
-              <a:t>4/4/2026</a:t>
+              <a:t>4/5/2026</a:t>
             </a:fld>
             <a:endParaRPr lang="en-US"/>
           </a:p>
@@ -9356,7 +9541,7 @@
           <a:p>
             <a:fld id="{C882E6FB-EB88-4936-BED9-9E37159958CA}" type="datetimeFigureOut">
               <a:rPr lang="en-US" smtClean="0"/>
-              <a:t>4/4/2026</a:t>
+              <a:t>4/5/2026</a:t>
             </a:fld>
             <a:endParaRPr lang="en-US"/>
           </a:p>
@@ -10069,6 +10254,746 @@
 </p:sld>
 </file>
 
+<file path=ppt/slides/slide10.xml><?xml version="1.0" encoding="utf-8"?>
+<p:sld xmlns:a="http://schemas.openxmlformats.org/drawingml/2006/main" xmlns:r="http://schemas.openxmlformats.org/officeDocument/2006/relationships" xmlns:p="http://schemas.openxmlformats.org/presentationml/2006/main">
+  <p:cSld>
+    <p:bg>
+      <p:bgPr>
+        <a:solidFill>
+          <a:schemeClr val="bg1"/>
+        </a:solidFill>
+        <a:effectLst/>
+      </p:bgPr>
+    </p:bg>
+    <p:spTree>
+      <p:nvGrpSpPr>
+        <p:cNvPr id="1" name=""/>
+        <p:cNvGrpSpPr/>
+        <p:nvPr/>
+      </p:nvGrpSpPr>
+      <p:grpSpPr>
+        <a:xfrm>
+          <a:off x="0" y="0"/>
+          <a:ext cx="0" cy="0"/>
+          <a:chOff x="0" y="0"/>
+          <a:chExt cx="0" cy="0"/>
+        </a:xfrm>
+      </p:grpSpPr>
+      <p:sp useBgFill="1">
+        <p:nvSpPr>
+          <p:cNvPr id="28" name="Rectangle 27">
+            <a:extLst>
+              <a:ext uri="{FF2B5EF4-FFF2-40B4-BE49-F238E27FC236}">
+                <a16:creationId xmlns:a16="http://schemas.microsoft.com/office/drawing/2014/main" id="{C1A1C5D3-C053-4EE9-BE1A-419B6E27CCAE}"/>
+              </a:ext>
+              <a:ext uri="{C183D7F6-B498-43B3-948B-1728B52AA6E4}">
+                <adec:decorative xmlns:adec="http://schemas.microsoft.com/office/drawing/2017/decorative" val="1"/>
+              </a:ext>
+            </a:extLst>
+          </p:cNvPr>
+          <p:cNvSpPr>
+            <a:spLocks noGrp="1" noRot="1" noChangeAspect="1" noMove="1" noResize="1" noEditPoints="1" noAdjustHandles="1" noChangeArrowheads="1" noChangeShapeType="1" noTextEdit="1"/>
+          </p:cNvSpPr>
+          <p:nvPr>
+            <p:extLst>
+              <p:ext uri="{386F3935-93C4-4BCD-93E2-E3B085C9AB24}">
+                <p16:designElem xmlns:p16="http://schemas.microsoft.com/office/powerpoint/2015/main" val="1"/>
+              </p:ext>
+            </p:extLst>
+          </p:nvPr>
+        </p:nvSpPr>
+        <p:spPr>
+          <a:xfrm>
+            <a:off x="0" y="0"/>
+            <a:ext cx="12192000" cy="6858000"/>
+          </a:xfrm>
+          <a:prstGeom prst="rect">
+            <a:avLst/>
+          </a:prstGeom>
+          <a:ln>
+            <a:noFill/>
+          </a:ln>
+        </p:spPr>
+        <p:style>
+          <a:lnRef idx="2">
+            <a:schemeClr val="accent1">
+              <a:shade val="50000"/>
+            </a:schemeClr>
+          </a:lnRef>
+          <a:fillRef idx="1">
+            <a:schemeClr val="accent1"/>
+          </a:fillRef>
+          <a:effectRef idx="0">
+            <a:schemeClr val="accent1"/>
+          </a:effectRef>
+          <a:fontRef idx="minor">
+            <a:schemeClr val="lt1"/>
+          </a:fontRef>
+        </p:style>
+        <p:txBody>
+          <a:bodyPr rtlCol="0" anchor="ctr"/>
+          <a:lstStyle/>
+          <a:p>
+            <a:pPr algn="ctr"/>
+            <a:endParaRPr lang="en-US"/>
+          </a:p>
+        </p:txBody>
+      </p:sp>
+      <p:sp useBgFill="1">
+        <p:nvSpPr>
+          <p:cNvPr id="30" name="Rectangle 29">
+            <a:extLst>
+              <a:ext uri="{FF2B5EF4-FFF2-40B4-BE49-F238E27FC236}">
+                <a16:creationId xmlns:a16="http://schemas.microsoft.com/office/drawing/2014/main" id="{A3473CF9-37EB-43E7-89EF-D2D1C53D1DAC}"/>
+              </a:ext>
+              <a:ext uri="{C183D7F6-B498-43B3-948B-1728B52AA6E4}">
+                <adec:decorative xmlns:adec="http://schemas.microsoft.com/office/drawing/2017/decorative" val="1"/>
+              </a:ext>
+            </a:extLst>
+          </p:cNvPr>
+          <p:cNvSpPr>
+            <a:spLocks noGrp="1" noRot="1" noChangeAspect="1" noMove="1" noResize="1" noEditPoints="1" noAdjustHandles="1" noChangeArrowheads="1" noChangeShapeType="1" noTextEdit="1"/>
+          </p:cNvSpPr>
+          <p:nvPr>
+            <p:extLst>
+              <p:ext uri="{386F3935-93C4-4BCD-93E2-E3B085C9AB24}">
+                <p16:designElem xmlns:p16="http://schemas.microsoft.com/office/powerpoint/2015/main" val="1"/>
+              </p:ext>
+            </p:extLst>
+          </p:nvPr>
+        </p:nvSpPr>
+        <p:spPr>
+          <a:xfrm>
+            <a:off x="1903615" y="221673"/>
+            <a:ext cx="8384770" cy="1332634"/>
+          </a:xfrm>
+          <a:prstGeom prst="rect">
+            <a:avLst/>
+          </a:prstGeom>
+          <a:ln w="12700">
+            <a:solidFill>
+              <a:srgbClr val="E1E1E1"/>
+            </a:solidFill>
+          </a:ln>
+          <a:effectLst>
+            <a:outerShdw blurRad="50800" dist="38100" dir="2700000" algn="tl" rotWithShape="0">
+              <a:schemeClr val="bg2">
+                <a:lumMod val="85000"/>
+                <a:alpha val="50000"/>
+              </a:schemeClr>
+            </a:outerShdw>
+          </a:effectLst>
+        </p:spPr>
+        <p:style>
+          <a:lnRef idx="2">
+            <a:schemeClr val="accent1">
+              <a:shade val="50000"/>
+            </a:schemeClr>
+          </a:lnRef>
+          <a:fillRef idx="1">
+            <a:schemeClr val="accent1"/>
+          </a:fillRef>
+          <a:effectRef idx="0">
+            <a:schemeClr val="accent1"/>
+          </a:effectRef>
+          <a:fontRef idx="minor">
+            <a:schemeClr val="lt1"/>
+          </a:fontRef>
+        </p:style>
+        <p:txBody>
+          <a:bodyPr rtlCol="0" anchor="ctr"/>
+          <a:lstStyle/>
+          <a:p>
+            <a:pPr marL="0" marR="0" lvl="0" indent="0" algn="ctr" defTabSz="914400" rtl="0" eaLnBrk="1" fontAlgn="auto" latinLnBrk="0" hangingPunct="1">
+              <a:lnSpc>
+                <a:spcPct val="100000"/>
+              </a:lnSpc>
+              <a:spcBef>
+                <a:spcPts val="0"/>
+              </a:spcBef>
+              <a:spcAft>
+                <a:spcPts val="0"/>
+              </a:spcAft>
+              <a:buClrTx/>
+              <a:buSzTx/>
+              <a:buFontTx/>
+              <a:buNone/>
+              <a:tabLst/>
+              <a:defRPr/>
+            </a:pPr>
+            <a:endParaRPr kumimoji="0" lang="en-US" sz="1800" b="0" i="0" u="none" strike="noStrike" kern="1200" cap="none" spc="0" normalizeH="0" baseline="0" noProof="0">
+              <a:ln>
+                <a:noFill/>
+              </a:ln>
+              <a:solidFill>
+                <a:prstClr val="white"/>
+              </a:solidFill>
+              <a:effectLst/>
+              <a:uLnTx/>
+              <a:uFillTx/>
+              <a:latin typeface="Calibri" panose="020F0502020204030204"/>
+              <a:ea typeface="+mn-ea"/>
+              <a:cs typeface="+mn-cs"/>
+            </a:endParaRPr>
+          </a:p>
+        </p:txBody>
+      </p:sp>
+      <p:sp>
+        <p:nvSpPr>
+          <p:cNvPr id="2" name="Title 1">
+            <a:extLst>
+              <a:ext uri="{FF2B5EF4-FFF2-40B4-BE49-F238E27FC236}">
+                <a16:creationId xmlns:a16="http://schemas.microsoft.com/office/drawing/2014/main" id="{7523CF74-09B7-84B3-F859-D7073DC1C80F}"/>
+              </a:ext>
+            </a:extLst>
+          </p:cNvPr>
+          <p:cNvSpPr>
+            <a:spLocks noGrp="1"/>
+          </p:cNvSpPr>
+          <p:nvPr>
+            <p:ph type="title"/>
+          </p:nvPr>
+        </p:nvSpPr>
+        <p:spPr>
+          <a:xfrm>
+            <a:off x="2103121" y="310343"/>
+            <a:ext cx="7985759" cy="868823"/>
+          </a:xfrm>
+        </p:spPr>
+        <p:txBody>
+          <a:bodyPr vert="horz" lIns="91440" tIns="45720" rIns="91440" bIns="45720" rtlCol="0" anchor="ctr">
+            <a:normAutofit/>
+          </a:bodyPr>
+          <a:lstStyle/>
+          <a:p>
+            <a:pPr algn="ctr"/>
+            <a:r>
+              <a:rPr lang="en-US" sz="4000" kern="1200">
+                <a:solidFill>
+                  <a:schemeClr val="tx1"/>
+                </a:solidFill>
+                <a:latin typeface="+mj-lt"/>
+                <a:ea typeface="+mj-ea"/>
+                <a:cs typeface="+mj-cs"/>
+              </a:rPr>
+              <a:t>Planning</a:t>
+            </a:r>
+          </a:p>
+        </p:txBody>
+      </p:sp>
+      <p:sp>
+        <p:nvSpPr>
+          <p:cNvPr id="32" name="Rectangle: Rounded Corners 31">
+            <a:extLst>
+              <a:ext uri="{FF2B5EF4-FFF2-40B4-BE49-F238E27FC236}">
+                <a16:creationId xmlns:a16="http://schemas.microsoft.com/office/drawing/2014/main" id="{586B4EF9-43BA-4655-A6FF-1D8E21574C95}"/>
+              </a:ext>
+              <a:ext uri="{C183D7F6-B498-43B3-948B-1728B52AA6E4}">
+                <adec:decorative xmlns:adec="http://schemas.microsoft.com/office/drawing/2017/decorative" val="1"/>
+              </a:ext>
+            </a:extLst>
+          </p:cNvPr>
+          <p:cNvSpPr>
+            <a:spLocks noGrp="1" noRot="1" noChangeAspect="1" noMove="1" noResize="1" noEditPoints="1" noAdjustHandles="1" noChangeArrowheads="1" noChangeShapeType="1" noTextEdit="1"/>
+          </p:cNvSpPr>
+          <p:nvPr>
+            <p:extLst>
+              <p:ext uri="{386F3935-93C4-4BCD-93E2-E3B085C9AB24}">
+                <p16:designElem xmlns:p16="http://schemas.microsoft.com/office/powerpoint/2015/main" val="1"/>
+              </p:ext>
+            </p:extLst>
+          </p:nvPr>
+        </p:nvSpPr>
+        <p:spPr>
+          <a:xfrm>
+            <a:off x="2483110" y="1211407"/>
+            <a:ext cx="7225780" cy="685800"/>
+          </a:xfrm>
+          <a:prstGeom prst="roundRect">
+            <a:avLst>
+              <a:gd name="adj" fmla="val 0"/>
+            </a:avLst>
+          </a:prstGeom>
+          <a:solidFill>
+            <a:schemeClr val="accent2"/>
+          </a:solidFill>
+          <a:ln>
+            <a:noFill/>
+          </a:ln>
+        </p:spPr>
+        <p:style>
+          <a:lnRef idx="2">
+            <a:schemeClr val="accent1">
+              <a:shade val="50000"/>
+            </a:schemeClr>
+          </a:lnRef>
+          <a:fillRef idx="1">
+            <a:schemeClr val="accent1"/>
+          </a:fillRef>
+          <a:effectRef idx="0">
+            <a:schemeClr val="accent1"/>
+          </a:effectRef>
+          <a:fontRef idx="minor">
+            <a:schemeClr val="lt1"/>
+          </a:fontRef>
+        </p:style>
+        <p:txBody>
+          <a:bodyPr rtlCol="0" anchor="ctr"/>
+          <a:lstStyle/>
+          <a:p>
+            <a:pPr algn="ctr"/>
+            <a:endParaRPr lang="en-US">
+              <a:solidFill>
+                <a:prstClr val="white"/>
+              </a:solidFill>
+              <a:latin typeface="Calibri" panose="020F0502020204030204"/>
+            </a:endParaRPr>
+          </a:p>
+        </p:txBody>
+      </p:sp>
+      <p:sp>
+        <p:nvSpPr>
+          <p:cNvPr id="3" name="Text Placeholder 2">
+            <a:extLst>
+              <a:ext uri="{FF2B5EF4-FFF2-40B4-BE49-F238E27FC236}">
+                <a16:creationId xmlns:a16="http://schemas.microsoft.com/office/drawing/2014/main" id="{C605E30C-3490-D1E3-740D-40AD5E393958}"/>
+              </a:ext>
+            </a:extLst>
+          </p:cNvPr>
+          <p:cNvSpPr>
+            <a:spLocks noGrp="1"/>
+          </p:cNvSpPr>
+          <p:nvPr>
+            <p:ph type="body" idx="1"/>
+          </p:nvPr>
+        </p:nvSpPr>
+        <p:spPr>
+          <a:xfrm>
+            <a:off x="2615738" y="1263807"/>
+            <a:ext cx="6960524" cy="598516"/>
+          </a:xfrm>
+        </p:spPr>
+        <p:txBody>
+          <a:bodyPr vert="horz" lIns="91440" tIns="45720" rIns="91440" bIns="45720" rtlCol="0" anchor="ctr">
+            <a:normAutofit/>
+          </a:bodyPr>
+          <a:lstStyle/>
+          <a:p>
+            <a:pPr algn="ctr"/>
+            <a:r>
+              <a:rPr lang="en-US" sz="2000" kern="1200">
+                <a:solidFill>
+                  <a:schemeClr val="bg1"/>
+                </a:solidFill>
+                <a:latin typeface="+mn-lt"/>
+                <a:ea typeface="+mn-ea"/>
+                <a:cs typeface="+mn-cs"/>
+              </a:rPr>
+              <a:t>Gant chart</a:t>
+            </a:r>
+          </a:p>
+        </p:txBody>
+      </p:sp>
+      <p:pic>
+        <p:nvPicPr>
+          <p:cNvPr id="6" name="Picture 5">
+            <a:extLst>
+              <a:ext uri="{FF2B5EF4-FFF2-40B4-BE49-F238E27FC236}">
+                <a16:creationId xmlns:a16="http://schemas.microsoft.com/office/drawing/2014/main" id="{0D4E0165-E852-9E37-91F6-9A7920B23AEB}"/>
+              </a:ext>
+            </a:extLst>
+          </p:cNvPr>
+          <p:cNvPicPr>
+            <a:picLocks noChangeAspect="1"/>
+          </p:cNvPicPr>
+          <p:nvPr/>
+        </p:nvPicPr>
+        <p:blipFill>
+          <a:blip r:embed="rId2"/>
+          <a:stretch>
+            <a:fillRect/>
+          </a:stretch>
+        </p:blipFill>
+        <p:spPr>
+          <a:xfrm>
+            <a:off x="926432" y="2024164"/>
+            <a:ext cx="10503568" cy="4706879"/>
+          </a:xfrm>
+          <a:prstGeom prst="rect">
+            <a:avLst/>
+          </a:prstGeom>
+          <a:ln>
+            <a:solidFill>
+              <a:schemeClr val="accent2"/>
+            </a:solidFill>
+          </a:ln>
+        </p:spPr>
+      </p:pic>
+    </p:spTree>
+    <p:extLst>
+      <p:ext uri="{BB962C8B-B14F-4D97-AF65-F5344CB8AC3E}">
+        <p14:creationId xmlns:p14="http://schemas.microsoft.com/office/powerpoint/2010/main" val="3713997872"/>
+      </p:ext>
+    </p:extLst>
+  </p:cSld>
+  <p:clrMapOvr>
+    <a:masterClrMapping/>
+  </p:clrMapOvr>
+</p:sld>
+</file>
+
+<file path=ppt/slides/slide11.xml><?xml version="1.0" encoding="utf-8"?>
+<p:sld xmlns:a="http://schemas.openxmlformats.org/drawingml/2006/main" xmlns:r="http://schemas.openxmlformats.org/officeDocument/2006/relationships" xmlns:p="http://schemas.openxmlformats.org/presentationml/2006/main">
+  <p:cSld>
+    <p:bg>
+      <p:bgPr>
+        <a:solidFill>
+          <a:schemeClr val="bg1"/>
+        </a:solidFill>
+        <a:effectLst/>
+      </p:bgPr>
+    </p:bg>
+    <p:spTree>
+      <p:nvGrpSpPr>
+        <p:cNvPr id="1" name=""/>
+        <p:cNvGrpSpPr/>
+        <p:nvPr/>
+      </p:nvGrpSpPr>
+      <p:grpSpPr>
+        <a:xfrm>
+          <a:off x="0" y="0"/>
+          <a:ext cx="0" cy="0"/>
+          <a:chOff x="0" y="0"/>
+          <a:chExt cx="0" cy="0"/>
+        </a:xfrm>
+      </p:grpSpPr>
+      <p:sp useBgFill="1">
+        <p:nvSpPr>
+          <p:cNvPr id="7" name="Rectangle 6">
+            <a:extLst>
+              <a:ext uri="{FF2B5EF4-FFF2-40B4-BE49-F238E27FC236}">
+                <a16:creationId xmlns:a16="http://schemas.microsoft.com/office/drawing/2014/main" id="{9C7E0A2C-7C0A-4AAC-B3B0-6C12B2EBAE05}"/>
+              </a:ext>
+              <a:ext uri="{C183D7F6-B498-43B3-948B-1728B52AA6E4}">
+                <adec:decorative xmlns:adec="http://schemas.microsoft.com/office/drawing/2017/decorative" val="1"/>
+              </a:ext>
+            </a:extLst>
+          </p:cNvPr>
+          <p:cNvSpPr>
+            <a:spLocks noGrp="1" noRot="1" noChangeAspect="1" noMove="1" noResize="1" noEditPoints="1" noAdjustHandles="1" noChangeArrowheads="1" noChangeShapeType="1" noTextEdit="1"/>
+          </p:cNvSpPr>
+          <p:nvPr>
+            <p:extLst>
+              <p:ext uri="{386F3935-93C4-4BCD-93E2-E3B085C9AB24}">
+                <p16:designElem xmlns:p16="http://schemas.microsoft.com/office/powerpoint/2015/main" val="1"/>
+              </p:ext>
+            </p:extLst>
+          </p:nvPr>
+        </p:nvSpPr>
+        <p:spPr>
+          <a:xfrm>
+            <a:off x="0" y="0"/>
+            <a:ext cx="12191999" cy="6857365"/>
+          </a:xfrm>
+          <a:prstGeom prst="rect">
+            <a:avLst/>
+          </a:prstGeom>
+          <a:ln>
+            <a:noFill/>
+          </a:ln>
+        </p:spPr>
+        <p:style>
+          <a:lnRef idx="2">
+            <a:schemeClr val="accent1">
+              <a:shade val="50000"/>
+            </a:schemeClr>
+          </a:lnRef>
+          <a:fillRef idx="1">
+            <a:schemeClr val="accent1"/>
+          </a:fillRef>
+          <a:effectRef idx="0">
+            <a:schemeClr val="accent1"/>
+          </a:effectRef>
+          <a:fontRef idx="minor">
+            <a:schemeClr val="lt1"/>
+          </a:fontRef>
+        </p:style>
+        <p:txBody>
+          <a:bodyPr rtlCol="0" anchor="ctr"/>
+          <a:lstStyle/>
+          <a:p>
+            <a:pPr algn="ctr"/>
+            <a:endParaRPr lang="en-US"/>
+          </a:p>
+        </p:txBody>
+      </p:sp>
+      <p:sp>
+        <p:nvSpPr>
+          <p:cNvPr id="9" name="Rectangle 8">
+            <a:extLst>
+              <a:ext uri="{FF2B5EF4-FFF2-40B4-BE49-F238E27FC236}">
+                <a16:creationId xmlns:a16="http://schemas.microsoft.com/office/drawing/2014/main" id="{5EB7D2A2-F448-44D4-938C-DC84CBCB3B1E}"/>
+              </a:ext>
+              <a:ext uri="{C183D7F6-B498-43B3-948B-1728B52AA6E4}">
+                <adec:decorative xmlns:adec="http://schemas.microsoft.com/office/drawing/2017/decorative" val="1"/>
+              </a:ext>
+            </a:extLst>
+          </p:cNvPr>
+          <p:cNvSpPr>
+            <a:spLocks noGrp="1" noRot="1" noChangeAspect="1" noMove="1" noResize="1" noEditPoints="1" noAdjustHandles="1" noChangeArrowheads="1" noChangeShapeType="1" noTextEdit="1"/>
+          </p:cNvSpPr>
+          <p:nvPr>
+            <p:extLst>
+              <p:ext uri="{386F3935-93C4-4BCD-93E2-E3B085C9AB24}">
+                <p16:designElem xmlns:p16="http://schemas.microsoft.com/office/powerpoint/2015/main" val="1"/>
+              </p:ext>
+            </p:extLst>
+          </p:nvPr>
+        </p:nvSpPr>
+        <p:spPr>
+          <a:xfrm>
+            <a:off x="0" y="1"/>
+            <a:ext cx="12192000" cy="5187142"/>
+          </a:xfrm>
+          <a:prstGeom prst="rect">
+            <a:avLst/>
+          </a:prstGeom>
+          <a:solidFill>
+            <a:schemeClr val="accent4"/>
+          </a:solidFill>
+          <a:ln>
+            <a:noFill/>
+          </a:ln>
+        </p:spPr>
+        <p:style>
+          <a:lnRef idx="2">
+            <a:schemeClr val="accent1">
+              <a:shade val="50000"/>
+            </a:schemeClr>
+          </a:lnRef>
+          <a:fillRef idx="1">
+            <a:schemeClr val="accent1"/>
+          </a:fillRef>
+          <a:effectRef idx="0">
+            <a:schemeClr val="accent1"/>
+          </a:effectRef>
+          <a:fontRef idx="minor">
+            <a:schemeClr val="lt1"/>
+          </a:fontRef>
+        </p:style>
+        <p:txBody>
+          <a:bodyPr rtlCol="0" anchor="ctr"/>
+          <a:lstStyle/>
+          <a:p>
+            <a:pPr algn="ctr"/>
+            <a:endParaRPr lang="en-US" dirty="0"/>
+          </a:p>
+        </p:txBody>
+      </p:sp>
+      <p:sp>
+        <p:nvSpPr>
+          <p:cNvPr id="11" name="Rectangle 10">
+            <a:extLst>
+              <a:ext uri="{FF2B5EF4-FFF2-40B4-BE49-F238E27FC236}">
+                <a16:creationId xmlns:a16="http://schemas.microsoft.com/office/drawing/2014/main" id="{871AEA07-1E14-44B4-8E55-64EF049CD66F}"/>
+              </a:ext>
+              <a:ext uri="{C183D7F6-B498-43B3-948B-1728B52AA6E4}">
+                <adec:decorative xmlns:adec="http://schemas.microsoft.com/office/drawing/2017/decorative" val="1"/>
+              </a:ext>
+            </a:extLst>
+          </p:cNvPr>
+          <p:cNvSpPr>
+            <a:spLocks noGrp="1" noRot="1" noChangeAspect="1" noMove="1" noResize="1" noEditPoints="1" noAdjustHandles="1" noChangeArrowheads="1" noChangeShapeType="1" noTextEdit="1"/>
+          </p:cNvSpPr>
+          <p:nvPr>
+            <p:extLst>
+              <p:ext uri="{386F3935-93C4-4BCD-93E2-E3B085C9AB24}">
+                <p16:designElem xmlns:p16="http://schemas.microsoft.com/office/powerpoint/2015/main" val="1"/>
+              </p:ext>
+            </p:extLst>
+          </p:nvPr>
+        </p:nvSpPr>
+        <p:spPr>
+          <a:xfrm>
+            <a:off x="596464" y="551961"/>
+            <a:ext cx="10999072" cy="5399950"/>
+          </a:xfrm>
+          <a:prstGeom prst="rect">
+            <a:avLst/>
+          </a:prstGeom>
+          <a:solidFill>
+            <a:schemeClr val="bg1"/>
+          </a:solidFill>
+          <a:ln>
+            <a:noFill/>
+          </a:ln>
+          <a:effectLst>
+            <a:outerShdw blurRad="139700" dist="127000" dir="5400000" algn="t" rotWithShape="0">
+              <a:prstClr val="black">
+                <a:alpha val="15000"/>
+              </a:prstClr>
+            </a:outerShdw>
+          </a:effectLst>
+        </p:spPr>
+        <p:style>
+          <a:lnRef idx="2">
+            <a:schemeClr val="accent1">
+              <a:shade val="50000"/>
+            </a:schemeClr>
+          </a:lnRef>
+          <a:fillRef idx="1">
+            <a:schemeClr val="accent1"/>
+          </a:fillRef>
+          <a:effectRef idx="0">
+            <a:schemeClr val="accent1"/>
+          </a:effectRef>
+          <a:fontRef idx="minor">
+            <a:schemeClr val="lt1"/>
+          </a:fontRef>
+        </p:style>
+        <p:txBody>
+          <a:bodyPr rtlCol="0" anchor="ctr"/>
+          <a:lstStyle/>
+          <a:p>
+            <a:pPr algn="ctr"/>
+            <a:endParaRPr lang="en-US"/>
+          </a:p>
+        </p:txBody>
+      </p:sp>
+      <p:sp>
+        <p:nvSpPr>
+          <p:cNvPr id="2" name="Title 1">
+            <a:extLst>
+              <a:ext uri="{FF2B5EF4-FFF2-40B4-BE49-F238E27FC236}">
+                <a16:creationId xmlns:a16="http://schemas.microsoft.com/office/drawing/2014/main" id="{9C9AD6B9-1CEE-7976-0BB7-22F5E9535735}"/>
+              </a:ext>
+            </a:extLst>
+          </p:cNvPr>
+          <p:cNvSpPr>
+            <a:spLocks noGrp="1"/>
+          </p:cNvSpPr>
+          <p:nvPr>
+            <p:ph type="title"/>
+          </p:nvPr>
+        </p:nvSpPr>
+        <p:spPr>
+          <a:xfrm>
+            <a:off x="1523999" y="1180494"/>
+            <a:ext cx="9144000" cy="2387600"/>
+          </a:xfrm>
+        </p:spPr>
+        <p:txBody>
+          <a:bodyPr vert="horz" lIns="91440" tIns="45720" rIns="91440" bIns="45720" rtlCol="0" anchor="b">
+            <a:normAutofit/>
+          </a:bodyPr>
+          <a:lstStyle/>
+          <a:p>
+            <a:pPr algn="ctr"/>
+            <a:r>
+              <a:rPr lang="en-US" sz="3500" kern="1200" dirty="0">
+                <a:solidFill>
+                  <a:schemeClr val="tx1"/>
+                </a:solidFill>
+                <a:latin typeface="+mj-lt"/>
+                <a:ea typeface="+mj-ea"/>
+                <a:cs typeface="+mj-cs"/>
+              </a:rPr>
+              <a:t>Website: </a:t>
+            </a:r>
+            <a:r>
+              <a:rPr lang="en-US" sz="3500" kern="1200" dirty="0">
+                <a:solidFill>
+                  <a:srgbClr val="0070C0"/>
+                </a:solidFill>
+                <a:latin typeface="+mj-lt"/>
+                <a:ea typeface="+mj-ea"/>
+                <a:cs typeface="+mj-cs"/>
+                <a:hlinkClick r:id="rId2">
+                  <a:extLst>
+                    <a:ext uri="{A12FA001-AC4F-418D-AE19-62706E023703}">
+                      <ahyp:hlinkClr xmlns:ahyp="http://schemas.microsoft.com/office/drawing/2018/hyperlinkcolor" val="tx"/>
+                    </a:ext>
+                  </a:extLst>
+                </a:hlinkClick>
+              </a:rPr>
+              <a:t>https://jjdeuce06.github.io/VulcanActivityTracker/</a:t>
+            </a:r>
+            <a:endParaRPr lang="en-US" sz="3500" kern="1200" dirty="0">
+              <a:solidFill>
+                <a:srgbClr val="0070C0"/>
+              </a:solidFill>
+              <a:latin typeface="+mj-lt"/>
+              <a:ea typeface="+mj-ea"/>
+              <a:cs typeface="+mj-cs"/>
+            </a:endParaRPr>
+          </a:p>
+        </p:txBody>
+      </p:sp>
+      <p:cxnSp>
+        <p:nvCxnSpPr>
+          <p:cNvPr id="13" name="Straight Connector 12">
+            <a:extLst>
+              <a:ext uri="{FF2B5EF4-FFF2-40B4-BE49-F238E27FC236}">
+                <a16:creationId xmlns:a16="http://schemas.microsoft.com/office/drawing/2014/main" id="{F7C8EA93-3210-4C62-99E9-153C275E3A87}"/>
+              </a:ext>
+              <a:ext uri="{C183D7F6-B498-43B3-948B-1728B52AA6E4}">
+                <adec:decorative xmlns:adec="http://schemas.microsoft.com/office/drawing/2017/decorative" val="1"/>
+              </a:ext>
+            </a:extLst>
+          </p:cNvPr>
+          <p:cNvCxnSpPr>
+            <a:cxnSpLocks noGrp="1" noRot="1" noChangeAspect="1" noMove="1" noResize="1" noEditPoints="1" noAdjustHandles="1" noChangeArrowheads="1" noChangeShapeType="1"/>
+          </p:cNvCxnSpPr>
+          <p:nvPr>
+            <p:extLst>
+              <p:ext uri="{386F3935-93C4-4BCD-93E2-E3B085C9AB24}">
+                <p16:designElem xmlns:p16="http://schemas.microsoft.com/office/powerpoint/2015/main" val="1"/>
+              </p:ext>
+            </p:extLst>
+          </p:nvPr>
+        </p:nvCxnSpPr>
+        <p:spPr>
+          <a:xfrm flipH="1">
+            <a:off x="596464" y="6329769"/>
+            <a:ext cx="11000232" cy="0"/>
+          </a:xfrm>
+          <a:prstGeom prst="line">
+            <a:avLst/>
+          </a:prstGeom>
+          <a:ln w="152400">
+            <a:solidFill>
+              <a:schemeClr val="accent4"/>
+            </a:solidFill>
+          </a:ln>
+        </p:spPr>
+        <p:style>
+          <a:lnRef idx="1">
+            <a:schemeClr val="accent1"/>
+          </a:lnRef>
+          <a:fillRef idx="0">
+            <a:schemeClr val="accent1"/>
+          </a:fillRef>
+          <a:effectRef idx="0">
+            <a:schemeClr val="accent1"/>
+          </a:effectRef>
+          <a:fontRef idx="minor">
+            <a:schemeClr val="tx1"/>
+          </a:fontRef>
+        </p:style>
+      </p:cxnSp>
+    </p:spTree>
+    <p:extLst>
+      <p:ext uri="{BB962C8B-B14F-4D97-AF65-F5344CB8AC3E}">
+        <p14:creationId xmlns:p14="http://schemas.microsoft.com/office/powerpoint/2010/main" val="3921983173"/>
+      </p:ext>
+    </p:extLst>
+  </p:cSld>
+  <p:clrMapOvr>
+    <a:masterClrMapping/>
+  </p:clrMapOvr>
+</p:sld>
+</file>
+
 <file path=ppt/slides/slide2.xml><?xml version="1.0" encoding="utf-8"?>
 <p:sld xmlns:a="http://schemas.openxmlformats.org/drawingml/2006/main" xmlns:r="http://schemas.openxmlformats.org/officeDocument/2006/relationships" xmlns:p="http://schemas.openxmlformats.org/presentationml/2006/main">
   <p:cSld>
@@ -12601,6 +13526,1332 @@
       </p:grpSpPr>
       <p:sp useBgFill="1">
         <p:nvSpPr>
+          <p:cNvPr id="8" name="Rectangle 7">
+            <a:extLst>
+              <a:ext uri="{FF2B5EF4-FFF2-40B4-BE49-F238E27FC236}">
+                <a16:creationId xmlns:a16="http://schemas.microsoft.com/office/drawing/2014/main" id="{46F1F2C8-798B-4CCE-A851-94AFAF350BED}"/>
+              </a:ext>
+              <a:ext uri="{C183D7F6-B498-43B3-948B-1728B52AA6E4}">
+                <adec:decorative xmlns:adec="http://schemas.microsoft.com/office/drawing/2017/decorative" val="1"/>
+              </a:ext>
+            </a:extLst>
+          </p:cNvPr>
+          <p:cNvSpPr>
+            <a:spLocks noGrp="1" noRot="1" noChangeAspect="1" noMove="1" noResize="1" noEditPoints="1" noAdjustHandles="1" noChangeArrowheads="1" noChangeShapeType="1" noTextEdit="1"/>
+          </p:cNvSpPr>
+          <p:nvPr>
+            <p:extLst>
+              <p:ext uri="{386F3935-93C4-4BCD-93E2-E3B085C9AB24}">
+                <p16:designElem xmlns:p16="http://schemas.microsoft.com/office/powerpoint/2015/main" val="1"/>
+              </p:ext>
+            </p:extLst>
+          </p:nvPr>
+        </p:nvSpPr>
+        <p:spPr>
+          <a:xfrm>
+            <a:off x="3048" y="0"/>
+            <a:ext cx="12188952" cy="6858000"/>
+          </a:xfrm>
+          <a:prstGeom prst="rect">
+            <a:avLst/>
+          </a:prstGeom>
+          <a:ln>
+            <a:noFill/>
+          </a:ln>
+        </p:spPr>
+        <p:style>
+          <a:lnRef idx="2">
+            <a:schemeClr val="accent1">
+              <a:shade val="50000"/>
+            </a:schemeClr>
+          </a:lnRef>
+          <a:fillRef idx="1">
+            <a:schemeClr val="accent1"/>
+          </a:fillRef>
+          <a:effectRef idx="0">
+            <a:schemeClr val="accent1"/>
+          </a:effectRef>
+          <a:fontRef idx="minor">
+            <a:schemeClr val="lt1"/>
+          </a:fontRef>
+        </p:style>
+        <p:txBody>
+          <a:bodyPr rtlCol="0" anchor="ctr"/>
+          <a:lstStyle/>
+          <a:p>
+            <a:pPr algn="ctr"/>
+            <a:endParaRPr lang="en-US"/>
+          </a:p>
+        </p:txBody>
+      </p:sp>
+      <p:sp>
+        <p:nvSpPr>
+          <p:cNvPr id="2" name="Title 1">
+            <a:extLst>
+              <a:ext uri="{FF2B5EF4-FFF2-40B4-BE49-F238E27FC236}">
+                <a16:creationId xmlns:a16="http://schemas.microsoft.com/office/drawing/2014/main" id="{DF831928-2BB9-C45B-9B78-9B9C5E78C657}"/>
+              </a:ext>
+            </a:extLst>
+          </p:cNvPr>
+          <p:cNvSpPr>
+            <a:spLocks noGrp="1"/>
+          </p:cNvSpPr>
+          <p:nvPr>
+            <p:ph type="title"/>
+          </p:nvPr>
+        </p:nvSpPr>
+        <p:spPr>
+          <a:xfrm>
+            <a:off x="848239" y="238999"/>
+            <a:ext cx="5425781" cy="899768"/>
+          </a:xfrm>
+        </p:spPr>
+        <p:txBody>
+          <a:bodyPr vert="horz" lIns="91440" tIns="45720" rIns="91440" bIns="45720" rtlCol="0" anchor="b">
+            <a:normAutofit fontScale="90000"/>
+          </a:bodyPr>
+          <a:lstStyle/>
+          <a:p>
+            <a:r>
+              <a:rPr lang="en-US" kern="1200" dirty="0">
+                <a:solidFill>
+                  <a:schemeClr val="tx1"/>
+                </a:solidFill>
+                <a:latin typeface="+mj-lt"/>
+                <a:ea typeface="+mj-ea"/>
+                <a:cs typeface="+mj-cs"/>
+              </a:rPr>
+              <a:t>Hosting</a:t>
+            </a:r>
+          </a:p>
+        </p:txBody>
+      </p:sp>
+      <p:sp>
+        <p:nvSpPr>
+          <p:cNvPr id="3" name="Text Placeholder 2">
+            <a:extLst>
+              <a:ext uri="{FF2B5EF4-FFF2-40B4-BE49-F238E27FC236}">
+                <a16:creationId xmlns:a16="http://schemas.microsoft.com/office/drawing/2014/main" id="{A2C8BFE2-FC98-104F-F2E2-CE52A9F6721A}"/>
+              </a:ext>
+            </a:extLst>
+          </p:cNvPr>
+          <p:cNvSpPr>
+            <a:spLocks noGrp="1"/>
+          </p:cNvSpPr>
+          <p:nvPr>
+            <p:ph type="body" idx="1"/>
+          </p:nvPr>
+        </p:nvSpPr>
+        <p:spPr>
+          <a:xfrm>
+            <a:off x="308838" y="1366955"/>
+            <a:ext cx="6412910" cy="5252046"/>
+          </a:xfrm>
+        </p:spPr>
+        <p:txBody>
+          <a:bodyPr vert="horz" lIns="91440" tIns="45720" rIns="91440" bIns="45720" rtlCol="0">
+            <a:normAutofit fontScale="85000" lnSpcReduction="10000"/>
+          </a:bodyPr>
+          <a:lstStyle/>
+          <a:p>
+            <a:r>
+              <a:rPr lang="en-US" sz="2000" b="1" kern="1200" dirty="0">
+                <a:solidFill>
+                  <a:schemeClr val="tx1"/>
+                </a:solidFill>
+                <a:latin typeface="+mn-lt"/>
+                <a:ea typeface="+mn-ea"/>
+                <a:cs typeface="+mn-cs"/>
+              </a:rPr>
+              <a:t>Platforms Attempted:</a:t>
+            </a:r>
+            <a:r>
+              <a:rPr lang="en-US" sz="2000" kern="1200" dirty="0">
+                <a:solidFill>
+                  <a:schemeClr val="tx1"/>
+                </a:solidFill>
+                <a:latin typeface="+mn-lt"/>
+                <a:ea typeface="+mn-ea"/>
+                <a:cs typeface="+mn-cs"/>
+              </a:rPr>
+              <a:t> </a:t>
+            </a:r>
+          </a:p>
+          <a:p>
+            <a:pPr marL="342900" lvl="1" indent="-342900">
+              <a:spcBef>
+                <a:spcPts val="1000"/>
+              </a:spcBef>
+              <a:buFont typeface="Arial" panose="020B0604020202020204" pitchFamily="34" charset="0"/>
+              <a:buChar char="•"/>
+            </a:pPr>
+            <a:r>
+              <a:rPr lang="en-US" kern="1200" dirty="0">
+                <a:solidFill>
+                  <a:schemeClr val="tx1"/>
+                </a:solidFill>
+                <a:latin typeface="+mn-lt"/>
+                <a:ea typeface="+mn-ea"/>
+                <a:cs typeface="+mn-cs"/>
+              </a:rPr>
+              <a:t>Render (Free &amp; Paid) → MSSQL container failed to start </a:t>
+            </a:r>
+          </a:p>
+          <a:p>
+            <a:pPr marL="342900" lvl="1" indent="-342900">
+              <a:spcBef>
+                <a:spcPts val="1000"/>
+              </a:spcBef>
+              <a:buFont typeface="Arial" panose="020B0604020202020204" pitchFamily="34" charset="0"/>
+              <a:buChar char="•"/>
+            </a:pPr>
+            <a:r>
+              <a:rPr lang="en-US" kern="1200" dirty="0">
+                <a:solidFill>
+                  <a:schemeClr val="tx1"/>
+                </a:solidFill>
+                <a:latin typeface="+mn-lt"/>
+                <a:ea typeface="+mn-ea"/>
+                <a:cs typeface="+mn-cs"/>
+              </a:rPr>
+              <a:t>Azure Container Apps → Resource limits, container failures </a:t>
+            </a:r>
+          </a:p>
+          <a:p>
+            <a:pPr marL="342900" lvl="1" indent="-342900">
+              <a:spcBef>
+                <a:spcPts val="1000"/>
+              </a:spcBef>
+              <a:buFont typeface="Arial" panose="020B0604020202020204" pitchFamily="34" charset="0"/>
+              <a:buChar char="•"/>
+            </a:pPr>
+            <a:r>
+              <a:rPr lang="en-US" kern="1200" dirty="0">
+                <a:solidFill>
+                  <a:schemeClr val="tx1"/>
+                </a:solidFill>
+                <a:latin typeface="+mn-lt"/>
+                <a:ea typeface="+mn-ea"/>
+                <a:cs typeface="+mn-cs"/>
+              </a:rPr>
+              <a:t>Local Docker → Worked (Intel), failed on ARM/cloud </a:t>
+            </a:r>
+          </a:p>
+          <a:p>
+            <a:r>
+              <a:rPr lang="en-US" sz="2000" b="1" kern="1200" dirty="0">
+                <a:solidFill>
+                  <a:schemeClr val="tx1"/>
+                </a:solidFill>
+                <a:latin typeface="+mn-lt"/>
+                <a:ea typeface="+mn-ea"/>
+                <a:cs typeface="+mn-cs"/>
+              </a:rPr>
+              <a:t>Key Issues:</a:t>
+            </a:r>
+            <a:r>
+              <a:rPr lang="en-US" sz="2000" kern="1200" dirty="0">
+                <a:solidFill>
+                  <a:schemeClr val="tx1"/>
+                </a:solidFill>
+                <a:latin typeface="+mn-lt"/>
+                <a:ea typeface="+mn-ea"/>
+                <a:cs typeface="+mn-cs"/>
+              </a:rPr>
+              <a:t> </a:t>
+            </a:r>
+          </a:p>
+          <a:p>
+            <a:pPr marL="342900" lvl="1" indent="-342900">
+              <a:spcBef>
+                <a:spcPts val="1000"/>
+              </a:spcBef>
+              <a:buFont typeface="Arial" panose="020B0604020202020204" pitchFamily="34" charset="0"/>
+              <a:buChar char="•"/>
+            </a:pPr>
+            <a:r>
+              <a:rPr lang="en-US" kern="1200" dirty="0">
+                <a:solidFill>
+                  <a:schemeClr val="tx1"/>
+                </a:solidFill>
+                <a:latin typeface="+mn-lt"/>
+                <a:ea typeface="+mn-ea"/>
+                <a:cs typeface="+mn-cs"/>
+              </a:rPr>
+              <a:t>MSSQL not supported in multi-container free/student tiers </a:t>
+            </a:r>
+          </a:p>
+          <a:p>
+            <a:pPr marL="342900" lvl="1" indent="-342900">
+              <a:spcBef>
+                <a:spcPts val="1000"/>
+              </a:spcBef>
+              <a:buFont typeface="Arial" panose="020B0604020202020204" pitchFamily="34" charset="0"/>
+              <a:buChar char="•"/>
+            </a:pPr>
+            <a:r>
+              <a:rPr lang="en-US" kern="1200" dirty="0">
+                <a:solidFill>
+                  <a:schemeClr val="tx1"/>
+                </a:solidFill>
+                <a:latin typeface="+mn-lt"/>
+                <a:ea typeface="+mn-ea"/>
+                <a:cs typeface="+mn-cs"/>
+              </a:rPr>
+              <a:t>Startup timing failures (</a:t>
+            </a:r>
+            <a:r>
+              <a:rPr lang="en-US" i="1" kern="1200" dirty="0">
+                <a:solidFill>
+                  <a:schemeClr val="tx1"/>
+                </a:solidFill>
+                <a:latin typeface="+mn-lt"/>
+                <a:ea typeface="+mn-ea"/>
+                <a:cs typeface="+mn-cs"/>
+              </a:rPr>
+              <a:t>“SQL Server never became ready”</a:t>
+            </a:r>
+            <a:r>
+              <a:rPr lang="en-US" kern="1200" dirty="0">
+                <a:solidFill>
+                  <a:schemeClr val="tx1"/>
+                </a:solidFill>
+                <a:latin typeface="+mn-lt"/>
+                <a:ea typeface="+mn-ea"/>
+                <a:cs typeface="+mn-cs"/>
+              </a:rPr>
+              <a:t>) </a:t>
+            </a:r>
+          </a:p>
+          <a:p>
+            <a:pPr marL="342900" lvl="1" indent="-342900">
+              <a:spcBef>
+                <a:spcPts val="1000"/>
+              </a:spcBef>
+              <a:buFont typeface="Arial" panose="020B0604020202020204" pitchFamily="34" charset="0"/>
+              <a:buChar char="•"/>
+            </a:pPr>
+            <a:r>
+              <a:rPr lang="en-US" kern="1200" dirty="0">
+                <a:solidFill>
+                  <a:schemeClr val="tx1"/>
+                </a:solidFill>
+                <a:latin typeface="+mn-lt"/>
+                <a:ea typeface="+mn-ea"/>
+                <a:cs typeface="+mn-cs"/>
+              </a:rPr>
+              <a:t>Architecture conflicts (amd64 vs arm64) </a:t>
+            </a:r>
+          </a:p>
+          <a:p>
+            <a:pPr marL="342900" lvl="1" indent="-342900">
+              <a:spcBef>
+                <a:spcPts val="1000"/>
+              </a:spcBef>
+              <a:buFont typeface="Arial" panose="020B0604020202020204" pitchFamily="34" charset="0"/>
+              <a:buChar char="•"/>
+            </a:pPr>
+            <a:r>
+              <a:rPr lang="en-US" kern="1200" dirty="0">
+                <a:solidFill>
+                  <a:schemeClr val="tx1"/>
+                </a:solidFill>
+                <a:latin typeface="+mn-lt"/>
+                <a:ea typeface="+mn-ea"/>
+                <a:cs typeface="+mn-cs"/>
+              </a:rPr>
+              <a:t>Environment variables unusable without DB container </a:t>
+            </a:r>
+          </a:p>
+          <a:p>
+            <a:r>
+              <a:rPr lang="en-US" sz="2000" b="1" kern="1200" dirty="0">
+                <a:solidFill>
+                  <a:schemeClr val="tx1"/>
+                </a:solidFill>
+                <a:latin typeface="+mn-lt"/>
+                <a:ea typeface="+mn-ea"/>
+                <a:cs typeface="+mn-cs"/>
+              </a:rPr>
+              <a:t>Constraints:</a:t>
+            </a:r>
+            <a:r>
+              <a:rPr lang="en-US" sz="2000" kern="1200" dirty="0">
+                <a:solidFill>
+                  <a:schemeClr val="tx1"/>
+                </a:solidFill>
+                <a:latin typeface="+mn-lt"/>
+                <a:ea typeface="+mn-ea"/>
+                <a:cs typeface="+mn-cs"/>
+              </a:rPr>
+              <a:t> </a:t>
+            </a:r>
+          </a:p>
+          <a:p>
+            <a:pPr marL="0" lvl="1">
+              <a:spcBef>
+                <a:spcPts val="1000"/>
+              </a:spcBef>
+            </a:pPr>
+            <a:r>
+              <a:rPr lang="en-US" kern="1200" dirty="0">
+                <a:solidFill>
+                  <a:schemeClr val="tx1"/>
+                </a:solidFill>
+                <a:latin typeface="+mn-lt"/>
+                <a:ea typeface="+mn-ea"/>
+                <a:cs typeface="+mn-cs"/>
+              </a:rPr>
+              <a:t>Cannot change MSSQL schema (SQL Server–dependent project) </a:t>
+            </a:r>
+          </a:p>
+          <a:p>
+            <a:r>
+              <a:rPr lang="en-US" sz="2000" b="1" kern="1200" dirty="0">
+                <a:solidFill>
+                  <a:schemeClr val="tx1"/>
+                </a:solidFill>
+                <a:latin typeface="+mn-lt"/>
+                <a:ea typeface="+mn-ea"/>
+                <a:cs typeface="+mn-cs"/>
+              </a:rPr>
+              <a:t>Conclusion:</a:t>
+            </a:r>
+            <a:r>
+              <a:rPr lang="en-US" sz="2000" kern="1200" dirty="0">
+                <a:solidFill>
+                  <a:schemeClr val="tx1"/>
+                </a:solidFill>
+                <a:latin typeface="+mn-lt"/>
+                <a:ea typeface="+mn-ea"/>
+                <a:cs typeface="+mn-cs"/>
+              </a:rPr>
+              <a:t> </a:t>
+            </a:r>
+          </a:p>
+          <a:p>
+            <a:pPr marL="0" lvl="1">
+              <a:spcBef>
+                <a:spcPts val="1000"/>
+              </a:spcBef>
+            </a:pPr>
+            <a:r>
+              <a:rPr lang="en-US" kern="1200" dirty="0">
+                <a:solidFill>
+                  <a:schemeClr val="tx1"/>
+                </a:solidFill>
+                <a:latin typeface="+mn-lt"/>
+                <a:ea typeface="+mn-ea"/>
+                <a:cs typeface="+mn-cs"/>
+              </a:rPr>
+              <a:t>PaaS platforms not viable for this architecture </a:t>
+            </a:r>
+          </a:p>
+          <a:p>
+            <a:pPr marL="0" lvl="1">
+              <a:spcBef>
+                <a:spcPts val="1000"/>
+              </a:spcBef>
+            </a:pPr>
+            <a:r>
+              <a:rPr lang="en-US" b="1" kern="1200" dirty="0">
+                <a:solidFill>
+                  <a:schemeClr val="tx1"/>
+                </a:solidFill>
+                <a:latin typeface="+mn-lt"/>
+                <a:ea typeface="+mn-ea"/>
+                <a:cs typeface="+mn-cs"/>
+              </a:rPr>
+              <a:t>Best Solution:</a:t>
+            </a:r>
+            <a:r>
+              <a:rPr lang="en-US" kern="1200" dirty="0">
+                <a:solidFill>
+                  <a:schemeClr val="tx1"/>
+                </a:solidFill>
+                <a:latin typeface="+mn-lt"/>
+                <a:ea typeface="+mn-ea"/>
+                <a:cs typeface="+mn-cs"/>
+              </a:rPr>
+              <a:t> VPS deployment or Azure SQL + Render</a:t>
+            </a:r>
+          </a:p>
+          <a:p>
+            <a:endParaRPr lang="en-US" sz="600" kern="1200" dirty="0">
+              <a:solidFill>
+                <a:schemeClr val="tx1"/>
+              </a:solidFill>
+              <a:latin typeface="+mn-lt"/>
+              <a:ea typeface="+mn-ea"/>
+              <a:cs typeface="+mn-cs"/>
+            </a:endParaRPr>
+          </a:p>
+        </p:txBody>
+      </p:sp>
+      <p:sp>
+        <p:nvSpPr>
+          <p:cNvPr id="10" name="Freeform: Shape 9">
+            <a:extLst>
+              <a:ext uri="{FF2B5EF4-FFF2-40B4-BE49-F238E27FC236}">
+                <a16:creationId xmlns:a16="http://schemas.microsoft.com/office/drawing/2014/main" id="{755E9CD0-04B0-4A3C-B291-AD913379C713}"/>
+              </a:ext>
+              <a:ext uri="{C183D7F6-B498-43B3-948B-1728B52AA6E4}">
+                <adec:decorative xmlns:adec="http://schemas.microsoft.com/office/drawing/2017/decorative" val="1"/>
+              </a:ext>
+            </a:extLst>
+          </p:cNvPr>
+          <p:cNvSpPr>
+            <a:spLocks noGrp="1" noRot="1" noChangeAspect="1" noMove="1" noResize="1" noEditPoints="1" noAdjustHandles="1" noChangeArrowheads="1" noChangeShapeType="1" noTextEdit="1"/>
+          </p:cNvSpPr>
+          <p:nvPr>
+            <p:extLst>
+              <p:ext uri="{386F3935-93C4-4BCD-93E2-E3B085C9AB24}">
+                <p16:designElem xmlns:p16="http://schemas.microsoft.com/office/powerpoint/2015/main" val="1"/>
+              </p:ext>
+            </p:extLst>
+          </p:nvPr>
+        </p:nvSpPr>
+        <p:spPr>
+          <a:xfrm>
+            <a:off x="10208695" y="1"/>
+            <a:ext cx="1135066" cy="477997"/>
+          </a:xfrm>
+          <a:custGeom>
+            <a:avLst/>
+            <a:gdLst>
+              <a:gd name="connsiteX0" fmla="*/ 0 w 1135066"/>
+              <a:gd name="connsiteY0" fmla="*/ 0 h 477997"/>
+              <a:gd name="connsiteX1" fmla="*/ 1135066 w 1135066"/>
+              <a:gd name="connsiteY1" fmla="*/ 0 h 477997"/>
+              <a:gd name="connsiteX2" fmla="*/ 1133370 w 1135066"/>
+              <a:gd name="connsiteY2" fmla="*/ 16827 h 477997"/>
+              <a:gd name="connsiteX3" fmla="*/ 567533 w 1135066"/>
+              <a:gd name="connsiteY3" fmla="*/ 477997 h 477997"/>
+              <a:gd name="connsiteX4" fmla="*/ 1696 w 1135066"/>
+              <a:gd name="connsiteY4" fmla="*/ 16827 h 477997"/>
+            </a:gdLst>
+            <a:ahLst/>
+            <a:cxnLst>
+              <a:cxn ang="0">
+                <a:pos x="connsiteX0" y="connsiteY0"/>
+              </a:cxn>
+              <a:cxn ang="0">
+                <a:pos x="connsiteX1" y="connsiteY1"/>
+              </a:cxn>
+              <a:cxn ang="0">
+                <a:pos x="connsiteX2" y="connsiteY2"/>
+              </a:cxn>
+              <a:cxn ang="0">
+                <a:pos x="connsiteX3" y="connsiteY3"/>
+              </a:cxn>
+              <a:cxn ang="0">
+                <a:pos x="connsiteX4" y="connsiteY4"/>
+              </a:cxn>
+            </a:cxnLst>
+            <a:rect l="l" t="t" r="r" b="b"/>
+            <a:pathLst>
+              <a:path w="1135066" h="477997">
+                <a:moveTo>
+                  <a:pt x="0" y="0"/>
+                </a:moveTo>
+                <a:lnTo>
+                  <a:pt x="1135066" y="0"/>
+                </a:lnTo>
+                <a:lnTo>
+                  <a:pt x="1133370" y="16827"/>
+                </a:lnTo>
+                <a:cubicBezTo>
+                  <a:pt x="1079514" y="280016"/>
+                  <a:pt x="846644" y="477997"/>
+                  <a:pt x="567533" y="477997"/>
+                </a:cubicBezTo>
+                <a:cubicBezTo>
+                  <a:pt x="288422" y="477997"/>
+                  <a:pt x="55552" y="280016"/>
+                  <a:pt x="1696" y="16827"/>
+                </a:cubicBezTo>
+                <a:close/>
+              </a:path>
+            </a:pathLst>
+          </a:custGeom>
+          <a:solidFill>
+            <a:schemeClr val="accent5"/>
+          </a:solidFill>
+          <a:ln>
+            <a:noFill/>
+          </a:ln>
+        </p:spPr>
+        <p:style>
+          <a:lnRef idx="2">
+            <a:schemeClr val="accent1">
+              <a:shade val="50000"/>
+            </a:schemeClr>
+          </a:lnRef>
+          <a:fillRef idx="1">
+            <a:schemeClr val="accent1"/>
+          </a:fillRef>
+          <a:effectRef idx="0">
+            <a:schemeClr val="accent1"/>
+          </a:effectRef>
+          <a:fontRef idx="minor">
+            <a:schemeClr val="lt1"/>
+          </a:fontRef>
+        </p:style>
+        <p:txBody>
+          <a:bodyPr wrap="square" rtlCol="0" anchor="ctr">
+            <a:noAutofit/>
+          </a:bodyPr>
+          <a:lstStyle/>
+          <a:p>
+            <a:pPr algn="ctr"/>
+            <a:endParaRPr lang="en-US"/>
+          </a:p>
+        </p:txBody>
+      </p:sp>
+      <p:sp>
+        <p:nvSpPr>
+          <p:cNvPr id="12" name="Oval 11">
+            <a:extLst>
+              <a:ext uri="{FF2B5EF4-FFF2-40B4-BE49-F238E27FC236}">
+                <a16:creationId xmlns:a16="http://schemas.microsoft.com/office/drawing/2014/main" id="{1DD8BF3B-6066-418C-8D1A-75C5E396FC04}"/>
+              </a:ext>
+              <a:ext uri="{C183D7F6-B498-43B3-948B-1728B52AA6E4}">
+                <adec:decorative xmlns:adec="http://schemas.microsoft.com/office/drawing/2017/decorative" val="1"/>
+              </a:ext>
+            </a:extLst>
+          </p:cNvPr>
+          <p:cNvSpPr>
+            <a:spLocks noGrp="1" noRot="1" noChangeAspect="1" noMove="1" noResize="1" noEditPoints="1" noAdjustHandles="1" noChangeArrowheads="1" noChangeShapeType="1" noTextEdit="1"/>
+          </p:cNvSpPr>
+          <p:nvPr>
+            <p:extLst>
+              <p:ext uri="{386F3935-93C4-4BCD-93E2-E3B085C9AB24}">
+                <p16:designElem xmlns:p16="http://schemas.microsoft.com/office/powerpoint/2015/main" val="1"/>
+              </p:ext>
+            </p:extLst>
+          </p:nvPr>
+        </p:nvSpPr>
+        <p:spPr>
+          <a:xfrm>
+            <a:off x="6821310" y="2624479"/>
+            <a:ext cx="812427" cy="812427"/>
+          </a:xfrm>
+          <a:prstGeom prst="ellipse">
+            <a:avLst/>
+          </a:prstGeom>
+          <a:noFill/>
+          <a:ln w="127000">
+            <a:solidFill>
+              <a:schemeClr val="accent5"/>
+            </a:solidFill>
+          </a:ln>
+        </p:spPr>
+        <p:style>
+          <a:lnRef idx="2">
+            <a:schemeClr val="accent1">
+              <a:shade val="50000"/>
+            </a:schemeClr>
+          </a:lnRef>
+          <a:fillRef idx="1">
+            <a:schemeClr val="accent1"/>
+          </a:fillRef>
+          <a:effectRef idx="0">
+            <a:schemeClr val="accent1"/>
+          </a:effectRef>
+          <a:fontRef idx="minor">
+            <a:schemeClr val="lt1"/>
+          </a:fontRef>
+        </p:style>
+        <p:txBody>
+          <a:bodyPr rtlCol="0" anchor="ctr"/>
+          <a:lstStyle/>
+          <a:p>
+            <a:pPr algn="ctr"/>
+            <a:endParaRPr lang="en-US" dirty="0"/>
+          </a:p>
+        </p:txBody>
+      </p:sp>
+      <p:sp>
+        <p:nvSpPr>
+          <p:cNvPr id="14" name="Block Arc 13">
+            <a:extLst>
+              <a:ext uri="{FF2B5EF4-FFF2-40B4-BE49-F238E27FC236}">
+                <a16:creationId xmlns:a16="http://schemas.microsoft.com/office/drawing/2014/main" id="{80BC66F9-7A74-4286-AD22-1174052CC22C}"/>
+              </a:ext>
+              <a:ext uri="{C183D7F6-B498-43B3-948B-1728B52AA6E4}">
+                <adec:decorative xmlns:adec="http://schemas.microsoft.com/office/drawing/2017/decorative" val="1"/>
+              </a:ext>
+            </a:extLst>
+          </p:cNvPr>
+          <p:cNvSpPr>
+            <a:spLocks noGrp="1" noRot="1" noChangeAspect="1" noMove="1" noResize="1" noEditPoints="1" noAdjustHandles="1" noChangeArrowheads="1" noChangeShapeType="1" noTextEdit="1"/>
+          </p:cNvSpPr>
+          <p:nvPr>
+            <p:extLst>
+              <p:ext uri="{386F3935-93C4-4BCD-93E2-E3B085C9AB24}">
+                <p16:designElem xmlns:p16="http://schemas.microsoft.com/office/powerpoint/2015/main" val="1"/>
+              </p:ext>
+            </p:extLst>
+          </p:nvPr>
+        </p:nvSpPr>
+        <p:spPr>
+          <a:xfrm rot="16200000">
+            <a:off x="8912417" y="1202394"/>
+            <a:ext cx="2387600" cy="2387600"/>
+          </a:xfrm>
+          <a:prstGeom prst="blockArc">
+            <a:avLst/>
+          </a:prstGeom>
+          <a:solidFill>
+            <a:schemeClr val="accent2"/>
+          </a:solidFill>
+          <a:ln>
+            <a:noFill/>
+          </a:ln>
+        </p:spPr>
+        <p:style>
+          <a:lnRef idx="2">
+            <a:schemeClr val="accent1">
+              <a:shade val="50000"/>
+            </a:schemeClr>
+          </a:lnRef>
+          <a:fillRef idx="1">
+            <a:schemeClr val="accent1"/>
+          </a:fillRef>
+          <a:effectRef idx="0">
+            <a:schemeClr val="accent1"/>
+          </a:effectRef>
+          <a:fontRef idx="minor">
+            <a:schemeClr val="lt1"/>
+          </a:fontRef>
+        </p:style>
+        <p:txBody>
+          <a:bodyPr rtlCol="0" anchor="ctr"/>
+          <a:lstStyle/>
+          <a:p>
+            <a:pPr algn="ctr"/>
+            <a:endParaRPr lang="en-US">
+              <a:solidFill>
+                <a:schemeClr val="tx1"/>
+              </a:solidFill>
+            </a:endParaRPr>
+          </a:p>
+        </p:txBody>
+      </p:sp>
+      <p:sp>
+        <p:nvSpPr>
+          <p:cNvPr id="16" name="Freeform: Shape 15">
+            <a:extLst>
+              <a:ext uri="{FF2B5EF4-FFF2-40B4-BE49-F238E27FC236}">
+                <a16:creationId xmlns:a16="http://schemas.microsoft.com/office/drawing/2014/main" id="{D8142CC3-2B5C-48E6-9DF0-6C8ACBAF23EF}"/>
+              </a:ext>
+              <a:ext uri="{C183D7F6-B498-43B3-948B-1728B52AA6E4}">
+                <adec:decorative xmlns:adec="http://schemas.microsoft.com/office/drawing/2017/decorative" val="1"/>
+              </a:ext>
+            </a:extLst>
+          </p:cNvPr>
+          <p:cNvSpPr>
+            <a:spLocks noGrp="1" noRot="1" noChangeAspect="1" noMove="1" noResize="1" noEditPoints="1" noAdjustHandles="1" noChangeArrowheads="1" noChangeShapeType="1" noTextEdit="1"/>
+          </p:cNvSpPr>
+          <p:nvPr>
+            <p:extLst>
+              <p:ext uri="{386F3935-93C4-4BCD-93E2-E3B085C9AB24}">
+                <p16:designElem xmlns:p16="http://schemas.microsoft.com/office/powerpoint/2015/main" val="1"/>
+              </p:ext>
+            </p:extLst>
+          </p:nvPr>
+        </p:nvSpPr>
+        <p:spPr>
+          <a:xfrm>
+            <a:off x="6821310" y="0"/>
+            <a:ext cx="2315251" cy="1550992"/>
+          </a:xfrm>
+          <a:custGeom>
+            <a:avLst/>
+            <a:gdLst>
+              <a:gd name="connsiteX0" fmla="*/ 0 w 2315251"/>
+              <a:gd name="connsiteY0" fmla="*/ 0 h 1550992"/>
+              <a:gd name="connsiteX1" fmla="*/ 138700 w 2315251"/>
+              <a:gd name="connsiteY1" fmla="*/ 0 h 1550992"/>
+              <a:gd name="connsiteX2" fmla="*/ 138700 w 2315251"/>
+              <a:gd name="connsiteY2" fmla="*/ 1361400 h 1550992"/>
+              <a:gd name="connsiteX3" fmla="*/ 2107387 w 2315251"/>
+              <a:gd name="connsiteY3" fmla="*/ 222673 h 1550992"/>
+              <a:gd name="connsiteX4" fmla="*/ 1722420 w 2315251"/>
+              <a:gd name="connsiteY4" fmla="*/ 0 h 1550992"/>
+              <a:gd name="connsiteX5" fmla="*/ 1999436 w 2315251"/>
+              <a:gd name="connsiteY5" fmla="*/ 0 h 1550992"/>
+              <a:gd name="connsiteX6" fmla="*/ 2280549 w 2315251"/>
+              <a:gd name="connsiteY6" fmla="*/ 162605 h 1550992"/>
+              <a:gd name="connsiteX7" fmla="*/ 2305953 w 2315251"/>
+              <a:gd name="connsiteY7" fmla="*/ 257336 h 1550992"/>
+              <a:gd name="connsiteX8" fmla="*/ 2280549 w 2315251"/>
+              <a:gd name="connsiteY8" fmla="*/ 282740 h 1550992"/>
+              <a:gd name="connsiteX9" fmla="*/ 104026 w 2315251"/>
+              <a:gd name="connsiteY9" fmla="*/ 1541710 h 1550992"/>
+              <a:gd name="connsiteX10" fmla="*/ 69351 w 2315251"/>
+              <a:gd name="connsiteY10" fmla="*/ 1550992 h 1550992"/>
+              <a:gd name="connsiteX11" fmla="*/ 0 w 2315251"/>
+              <a:gd name="connsiteY11" fmla="*/ 1481643 h 1550992"/>
+            </a:gdLst>
+            <a:ahLst/>
+            <a:cxnLst>
+              <a:cxn ang="0">
+                <a:pos x="connsiteX0" y="connsiteY0"/>
+              </a:cxn>
+              <a:cxn ang="0">
+                <a:pos x="connsiteX1" y="connsiteY1"/>
+              </a:cxn>
+              <a:cxn ang="0">
+                <a:pos x="connsiteX2" y="connsiteY2"/>
+              </a:cxn>
+              <a:cxn ang="0">
+                <a:pos x="connsiteX3" y="connsiteY3"/>
+              </a:cxn>
+              <a:cxn ang="0">
+                <a:pos x="connsiteX4" y="connsiteY4"/>
+              </a:cxn>
+              <a:cxn ang="0">
+                <a:pos x="connsiteX5" y="connsiteY5"/>
+              </a:cxn>
+              <a:cxn ang="0">
+                <a:pos x="connsiteX6" y="connsiteY6"/>
+              </a:cxn>
+              <a:cxn ang="0">
+                <a:pos x="connsiteX7" y="connsiteY7"/>
+              </a:cxn>
+              <a:cxn ang="0">
+                <a:pos x="connsiteX8" y="connsiteY8"/>
+              </a:cxn>
+              <a:cxn ang="0">
+                <a:pos x="connsiteX9" y="connsiteY9"/>
+              </a:cxn>
+              <a:cxn ang="0">
+                <a:pos x="connsiteX10" y="connsiteY10"/>
+              </a:cxn>
+              <a:cxn ang="0">
+                <a:pos x="connsiteX11" y="connsiteY11"/>
+              </a:cxn>
+            </a:cxnLst>
+            <a:rect l="l" t="t" r="r" b="b"/>
+            <a:pathLst>
+              <a:path w="2315251" h="1550992">
+                <a:moveTo>
+                  <a:pt x="0" y="0"/>
+                </a:moveTo>
+                <a:lnTo>
+                  <a:pt x="138700" y="0"/>
+                </a:lnTo>
+                <a:lnTo>
+                  <a:pt x="138700" y="1361400"/>
+                </a:lnTo>
+                <a:lnTo>
+                  <a:pt x="2107387" y="222673"/>
+                </a:lnTo>
+                <a:lnTo>
+                  <a:pt x="1722420" y="0"/>
+                </a:lnTo>
+                <a:lnTo>
+                  <a:pt x="1999436" y="0"/>
+                </a:lnTo>
+                <a:lnTo>
+                  <a:pt x="2280549" y="162605"/>
+                </a:lnTo>
+                <a:cubicBezTo>
+                  <a:pt x="2313720" y="181745"/>
+                  <a:pt x="2325104" y="224155"/>
+                  <a:pt x="2305953" y="257336"/>
+                </a:cubicBezTo>
+                <a:cubicBezTo>
+                  <a:pt x="2299872" y="267889"/>
+                  <a:pt x="2291101" y="276648"/>
+                  <a:pt x="2280549" y="282740"/>
+                </a:cubicBezTo>
+                <a:lnTo>
+                  <a:pt x="104026" y="1541710"/>
+                </a:lnTo>
+                <a:cubicBezTo>
+                  <a:pt x="93484" y="1547802"/>
+                  <a:pt x="81523" y="1551003"/>
+                  <a:pt x="69351" y="1550992"/>
+                </a:cubicBezTo>
+                <a:cubicBezTo>
+                  <a:pt x="31049" y="1550992"/>
+                  <a:pt x="0" y="1519944"/>
+                  <a:pt x="0" y="1481643"/>
+                </a:cubicBezTo>
+                <a:close/>
+              </a:path>
+            </a:pathLst>
+          </a:custGeom>
+          <a:solidFill>
+            <a:schemeClr val="accent6"/>
+          </a:solidFill>
+          <a:ln w="9525" cap="flat">
+            <a:noFill/>
+            <a:prstDash val="solid"/>
+            <a:miter/>
+          </a:ln>
+        </p:spPr>
+        <p:txBody>
+          <a:bodyPr rtlCol="0" anchor="ctr"/>
+          <a:lstStyle/>
+          <a:p>
+            <a:endParaRPr lang="en-US" dirty="0"/>
+          </a:p>
+        </p:txBody>
+      </p:sp>
+      <p:cxnSp>
+        <p:nvCxnSpPr>
+          <p:cNvPr id="18" name="Straight Connector 17">
+            <a:extLst>
+              <a:ext uri="{FF2B5EF4-FFF2-40B4-BE49-F238E27FC236}">
+                <a16:creationId xmlns:a16="http://schemas.microsoft.com/office/drawing/2014/main" id="{7B2D303B-3DD0-4319-9EAD-361847FEC71D}"/>
+              </a:ext>
+              <a:ext uri="{C183D7F6-B498-43B3-948B-1728B52AA6E4}">
+                <adec:decorative xmlns:adec="http://schemas.microsoft.com/office/drawing/2017/decorative" val="1"/>
+              </a:ext>
+            </a:extLst>
+          </p:cNvPr>
+          <p:cNvCxnSpPr>
+            <a:cxnSpLocks noGrp="1" noRot="1" noChangeAspect="1" noMove="1" noResize="1" noEditPoints="1" noAdjustHandles="1" noChangeArrowheads="1" noChangeShapeType="1"/>
+          </p:cNvCxnSpPr>
+          <p:nvPr>
+            <p:extLst>
+              <p:ext uri="{386F3935-93C4-4BCD-93E2-E3B085C9AB24}">
+                <p16:designElem xmlns:p16="http://schemas.microsoft.com/office/powerpoint/2015/main" val="1"/>
+              </p:ext>
+            </p:extLst>
+          </p:nvPr>
+        </p:nvCxnSpPr>
+        <p:spPr>
+          <a:xfrm>
+            <a:off x="11724638" y="1331572"/>
+            <a:ext cx="0" cy="1597708"/>
+          </a:xfrm>
+          <a:prstGeom prst="line">
+            <a:avLst/>
+          </a:prstGeom>
+          <a:ln w="127000" cap="rnd">
+            <a:solidFill>
+              <a:schemeClr val="accent4"/>
+            </a:solidFill>
+            <a:prstDash val="dash"/>
+          </a:ln>
+        </p:spPr>
+        <p:style>
+          <a:lnRef idx="1">
+            <a:schemeClr val="accent1"/>
+          </a:lnRef>
+          <a:fillRef idx="0">
+            <a:schemeClr val="accent1"/>
+          </a:fillRef>
+          <a:effectRef idx="0">
+            <a:schemeClr val="accent1"/>
+          </a:effectRef>
+          <a:fontRef idx="minor">
+            <a:schemeClr val="tx1"/>
+          </a:fontRef>
+        </p:style>
+      </p:cxnSp>
+      <p:sp>
+        <p:nvSpPr>
+          <p:cNvPr id="20" name="Freeform: Shape 19">
+            <a:extLst>
+              <a:ext uri="{FF2B5EF4-FFF2-40B4-BE49-F238E27FC236}">
+                <a16:creationId xmlns:a16="http://schemas.microsoft.com/office/drawing/2014/main" id="{46A89C79-8EF3-4AF9-B3D9-59A883F41C83}"/>
+              </a:ext>
+              <a:ext uri="{C183D7F6-B498-43B3-948B-1728B52AA6E4}">
+                <adec:decorative xmlns:adec="http://schemas.microsoft.com/office/drawing/2017/decorative" val="1"/>
+              </a:ext>
+            </a:extLst>
+          </p:cNvPr>
+          <p:cNvSpPr>
+            <a:spLocks noGrp="1" noRot="1" noChangeAspect="1" noMove="1" noResize="1" noEditPoints="1" noAdjustHandles="1" noChangeArrowheads="1" noChangeShapeType="1" noTextEdit="1"/>
+          </p:cNvSpPr>
+          <p:nvPr>
+            <p:extLst>
+              <p:ext uri="{386F3935-93C4-4BCD-93E2-E3B085C9AB24}">
+                <p16:designElem xmlns:p16="http://schemas.microsoft.com/office/powerpoint/2015/main" val="1"/>
+              </p:ext>
+            </p:extLst>
+          </p:nvPr>
+        </p:nvSpPr>
+        <p:spPr>
+          <a:xfrm>
+            <a:off x="11005550" y="4112081"/>
+            <a:ext cx="1186451" cy="1771650"/>
+          </a:xfrm>
+          <a:custGeom>
+            <a:avLst/>
+            <a:gdLst>
+              <a:gd name="connsiteX0" fmla="*/ 61913 w 1186451"/>
+              <a:gd name="connsiteY0" fmla="*/ 0 h 1771650"/>
+              <a:gd name="connsiteX1" fmla="*/ 1186451 w 1186451"/>
+              <a:gd name="connsiteY1" fmla="*/ 0 h 1771650"/>
+              <a:gd name="connsiteX2" fmla="*/ 1186451 w 1186451"/>
+              <a:gd name="connsiteY2" fmla="*/ 123825 h 1771650"/>
+              <a:gd name="connsiteX3" fmla="*/ 123825 w 1186451"/>
+              <a:gd name="connsiteY3" fmla="*/ 123825 h 1771650"/>
+              <a:gd name="connsiteX4" fmla="*/ 123825 w 1186451"/>
+              <a:gd name="connsiteY4" fmla="*/ 1647825 h 1771650"/>
+              <a:gd name="connsiteX5" fmla="*/ 1186451 w 1186451"/>
+              <a:gd name="connsiteY5" fmla="*/ 1647825 h 1771650"/>
+              <a:gd name="connsiteX6" fmla="*/ 1186451 w 1186451"/>
+              <a:gd name="connsiteY6" fmla="*/ 1771650 h 1771650"/>
+              <a:gd name="connsiteX7" fmla="*/ 61913 w 1186451"/>
+              <a:gd name="connsiteY7" fmla="*/ 1771650 h 1771650"/>
+              <a:gd name="connsiteX8" fmla="*/ 0 w 1186451"/>
+              <a:gd name="connsiteY8" fmla="*/ 1709738 h 1771650"/>
+              <a:gd name="connsiteX9" fmla="*/ 0 w 1186451"/>
+              <a:gd name="connsiteY9" fmla="*/ 61913 h 1771650"/>
+              <a:gd name="connsiteX10" fmla="*/ 61913 w 1186451"/>
+              <a:gd name="connsiteY10" fmla="*/ 0 h 1771650"/>
+            </a:gdLst>
+            <a:ahLst/>
+            <a:cxnLst>
+              <a:cxn ang="0">
+                <a:pos x="connsiteX0" y="connsiteY0"/>
+              </a:cxn>
+              <a:cxn ang="0">
+                <a:pos x="connsiteX1" y="connsiteY1"/>
+              </a:cxn>
+              <a:cxn ang="0">
+                <a:pos x="connsiteX2" y="connsiteY2"/>
+              </a:cxn>
+              <a:cxn ang="0">
+                <a:pos x="connsiteX3" y="connsiteY3"/>
+              </a:cxn>
+              <a:cxn ang="0">
+                <a:pos x="connsiteX4" y="connsiteY4"/>
+              </a:cxn>
+              <a:cxn ang="0">
+                <a:pos x="connsiteX5" y="connsiteY5"/>
+              </a:cxn>
+              <a:cxn ang="0">
+                <a:pos x="connsiteX6" y="connsiteY6"/>
+              </a:cxn>
+              <a:cxn ang="0">
+                <a:pos x="connsiteX7" y="connsiteY7"/>
+              </a:cxn>
+              <a:cxn ang="0">
+                <a:pos x="connsiteX8" y="connsiteY8"/>
+              </a:cxn>
+              <a:cxn ang="0">
+                <a:pos x="connsiteX9" y="connsiteY9"/>
+              </a:cxn>
+              <a:cxn ang="0">
+                <a:pos x="connsiteX10" y="connsiteY10"/>
+              </a:cxn>
+            </a:cxnLst>
+            <a:rect l="l" t="t" r="r" b="b"/>
+            <a:pathLst>
+              <a:path w="1186451" h="1771650">
+                <a:moveTo>
+                  <a:pt x="61913" y="0"/>
+                </a:moveTo>
+                <a:lnTo>
+                  <a:pt x="1186451" y="0"/>
+                </a:lnTo>
+                <a:lnTo>
+                  <a:pt x="1186451" y="123825"/>
+                </a:lnTo>
+                <a:lnTo>
+                  <a:pt x="123825" y="123825"/>
+                </a:lnTo>
+                <a:lnTo>
+                  <a:pt x="123825" y="1647825"/>
+                </a:lnTo>
+                <a:lnTo>
+                  <a:pt x="1186451" y="1647825"/>
+                </a:lnTo>
+                <a:lnTo>
+                  <a:pt x="1186451" y="1771650"/>
+                </a:lnTo>
+                <a:lnTo>
+                  <a:pt x="61913" y="1771650"/>
+                </a:lnTo>
+                <a:cubicBezTo>
+                  <a:pt x="27719" y="1771650"/>
+                  <a:pt x="0" y="1743932"/>
+                  <a:pt x="0" y="1709738"/>
+                </a:cubicBezTo>
+                <a:lnTo>
+                  <a:pt x="0" y="61913"/>
+                </a:lnTo>
+                <a:cubicBezTo>
+                  <a:pt x="0" y="27719"/>
+                  <a:pt x="27719" y="0"/>
+                  <a:pt x="61913" y="0"/>
+                </a:cubicBezTo>
+                <a:close/>
+              </a:path>
+            </a:pathLst>
+          </a:custGeom>
+          <a:solidFill>
+            <a:schemeClr val="accent6"/>
+          </a:solidFill>
+          <a:ln w="9525" cap="flat">
+            <a:noFill/>
+            <a:prstDash val="solid"/>
+            <a:miter/>
+          </a:ln>
+        </p:spPr>
+        <p:txBody>
+          <a:bodyPr rtlCol="0" anchor="ctr"/>
+          <a:lstStyle/>
+          <a:p>
+            <a:endParaRPr lang="en-US"/>
+          </a:p>
+        </p:txBody>
+      </p:sp>
+      <p:sp>
+        <p:nvSpPr>
+          <p:cNvPr id="22" name="Arc 21">
+            <a:extLst>
+              <a:ext uri="{FF2B5EF4-FFF2-40B4-BE49-F238E27FC236}">
+                <a16:creationId xmlns:a16="http://schemas.microsoft.com/office/drawing/2014/main" id="{EFE5CE34-4543-42E5-B82C-1F3D12422CDD}"/>
+              </a:ext>
+              <a:ext uri="{C183D7F6-B498-43B3-948B-1728B52AA6E4}">
+                <adec:decorative xmlns:adec="http://schemas.microsoft.com/office/drawing/2017/decorative" val="1"/>
+              </a:ext>
+            </a:extLst>
+          </p:cNvPr>
+          <p:cNvSpPr>
+            <a:spLocks noGrp="1" noRot="1" noChangeAspect="1" noMove="1" noResize="1" noEditPoints="1" noAdjustHandles="1" noChangeArrowheads="1" noChangeShapeType="1" noTextEdit="1"/>
+          </p:cNvSpPr>
+          <p:nvPr>
+            <p:extLst>
+              <p:ext uri="{386F3935-93C4-4BCD-93E2-E3B085C9AB24}">
+                <p16:designElem xmlns:p16="http://schemas.microsoft.com/office/powerpoint/2015/main" val="1"/>
+              </p:ext>
+            </p:extLst>
+          </p:nvPr>
+        </p:nvSpPr>
+        <p:spPr>
+          <a:xfrm rot="20992895">
+            <a:off x="6086940" y="4145122"/>
+            <a:ext cx="4083433" cy="4083433"/>
+          </a:xfrm>
+          <a:prstGeom prst="arc">
+            <a:avLst/>
+          </a:prstGeom>
+          <a:ln w="127000" cap="rnd">
+            <a:solidFill>
+              <a:schemeClr val="accent4"/>
+            </a:solidFill>
+            <a:prstDash val="dash"/>
+          </a:ln>
+        </p:spPr>
+        <p:style>
+          <a:lnRef idx="1">
+            <a:schemeClr val="accent1"/>
+          </a:lnRef>
+          <a:fillRef idx="0">
+            <a:schemeClr val="accent1"/>
+          </a:fillRef>
+          <a:effectRef idx="0">
+            <a:schemeClr val="accent1"/>
+          </a:effectRef>
+          <a:fontRef idx="minor">
+            <a:schemeClr val="tx1"/>
+          </a:fontRef>
+        </p:style>
+        <p:txBody>
+          <a:bodyPr rtlCol="0" anchor="ctr"/>
+          <a:lstStyle/>
+          <a:p>
+            <a:pPr algn="ctr"/>
+            <a:endParaRPr lang="en-US" dirty="0"/>
+          </a:p>
+        </p:txBody>
+      </p:sp>
+      <p:sp>
+        <p:nvSpPr>
+          <p:cNvPr id="24" name="Freeform: Shape 23">
+            <a:extLst>
+              <a:ext uri="{FF2B5EF4-FFF2-40B4-BE49-F238E27FC236}">
+                <a16:creationId xmlns:a16="http://schemas.microsoft.com/office/drawing/2014/main" id="{72AF41FE-63D7-4695-81D2-66D2510E4486}"/>
+              </a:ext>
+              <a:ext uri="{C183D7F6-B498-43B3-948B-1728B52AA6E4}">
+                <adec:decorative xmlns:adec="http://schemas.microsoft.com/office/drawing/2017/decorative" val="1"/>
+              </a:ext>
+            </a:extLst>
+          </p:cNvPr>
+          <p:cNvSpPr>
+            <a:spLocks noGrp="1" noRot="1" noChangeAspect="1" noMove="1" noResize="1" noEditPoints="1" noAdjustHandles="1" noChangeArrowheads="1" noChangeShapeType="1" noTextEdit="1"/>
+          </p:cNvSpPr>
+          <p:nvPr>
+            <p:extLst>
+              <p:ext uri="{386F3935-93C4-4BCD-93E2-E3B085C9AB24}">
+                <p16:designElem xmlns:p16="http://schemas.microsoft.com/office/powerpoint/2015/main" val="1"/>
+              </p:ext>
+            </p:extLst>
+          </p:nvPr>
+        </p:nvSpPr>
+        <p:spPr>
+          <a:xfrm>
+            <a:off x="6821310" y="4962670"/>
+            <a:ext cx="2643352" cy="1895331"/>
+          </a:xfrm>
+          <a:custGeom>
+            <a:avLst/>
+            <a:gdLst>
+              <a:gd name="connsiteX0" fmla="*/ 1321676 w 2643352"/>
+              <a:gd name="connsiteY0" fmla="*/ 0 h 1895331"/>
+              <a:gd name="connsiteX1" fmla="*/ 2643352 w 2643352"/>
+              <a:gd name="connsiteY1" fmla="*/ 1321676 h 1895331"/>
+              <a:gd name="connsiteX2" fmla="*/ 2539488 w 2643352"/>
+              <a:gd name="connsiteY2" fmla="*/ 1836132 h 1895331"/>
+              <a:gd name="connsiteX3" fmla="*/ 2510970 w 2643352"/>
+              <a:gd name="connsiteY3" fmla="*/ 1895331 h 1895331"/>
+              <a:gd name="connsiteX4" fmla="*/ 132382 w 2643352"/>
+              <a:gd name="connsiteY4" fmla="*/ 1895331 h 1895331"/>
+              <a:gd name="connsiteX5" fmla="*/ 103864 w 2643352"/>
+              <a:gd name="connsiteY5" fmla="*/ 1836132 h 1895331"/>
+              <a:gd name="connsiteX6" fmla="*/ 0 w 2643352"/>
+              <a:gd name="connsiteY6" fmla="*/ 1321676 h 1895331"/>
+              <a:gd name="connsiteX7" fmla="*/ 1321676 w 2643352"/>
+              <a:gd name="connsiteY7" fmla="*/ 0 h 1895331"/>
+            </a:gdLst>
+            <a:ahLst/>
+            <a:cxnLst>
+              <a:cxn ang="0">
+                <a:pos x="connsiteX0" y="connsiteY0"/>
+              </a:cxn>
+              <a:cxn ang="0">
+                <a:pos x="connsiteX1" y="connsiteY1"/>
+              </a:cxn>
+              <a:cxn ang="0">
+                <a:pos x="connsiteX2" y="connsiteY2"/>
+              </a:cxn>
+              <a:cxn ang="0">
+                <a:pos x="connsiteX3" y="connsiteY3"/>
+              </a:cxn>
+              <a:cxn ang="0">
+                <a:pos x="connsiteX4" y="connsiteY4"/>
+              </a:cxn>
+              <a:cxn ang="0">
+                <a:pos x="connsiteX5" y="connsiteY5"/>
+              </a:cxn>
+              <a:cxn ang="0">
+                <a:pos x="connsiteX6" y="connsiteY6"/>
+              </a:cxn>
+              <a:cxn ang="0">
+                <a:pos x="connsiteX7" y="connsiteY7"/>
+              </a:cxn>
+            </a:cxnLst>
+            <a:rect l="l" t="t" r="r" b="b"/>
+            <a:pathLst>
+              <a:path w="2643352" h="1895331">
+                <a:moveTo>
+                  <a:pt x="1321676" y="0"/>
+                </a:moveTo>
+                <a:cubicBezTo>
+                  <a:pt x="2051617" y="0"/>
+                  <a:pt x="2643352" y="591735"/>
+                  <a:pt x="2643352" y="1321676"/>
+                </a:cubicBezTo>
+                <a:cubicBezTo>
+                  <a:pt x="2643352" y="1504161"/>
+                  <a:pt x="2606369" y="1678009"/>
+                  <a:pt x="2539488" y="1836132"/>
+                </a:cubicBezTo>
+                <a:lnTo>
+                  <a:pt x="2510970" y="1895331"/>
+                </a:lnTo>
+                <a:lnTo>
+                  <a:pt x="132382" y="1895331"/>
+                </a:lnTo>
+                <a:lnTo>
+                  <a:pt x="103864" y="1836132"/>
+                </a:lnTo>
+                <a:cubicBezTo>
+                  <a:pt x="36984" y="1678009"/>
+                  <a:pt x="0" y="1504161"/>
+                  <a:pt x="0" y="1321676"/>
+                </a:cubicBezTo>
+                <a:cubicBezTo>
+                  <a:pt x="0" y="591735"/>
+                  <a:pt x="591735" y="0"/>
+                  <a:pt x="1321676" y="0"/>
+                </a:cubicBezTo>
+                <a:close/>
+              </a:path>
+            </a:pathLst>
+          </a:custGeom>
+          <a:solidFill>
+            <a:schemeClr val="accent2"/>
+          </a:solidFill>
+          <a:ln>
+            <a:noFill/>
+          </a:ln>
+        </p:spPr>
+        <p:style>
+          <a:lnRef idx="2">
+            <a:schemeClr val="accent1">
+              <a:shade val="50000"/>
+            </a:schemeClr>
+          </a:lnRef>
+          <a:fillRef idx="1">
+            <a:schemeClr val="accent1"/>
+          </a:fillRef>
+          <a:effectRef idx="0">
+            <a:schemeClr val="accent1"/>
+          </a:effectRef>
+          <a:fontRef idx="minor">
+            <a:schemeClr val="lt1"/>
+          </a:fontRef>
+        </p:style>
+        <p:txBody>
+          <a:bodyPr rtlCol="0" anchor="ctr"/>
+          <a:lstStyle/>
+          <a:p>
+            <a:pPr algn="ctr"/>
+            <a:endParaRPr lang="en-US"/>
+          </a:p>
+        </p:txBody>
+      </p:sp>
+    </p:spTree>
+    <p:extLst>
+      <p:ext uri="{BB962C8B-B14F-4D97-AF65-F5344CB8AC3E}">
+        <p14:creationId xmlns:p14="http://schemas.microsoft.com/office/powerpoint/2010/main" val="4265846240"/>
+      </p:ext>
+    </p:extLst>
+  </p:cSld>
+  <p:clrMapOvr>
+    <a:masterClrMapping/>
+  </p:clrMapOvr>
+</p:sld>
+</file>
+
+<file path=ppt/slides/slide6.xml><?xml version="1.0" encoding="utf-8"?>
+<p:sld xmlns:a="http://schemas.openxmlformats.org/drawingml/2006/main" xmlns:r="http://schemas.openxmlformats.org/officeDocument/2006/relationships" xmlns:p="http://schemas.openxmlformats.org/presentationml/2006/main">
+  <p:cSld>
+    <p:bg>
+      <p:bgPr>
+        <a:solidFill>
+          <a:schemeClr val="bg1"/>
+        </a:solidFill>
+        <a:effectLst/>
+      </p:bgPr>
+    </p:bg>
+    <p:spTree>
+      <p:nvGrpSpPr>
+        <p:cNvPr id="1" name=""/>
+        <p:cNvGrpSpPr/>
+        <p:nvPr/>
+      </p:nvGrpSpPr>
+      <p:grpSpPr>
+        <a:xfrm>
+          <a:off x="0" y="0"/>
+          <a:ext cx="0" cy="0"/>
+          <a:chOff x="0" y="0"/>
+          <a:chExt cx="0" cy="0"/>
+        </a:xfrm>
+      </p:grpSpPr>
+      <p:sp useBgFill="1">
+        <p:nvSpPr>
           <p:cNvPr id="5" name="Rectangle 4">
             <a:extLst>
               <a:ext uri="{FF2B5EF4-FFF2-40B4-BE49-F238E27FC236}">
@@ -12960,7 +15211,7 @@
 </p:sld>
 </file>
 
-<file path=ppt/slides/slide6.xml><?xml version="1.0" encoding="utf-8"?>
+<file path=ppt/slides/slide7.xml><?xml version="1.0" encoding="utf-8"?>
 <p:sld xmlns:a="http://schemas.openxmlformats.org/drawingml/2006/main" xmlns:r="http://schemas.openxmlformats.org/officeDocument/2006/relationships" xmlns:p="http://schemas.openxmlformats.org/presentationml/2006/main">
   <p:cSld>
     <p:bg>
@@ -13632,7 +15883,472 @@
 </p:sld>
 </file>
 
-<file path=ppt/slides/slide7.xml><?xml version="1.0" encoding="utf-8"?>
+<file path=ppt/slides/slide8.xml><?xml version="1.0" encoding="utf-8"?>
+<p:sld xmlns:a="http://schemas.openxmlformats.org/drawingml/2006/main" xmlns:r="http://schemas.openxmlformats.org/officeDocument/2006/relationships" xmlns:p="http://schemas.openxmlformats.org/presentationml/2006/main">
+  <p:cSld>
+    <p:bg>
+      <p:bgPr>
+        <a:solidFill>
+          <a:schemeClr val="bg1"/>
+        </a:solidFill>
+        <a:effectLst/>
+      </p:bgPr>
+    </p:bg>
+    <p:spTree>
+      <p:nvGrpSpPr>
+        <p:cNvPr id="1" name=""/>
+        <p:cNvGrpSpPr/>
+        <p:nvPr/>
+      </p:nvGrpSpPr>
+      <p:grpSpPr>
+        <a:xfrm>
+          <a:off x="0" y="0"/>
+          <a:ext cx="0" cy="0"/>
+          <a:chOff x="0" y="0"/>
+          <a:chExt cx="0" cy="0"/>
+        </a:xfrm>
+      </p:grpSpPr>
+      <p:sp useBgFill="1">
+        <p:nvSpPr>
+          <p:cNvPr id="14" name="Rectangle 13">
+            <a:extLst>
+              <a:ext uri="{FF2B5EF4-FFF2-40B4-BE49-F238E27FC236}">
+                <a16:creationId xmlns:a16="http://schemas.microsoft.com/office/drawing/2014/main" id="{D278ADA9-6383-4BDD-80D2-8899A402687B}"/>
+              </a:ext>
+              <a:ext uri="{C183D7F6-B498-43B3-948B-1728B52AA6E4}">
+                <adec:decorative xmlns:adec="http://schemas.microsoft.com/office/drawing/2017/decorative" val="1"/>
+              </a:ext>
+            </a:extLst>
+          </p:cNvPr>
+          <p:cNvSpPr>
+            <a:spLocks noGrp="1" noRot="1" noChangeAspect="1" noMove="1" noResize="1" noEditPoints="1" noAdjustHandles="1" noChangeArrowheads="1" noChangeShapeType="1" noTextEdit="1"/>
+          </p:cNvSpPr>
+          <p:nvPr>
+            <p:extLst>
+              <p:ext uri="{386F3935-93C4-4BCD-93E2-E3B085C9AB24}">
+                <p16:designElem xmlns:p16="http://schemas.microsoft.com/office/powerpoint/2015/main" val="1"/>
+              </p:ext>
+            </p:extLst>
+          </p:nvPr>
+        </p:nvSpPr>
+        <p:spPr>
+          <a:xfrm>
+            <a:off x="3048" y="0"/>
+            <a:ext cx="12188952" cy="6858000"/>
+          </a:xfrm>
+          <a:prstGeom prst="rect">
+            <a:avLst/>
+          </a:prstGeom>
+          <a:ln>
+            <a:noFill/>
+          </a:ln>
+        </p:spPr>
+        <p:style>
+          <a:lnRef idx="2">
+            <a:schemeClr val="accent1">
+              <a:shade val="50000"/>
+            </a:schemeClr>
+          </a:lnRef>
+          <a:fillRef idx="1">
+            <a:schemeClr val="accent1"/>
+          </a:fillRef>
+          <a:effectRef idx="0">
+            <a:schemeClr val="accent1"/>
+          </a:effectRef>
+          <a:fontRef idx="minor">
+            <a:schemeClr val="lt1"/>
+          </a:fontRef>
+        </p:style>
+        <p:txBody>
+          <a:bodyPr rtlCol="0" anchor="ctr"/>
+          <a:lstStyle/>
+          <a:p>
+            <a:pPr algn="ctr"/>
+            <a:endParaRPr lang="en-US"/>
+          </a:p>
+        </p:txBody>
+      </p:sp>
+      <p:sp>
+        <p:nvSpPr>
+          <p:cNvPr id="16" name="Rectangle 15">
+            <a:extLst>
+              <a:ext uri="{FF2B5EF4-FFF2-40B4-BE49-F238E27FC236}">
+                <a16:creationId xmlns:a16="http://schemas.microsoft.com/office/drawing/2014/main" id="{484B7147-B0F6-40ED-B5A2-FF72BC8198B6}"/>
+              </a:ext>
+              <a:ext uri="{C183D7F6-B498-43B3-948B-1728B52AA6E4}">
+                <adec:decorative xmlns:adec="http://schemas.microsoft.com/office/drawing/2017/decorative" val="1"/>
+              </a:ext>
+            </a:extLst>
+          </p:cNvPr>
+          <p:cNvSpPr>
+            <a:spLocks noGrp="1" noRot="1" noChangeAspect="1" noMove="1" noResize="1" noEditPoints="1" noAdjustHandles="1" noChangeArrowheads="1" noChangeShapeType="1" noTextEdit="1"/>
+          </p:cNvSpPr>
+          <p:nvPr>
+            <p:extLst>
+              <p:ext uri="{386F3935-93C4-4BCD-93E2-E3B085C9AB24}">
+                <p16:designElem xmlns:p16="http://schemas.microsoft.com/office/powerpoint/2015/main" val="1"/>
+              </p:ext>
+            </p:extLst>
+          </p:nvPr>
+        </p:nvSpPr>
+        <p:spPr>
+          <a:xfrm>
+            <a:off x="0" y="0"/>
+            <a:ext cx="12192000" cy="6858000"/>
+          </a:xfrm>
+          <a:prstGeom prst="rect">
+            <a:avLst/>
+          </a:prstGeom>
+          <a:solidFill>
+            <a:schemeClr val="accent2"/>
+          </a:solidFill>
+          <a:ln>
+            <a:noFill/>
+          </a:ln>
+        </p:spPr>
+        <p:style>
+          <a:lnRef idx="2">
+            <a:schemeClr val="accent1">
+              <a:shade val="50000"/>
+            </a:schemeClr>
+          </a:lnRef>
+          <a:fillRef idx="1">
+            <a:schemeClr val="accent1"/>
+          </a:fillRef>
+          <a:effectRef idx="0">
+            <a:schemeClr val="accent1"/>
+          </a:effectRef>
+          <a:fontRef idx="minor">
+            <a:schemeClr val="lt1"/>
+          </a:fontRef>
+        </p:style>
+        <p:txBody>
+          <a:bodyPr rtlCol="0" anchor="ctr"/>
+          <a:lstStyle/>
+          <a:p>
+            <a:pPr algn="ctr"/>
+            <a:endParaRPr lang="en-US">
+              <a:solidFill>
+                <a:schemeClr val="tx1"/>
+              </a:solidFill>
+            </a:endParaRPr>
+          </a:p>
+        </p:txBody>
+      </p:sp>
+      <p:sp>
+        <p:nvSpPr>
+          <p:cNvPr id="18" name="Rectangle 17">
+            <a:extLst>
+              <a:ext uri="{FF2B5EF4-FFF2-40B4-BE49-F238E27FC236}">
+                <a16:creationId xmlns:a16="http://schemas.microsoft.com/office/drawing/2014/main" id="{B36D2DE0-0628-4A9A-A59D-7BA8B5EB3022}"/>
+              </a:ext>
+              <a:ext uri="{C183D7F6-B498-43B3-948B-1728B52AA6E4}">
+                <adec:decorative xmlns:adec="http://schemas.microsoft.com/office/drawing/2017/decorative" val="1"/>
+              </a:ext>
+            </a:extLst>
+          </p:cNvPr>
+          <p:cNvSpPr>
+            <a:spLocks noGrp="1" noRot="1" noChangeAspect="1" noMove="1" noResize="1" noEditPoints="1" noAdjustHandles="1" noChangeArrowheads="1" noChangeShapeType="1" noTextEdit="1"/>
+          </p:cNvSpPr>
+          <p:nvPr>
+            <p:extLst>
+              <p:ext uri="{386F3935-93C4-4BCD-93E2-E3B085C9AB24}">
+                <p16:designElem xmlns:p16="http://schemas.microsoft.com/office/powerpoint/2015/main" val="1"/>
+              </p:ext>
+            </p:extLst>
+          </p:nvPr>
+        </p:nvSpPr>
+        <p:spPr>
+          <a:xfrm>
+            <a:off x="0" y="0"/>
+            <a:ext cx="12192000" cy="6858000"/>
+          </a:xfrm>
+          <a:prstGeom prst="rect">
+            <a:avLst/>
+          </a:prstGeom>
+          <a:noFill/>
+          <a:ln>
+            <a:noFill/>
+          </a:ln>
+        </p:spPr>
+        <p:style>
+          <a:lnRef idx="2">
+            <a:schemeClr val="accent1">
+              <a:shade val="50000"/>
+            </a:schemeClr>
+          </a:lnRef>
+          <a:fillRef idx="1">
+            <a:schemeClr val="accent1"/>
+          </a:fillRef>
+          <a:effectRef idx="0">
+            <a:schemeClr val="accent1"/>
+          </a:effectRef>
+          <a:fontRef idx="minor">
+            <a:schemeClr val="lt1"/>
+          </a:fontRef>
+        </p:style>
+        <p:txBody>
+          <a:bodyPr rtlCol="0" anchor="ctr"/>
+          <a:lstStyle/>
+          <a:p>
+            <a:pPr algn="ctr"/>
+            <a:endParaRPr lang="en-US"/>
+          </a:p>
+        </p:txBody>
+      </p:sp>
+      <p:sp>
+        <p:nvSpPr>
+          <p:cNvPr id="13" name="Oval 12">
+            <a:extLst>
+              <a:ext uri="{FF2B5EF4-FFF2-40B4-BE49-F238E27FC236}">
+                <a16:creationId xmlns:a16="http://schemas.microsoft.com/office/drawing/2014/main" id="{48E405C9-94BE-41DA-928C-DEC9A8550E9F}"/>
+              </a:ext>
+              <a:ext uri="{C183D7F6-B498-43B3-948B-1728B52AA6E4}">
+                <adec:decorative xmlns:adec="http://schemas.microsoft.com/office/drawing/2017/decorative" val="1"/>
+              </a:ext>
+            </a:extLst>
+          </p:cNvPr>
+          <p:cNvSpPr>
+            <a:spLocks noGrp="1" noRot="1" noChangeAspect="1" noMove="1" noResize="1" noEditPoints="1" noAdjustHandles="1" noChangeArrowheads="1" noChangeShapeType="1" noTextEdit="1"/>
+          </p:cNvSpPr>
+          <p:nvPr>
+            <p:extLst>
+              <p:ext uri="{386F3935-93C4-4BCD-93E2-E3B085C9AB24}">
+                <p16:designElem xmlns:p16="http://schemas.microsoft.com/office/powerpoint/2015/main" val="1"/>
+              </p:ext>
+            </p:extLst>
+          </p:nvPr>
+        </p:nvSpPr>
+        <p:spPr>
+          <a:xfrm>
+            <a:off x="2815929" y="148929"/>
+            <a:ext cx="6560142" cy="6560142"/>
+          </a:xfrm>
+          <a:prstGeom prst="ellipse">
+            <a:avLst/>
+          </a:prstGeom>
+          <a:solidFill>
+            <a:schemeClr val="bg1"/>
+          </a:solidFill>
+          <a:ln>
+            <a:noFill/>
+          </a:ln>
+        </p:spPr>
+        <p:style>
+          <a:lnRef idx="2">
+            <a:schemeClr val="accent1">
+              <a:shade val="50000"/>
+            </a:schemeClr>
+          </a:lnRef>
+          <a:fillRef idx="1">
+            <a:schemeClr val="accent1"/>
+          </a:fillRef>
+          <a:effectRef idx="0">
+            <a:schemeClr val="accent1"/>
+          </a:effectRef>
+          <a:fontRef idx="minor">
+            <a:schemeClr val="lt1"/>
+          </a:fontRef>
+        </p:style>
+        <p:txBody>
+          <a:bodyPr rtlCol="0" anchor="ctr"/>
+          <a:lstStyle/>
+          <a:p>
+            <a:pPr algn="ctr"/>
+            <a:endParaRPr lang="en-US">
+              <a:solidFill>
+                <a:schemeClr val="bg1"/>
+              </a:solidFill>
+            </a:endParaRPr>
+          </a:p>
+        </p:txBody>
+      </p:sp>
+      <p:sp>
+        <p:nvSpPr>
+          <p:cNvPr id="2" name="Title 1">
+            <a:extLst>
+              <a:ext uri="{FF2B5EF4-FFF2-40B4-BE49-F238E27FC236}">
+                <a16:creationId xmlns:a16="http://schemas.microsoft.com/office/drawing/2014/main" id="{093A71C4-DFA5-A2AF-DF66-B2209A4E3DCD}"/>
+              </a:ext>
+            </a:extLst>
+          </p:cNvPr>
+          <p:cNvSpPr>
+            <a:spLocks noGrp="1"/>
+          </p:cNvSpPr>
+          <p:nvPr>
+            <p:ph type="title"/>
+          </p:nvPr>
+        </p:nvSpPr>
+        <p:spPr>
+          <a:xfrm>
+            <a:off x="3315031" y="1380754"/>
+            <a:ext cx="5561938" cy="2513516"/>
+          </a:xfrm>
+        </p:spPr>
+        <p:txBody>
+          <a:bodyPr vert="horz" lIns="91440" tIns="45720" rIns="91440" bIns="45720" rtlCol="0" anchor="b">
+            <a:normAutofit/>
+          </a:bodyPr>
+          <a:lstStyle/>
+          <a:p>
+            <a:pPr algn="ctr"/>
+            <a:r>
+              <a:rPr lang="en-US" kern="1200">
+                <a:solidFill>
+                  <a:schemeClr val="tx1"/>
+                </a:solidFill>
+                <a:latin typeface="+mj-lt"/>
+                <a:ea typeface="+mj-ea"/>
+                <a:cs typeface="+mj-cs"/>
+              </a:rPr>
+              <a:t>Live Hosting Demo</a:t>
+            </a:r>
+          </a:p>
+        </p:txBody>
+      </p:sp>
+      <p:sp>
+        <p:nvSpPr>
+          <p:cNvPr id="15" name="Arc 14">
+            <a:extLst>
+              <a:ext uri="{FF2B5EF4-FFF2-40B4-BE49-F238E27FC236}">
+                <a16:creationId xmlns:a16="http://schemas.microsoft.com/office/drawing/2014/main" id="{D2091A72-D5BB-42AC-8FD3-F7747D90861E}"/>
+              </a:ext>
+              <a:ext uri="{C183D7F6-B498-43B3-948B-1728B52AA6E4}">
+                <adec:decorative xmlns:adec="http://schemas.microsoft.com/office/drawing/2017/decorative" val="1"/>
+              </a:ext>
+            </a:extLst>
+          </p:cNvPr>
+          <p:cNvSpPr>
+            <a:spLocks noGrp="1" noRot="1" noChangeAspect="1" noMove="1" noResize="1" noEditPoints="1" noAdjustHandles="1" noChangeArrowheads="1" noChangeShapeType="1" noTextEdit="1"/>
+          </p:cNvSpPr>
+          <p:nvPr>
+            <p:extLst>
+              <p:ext uri="{386F3935-93C4-4BCD-93E2-E3B085C9AB24}">
+                <p16:designElem xmlns:p16="http://schemas.microsoft.com/office/powerpoint/2015/main" val="1"/>
+              </p:ext>
+            </p:extLst>
+          </p:nvPr>
+        </p:nvSpPr>
+        <p:spPr>
+          <a:xfrm rot="9222429" flipV="1">
+            <a:off x="2494119" y="6170"/>
+            <a:ext cx="6816262" cy="6816262"/>
+          </a:xfrm>
+          <a:prstGeom prst="arc">
+            <a:avLst>
+              <a:gd name="adj1" fmla="val 16200000"/>
+              <a:gd name="adj2" fmla="val 20093138"/>
+            </a:avLst>
+          </a:prstGeom>
+          <a:ln w="127000" cap="rnd">
+            <a:solidFill>
+              <a:schemeClr val="accent4">
+                <a:alpha val="95000"/>
+              </a:schemeClr>
+            </a:solidFill>
+            <a:prstDash val="dash"/>
+          </a:ln>
+        </p:spPr>
+        <p:style>
+          <a:lnRef idx="1">
+            <a:schemeClr val="accent1"/>
+          </a:lnRef>
+          <a:fillRef idx="0">
+            <a:schemeClr val="accent1"/>
+          </a:fillRef>
+          <a:effectRef idx="0">
+            <a:schemeClr val="accent1"/>
+          </a:effectRef>
+          <a:fontRef idx="minor">
+            <a:schemeClr val="tx1"/>
+          </a:fontRef>
+        </p:style>
+        <p:txBody>
+          <a:bodyPr rtlCol="0" anchor="ctr"/>
+          <a:lstStyle/>
+          <a:p>
+            <a:pPr algn="ctr"/>
+            <a:endParaRPr lang="en-US" dirty="0"/>
+          </a:p>
+        </p:txBody>
+      </p:sp>
+      <p:sp>
+        <p:nvSpPr>
+          <p:cNvPr id="17" name="Oval 16">
+            <a:extLst>
+              <a:ext uri="{FF2B5EF4-FFF2-40B4-BE49-F238E27FC236}">
+                <a16:creationId xmlns:a16="http://schemas.microsoft.com/office/drawing/2014/main" id="{6ED12BFC-A737-46AF-8411-481112D54B0C}"/>
+              </a:ext>
+              <a:ext uri="{C183D7F6-B498-43B3-948B-1728B52AA6E4}">
+                <adec:decorative xmlns:adec="http://schemas.microsoft.com/office/drawing/2017/decorative" val="1"/>
+              </a:ext>
+            </a:extLst>
+          </p:cNvPr>
+          <p:cNvSpPr>
+            <a:spLocks noGrp="1" noRot="1" noChangeAspect="1" noMove="1" noResize="1" noEditPoints="1" noAdjustHandles="1" noChangeArrowheads="1" noChangeShapeType="1" noTextEdit="1"/>
+          </p:cNvSpPr>
+          <p:nvPr>
+            <p:extLst>
+              <p:ext uri="{386F3935-93C4-4BCD-93E2-E3B085C9AB24}">
+                <p16:designElem xmlns:p16="http://schemas.microsoft.com/office/powerpoint/2015/main" val="1"/>
+              </p:ext>
+            </p:extLst>
+          </p:nvPr>
+        </p:nvSpPr>
+        <p:spPr>
+          <a:xfrm>
+            <a:off x="8200995" y="5310973"/>
+            <a:ext cx="705948" cy="686798"/>
+          </a:xfrm>
+          <a:prstGeom prst="ellipse">
+            <a:avLst/>
+          </a:prstGeom>
+          <a:solidFill>
+            <a:schemeClr val="accent5"/>
+          </a:solidFill>
+          <a:ln>
+            <a:noFill/>
+          </a:ln>
+        </p:spPr>
+        <p:style>
+          <a:lnRef idx="2">
+            <a:schemeClr val="accent1">
+              <a:shade val="50000"/>
+            </a:schemeClr>
+          </a:lnRef>
+          <a:fillRef idx="1">
+            <a:schemeClr val="accent1"/>
+          </a:fillRef>
+          <a:effectRef idx="0">
+            <a:schemeClr val="accent1"/>
+          </a:effectRef>
+          <a:fontRef idx="minor">
+            <a:schemeClr val="lt1"/>
+          </a:fontRef>
+        </p:style>
+        <p:txBody>
+          <a:bodyPr rtlCol="0" anchor="ctr"/>
+          <a:lstStyle/>
+          <a:p>
+            <a:pPr algn="ctr"/>
+            <a:endParaRPr lang="en-US"/>
+          </a:p>
+        </p:txBody>
+      </p:sp>
+    </p:spTree>
+    <p:extLst>
+      <p:ext uri="{BB962C8B-B14F-4D97-AF65-F5344CB8AC3E}">
+        <p14:creationId xmlns:p14="http://schemas.microsoft.com/office/powerpoint/2010/main" val="1221735276"/>
+      </p:ext>
+    </p:extLst>
+  </p:cSld>
+  <p:clrMapOvr>
+    <a:masterClrMapping/>
+  </p:clrMapOvr>
+</p:sld>
+</file>
+
+<file path=ppt/slides/slide9.xml><?xml version="1.0" encoding="utf-8"?>
 <p:sld xmlns:a="http://schemas.openxmlformats.org/drawingml/2006/main" xmlns:r="http://schemas.openxmlformats.org/officeDocument/2006/relationships" xmlns:p="http://schemas.openxmlformats.org/presentationml/2006/main">
   <p:cSld>
     <p:bg>
@@ -13975,746 +16691,6 @@
     <p:extLst>
       <p:ext uri="{BB962C8B-B14F-4D97-AF65-F5344CB8AC3E}">
         <p14:creationId xmlns:p14="http://schemas.microsoft.com/office/powerpoint/2010/main" val="2561402868"/>
-      </p:ext>
-    </p:extLst>
-  </p:cSld>
-  <p:clrMapOvr>
-    <a:masterClrMapping/>
-  </p:clrMapOvr>
-</p:sld>
-</file>
-
-<file path=ppt/slides/slide8.xml><?xml version="1.0" encoding="utf-8"?>
-<p:sld xmlns:a="http://schemas.openxmlformats.org/drawingml/2006/main" xmlns:r="http://schemas.openxmlformats.org/officeDocument/2006/relationships" xmlns:p="http://schemas.openxmlformats.org/presentationml/2006/main">
-  <p:cSld>
-    <p:bg>
-      <p:bgPr>
-        <a:solidFill>
-          <a:schemeClr val="bg1"/>
-        </a:solidFill>
-        <a:effectLst/>
-      </p:bgPr>
-    </p:bg>
-    <p:spTree>
-      <p:nvGrpSpPr>
-        <p:cNvPr id="1" name=""/>
-        <p:cNvGrpSpPr/>
-        <p:nvPr/>
-      </p:nvGrpSpPr>
-      <p:grpSpPr>
-        <a:xfrm>
-          <a:off x="0" y="0"/>
-          <a:ext cx="0" cy="0"/>
-          <a:chOff x="0" y="0"/>
-          <a:chExt cx="0" cy="0"/>
-        </a:xfrm>
-      </p:grpSpPr>
-      <p:sp useBgFill="1">
-        <p:nvSpPr>
-          <p:cNvPr id="28" name="Rectangle 27">
-            <a:extLst>
-              <a:ext uri="{FF2B5EF4-FFF2-40B4-BE49-F238E27FC236}">
-                <a16:creationId xmlns:a16="http://schemas.microsoft.com/office/drawing/2014/main" id="{C1A1C5D3-C053-4EE9-BE1A-419B6E27CCAE}"/>
-              </a:ext>
-              <a:ext uri="{C183D7F6-B498-43B3-948B-1728B52AA6E4}">
-                <adec:decorative xmlns:adec="http://schemas.microsoft.com/office/drawing/2017/decorative" val="1"/>
-              </a:ext>
-            </a:extLst>
-          </p:cNvPr>
-          <p:cNvSpPr>
-            <a:spLocks noGrp="1" noRot="1" noChangeAspect="1" noMove="1" noResize="1" noEditPoints="1" noAdjustHandles="1" noChangeArrowheads="1" noChangeShapeType="1" noTextEdit="1"/>
-          </p:cNvSpPr>
-          <p:nvPr>
-            <p:extLst>
-              <p:ext uri="{386F3935-93C4-4BCD-93E2-E3B085C9AB24}">
-                <p16:designElem xmlns:p16="http://schemas.microsoft.com/office/powerpoint/2015/main" val="1"/>
-              </p:ext>
-            </p:extLst>
-          </p:nvPr>
-        </p:nvSpPr>
-        <p:spPr>
-          <a:xfrm>
-            <a:off x="0" y="0"/>
-            <a:ext cx="12192000" cy="6858000"/>
-          </a:xfrm>
-          <a:prstGeom prst="rect">
-            <a:avLst/>
-          </a:prstGeom>
-          <a:ln>
-            <a:noFill/>
-          </a:ln>
-        </p:spPr>
-        <p:style>
-          <a:lnRef idx="2">
-            <a:schemeClr val="accent1">
-              <a:shade val="50000"/>
-            </a:schemeClr>
-          </a:lnRef>
-          <a:fillRef idx="1">
-            <a:schemeClr val="accent1"/>
-          </a:fillRef>
-          <a:effectRef idx="0">
-            <a:schemeClr val="accent1"/>
-          </a:effectRef>
-          <a:fontRef idx="minor">
-            <a:schemeClr val="lt1"/>
-          </a:fontRef>
-        </p:style>
-        <p:txBody>
-          <a:bodyPr rtlCol="0" anchor="ctr"/>
-          <a:lstStyle/>
-          <a:p>
-            <a:pPr algn="ctr"/>
-            <a:endParaRPr lang="en-US"/>
-          </a:p>
-        </p:txBody>
-      </p:sp>
-      <p:sp useBgFill="1">
-        <p:nvSpPr>
-          <p:cNvPr id="30" name="Rectangle 29">
-            <a:extLst>
-              <a:ext uri="{FF2B5EF4-FFF2-40B4-BE49-F238E27FC236}">
-                <a16:creationId xmlns:a16="http://schemas.microsoft.com/office/drawing/2014/main" id="{A3473CF9-37EB-43E7-89EF-D2D1C53D1DAC}"/>
-              </a:ext>
-              <a:ext uri="{C183D7F6-B498-43B3-948B-1728B52AA6E4}">
-                <adec:decorative xmlns:adec="http://schemas.microsoft.com/office/drawing/2017/decorative" val="1"/>
-              </a:ext>
-            </a:extLst>
-          </p:cNvPr>
-          <p:cNvSpPr>
-            <a:spLocks noGrp="1" noRot="1" noChangeAspect="1" noMove="1" noResize="1" noEditPoints="1" noAdjustHandles="1" noChangeArrowheads="1" noChangeShapeType="1" noTextEdit="1"/>
-          </p:cNvSpPr>
-          <p:nvPr>
-            <p:extLst>
-              <p:ext uri="{386F3935-93C4-4BCD-93E2-E3B085C9AB24}">
-                <p16:designElem xmlns:p16="http://schemas.microsoft.com/office/powerpoint/2015/main" val="1"/>
-              </p:ext>
-            </p:extLst>
-          </p:nvPr>
-        </p:nvSpPr>
-        <p:spPr>
-          <a:xfrm>
-            <a:off x="1903615" y="221673"/>
-            <a:ext cx="8384770" cy="1332634"/>
-          </a:xfrm>
-          <a:prstGeom prst="rect">
-            <a:avLst/>
-          </a:prstGeom>
-          <a:ln w="12700">
-            <a:solidFill>
-              <a:srgbClr val="E1E1E1"/>
-            </a:solidFill>
-          </a:ln>
-          <a:effectLst>
-            <a:outerShdw blurRad="50800" dist="38100" dir="2700000" algn="tl" rotWithShape="0">
-              <a:schemeClr val="bg2">
-                <a:lumMod val="85000"/>
-                <a:alpha val="50000"/>
-              </a:schemeClr>
-            </a:outerShdw>
-          </a:effectLst>
-        </p:spPr>
-        <p:style>
-          <a:lnRef idx="2">
-            <a:schemeClr val="accent1">
-              <a:shade val="50000"/>
-            </a:schemeClr>
-          </a:lnRef>
-          <a:fillRef idx="1">
-            <a:schemeClr val="accent1"/>
-          </a:fillRef>
-          <a:effectRef idx="0">
-            <a:schemeClr val="accent1"/>
-          </a:effectRef>
-          <a:fontRef idx="minor">
-            <a:schemeClr val="lt1"/>
-          </a:fontRef>
-        </p:style>
-        <p:txBody>
-          <a:bodyPr rtlCol="0" anchor="ctr"/>
-          <a:lstStyle/>
-          <a:p>
-            <a:pPr marL="0" marR="0" lvl="0" indent="0" algn="ctr" defTabSz="914400" rtl="0" eaLnBrk="1" fontAlgn="auto" latinLnBrk="0" hangingPunct="1">
-              <a:lnSpc>
-                <a:spcPct val="100000"/>
-              </a:lnSpc>
-              <a:spcBef>
-                <a:spcPts val="0"/>
-              </a:spcBef>
-              <a:spcAft>
-                <a:spcPts val="0"/>
-              </a:spcAft>
-              <a:buClrTx/>
-              <a:buSzTx/>
-              <a:buFontTx/>
-              <a:buNone/>
-              <a:tabLst/>
-              <a:defRPr/>
-            </a:pPr>
-            <a:endParaRPr kumimoji="0" lang="en-US" sz="1800" b="0" i="0" u="none" strike="noStrike" kern="1200" cap="none" spc="0" normalizeH="0" baseline="0" noProof="0">
-              <a:ln>
-                <a:noFill/>
-              </a:ln>
-              <a:solidFill>
-                <a:prstClr val="white"/>
-              </a:solidFill>
-              <a:effectLst/>
-              <a:uLnTx/>
-              <a:uFillTx/>
-              <a:latin typeface="Calibri" panose="020F0502020204030204"/>
-              <a:ea typeface="+mn-ea"/>
-              <a:cs typeface="+mn-cs"/>
-            </a:endParaRPr>
-          </a:p>
-        </p:txBody>
-      </p:sp>
-      <p:sp>
-        <p:nvSpPr>
-          <p:cNvPr id="2" name="Title 1">
-            <a:extLst>
-              <a:ext uri="{FF2B5EF4-FFF2-40B4-BE49-F238E27FC236}">
-                <a16:creationId xmlns:a16="http://schemas.microsoft.com/office/drawing/2014/main" id="{7523CF74-09B7-84B3-F859-D7073DC1C80F}"/>
-              </a:ext>
-            </a:extLst>
-          </p:cNvPr>
-          <p:cNvSpPr>
-            <a:spLocks noGrp="1"/>
-          </p:cNvSpPr>
-          <p:nvPr>
-            <p:ph type="title"/>
-          </p:nvPr>
-        </p:nvSpPr>
-        <p:spPr>
-          <a:xfrm>
-            <a:off x="2103121" y="310343"/>
-            <a:ext cx="7985759" cy="868823"/>
-          </a:xfrm>
-        </p:spPr>
-        <p:txBody>
-          <a:bodyPr vert="horz" lIns="91440" tIns="45720" rIns="91440" bIns="45720" rtlCol="0" anchor="ctr">
-            <a:normAutofit/>
-          </a:bodyPr>
-          <a:lstStyle/>
-          <a:p>
-            <a:pPr algn="ctr"/>
-            <a:r>
-              <a:rPr lang="en-US" sz="4000" kern="1200">
-                <a:solidFill>
-                  <a:schemeClr val="tx1"/>
-                </a:solidFill>
-                <a:latin typeface="+mj-lt"/>
-                <a:ea typeface="+mj-ea"/>
-                <a:cs typeface="+mj-cs"/>
-              </a:rPr>
-              <a:t>Planning</a:t>
-            </a:r>
-          </a:p>
-        </p:txBody>
-      </p:sp>
-      <p:sp>
-        <p:nvSpPr>
-          <p:cNvPr id="32" name="Rectangle: Rounded Corners 31">
-            <a:extLst>
-              <a:ext uri="{FF2B5EF4-FFF2-40B4-BE49-F238E27FC236}">
-                <a16:creationId xmlns:a16="http://schemas.microsoft.com/office/drawing/2014/main" id="{586B4EF9-43BA-4655-A6FF-1D8E21574C95}"/>
-              </a:ext>
-              <a:ext uri="{C183D7F6-B498-43B3-948B-1728B52AA6E4}">
-                <adec:decorative xmlns:adec="http://schemas.microsoft.com/office/drawing/2017/decorative" val="1"/>
-              </a:ext>
-            </a:extLst>
-          </p:cNvPr>
-          <p:cNvSpPr>
-            <a:spLocks noGrp="1" noRot="1" noChangeAspect="1" noMove="1" noResize="1" noEditPoints="1" noAdjustHandles="1" noChangeArrowheads="1" noChangeShapeType="1" noTextEdit="1"/>
-          </p:cNvSpPr>
-          <p:nvPr>
-            <p:extLst>
-              <p:ext uri="{386F3935-93C4-4BCD-93E2-E3B085C9AB24}">
-                <p16:designElem xmlns:p16="http://schemas.microsoft.com/office/powerpoint/2015/main" val="1"/>
-              </p:ext>
-            </p:extLst>
-          </p:nvPr>
-        </p:nvSpPr>
-        <p:spPr>
-          <a:xfrm>
-            <a:off x="2483110" y="1211407"/>
-            <a:ext cx="7225780" cy="685800"/>
-          </a:xfrm>
-          <a:prstGeom prst="roundRect">
-            <a:avLst>
-              <a:gd name="adj" fmla="val 0"/>
-            </a:avLst>
-          </a:prstGeom>
-          <a:solidFill>
-            <a:schemeClr val="accent2"/>
-          </a:solidFill>
-          <a:ln>
-            <a:noFill/>
-          </a:ln>
-        </p:spPr>
-        <p:style>
-          <a:lnRef idx="2">
-            <a:schemeClr val="accent1">
-              <a:shade val="50000"/>
-            </a:schemeClr>
-          </a:lnRef>
-          <a:fillRef idx="1">
-            <a:schemeClr val="accent1"/>
-          </a:fillRef>
-          <a:effectRef idx="0">
-            <a:schemeClr val="accent1"/>
-          </a:effectRef>
-          <a:fontRef idx="minor">
-            <a:schemeClr val="lt1"/>
-          </a:fontRef>
-        </p:style>
-        <p:txBody>
-          <a:bodyPr rtlCol="0" anchor="ctr"/>
-          <a:lstStyle/>
-          <a:p>
-            <a:pPr algn="ctr"/>
-            <a:endParaRPr lang="en-US">
-              <a:solidFill>
-                <a:prstClr val="white"/>
-              </a:solidFill>
-              <a:latin typeface="Calibri" panose="020F0502020204030204"/>
-            </a:endParaRPr>
-          </a:p>
-        </p:txBody>
-      </p:sp>
-      <p:sp>
-        <p:nvSpPr>
-          <p:cNvPr id="3" name="Text Placeholder 2">
-            <a:extLst>
-              <a:ext uri="{FF2B5EF4-FFF2-40B4-BE49-F238E27FC236}">
-                <a16:creationId xmlns:a16="http://schemas.microsoft.com/office/drawing/2014/main" id="{C605E30C-3490-D1E3-740D-40AD5E393958}"/>
-              </a:ext>
-            </a:extLst>
-          </p:cNvPr>
-          <p:cNvSpPr>
-            <a:spLocks noGrp="1"/>
-          </p:cNvSpPr>
-          <p:nvPr>
-            <p:ph type="body" idx="1"/>
-          </p:nvPr>
-        </p:nvSpPr>
-        <p:spPr>
-          <a:xfrm>
-            <a:off x="2615738" y="1263807"/>
-            <a:ext cx="6960524" cy="598516"/>
-          </a:xfrm>
-        </p:spPr>
-        <p:txBody>
-          <a:bodyPr vert="horz" lIns="91440" tIns="45720" rIns="91440" bIns="45720" rtlCol="0" anchor="ctr">
-            <a:normAutofit/>
-          </a:bodyPr>
-          <a:lstStyle/>
-          <a:p>
-            <a:pPr algn="ctr"/>
-            <a:r>
-              <a:rPr lang="en-US" sz="2000" kern="1200">
-                <a:solidFill>
-                  <a:schemeClr val="bg1"/>
-                </a:solidFill>
-                <a:latin typeface="+mn-lt"/>
-                <a:ea typeface="+mn-ea"/>
-                <a:cs typeface="+mn-cs"/>
-              </a:rPr>
-              <a:t>Gant chart</a:t>
-            </a:r>
-          </a:p>
-        </p:txBody>
-      </p:sp>
-      <p:pic>
-        <p:nvPicPr>
-          <p:cNvPr id="6" name="Picture 5">
-            <a:extLst>
-              <a:ext uri="{FF2B5EF4-FFF2-40B4-BE49-F238E27FC236}">
-                <a16:creationId xmlns:a16="http://schemas.microsoft.com/office/drawing/2014/main" id="{0D4E0165-E852-9E37-91F6-9A7920B23AEB}"/>
-              </a:ext>
-            </a:extLst>
-          </p:cNvPr>
-          <p:cNvPicPr>
-            <a:picLocks noChangeAspect="1"/>
-          </p:cNvPicPr>
-          <p:nvPr/>
-        </p:nvPicPr>
-        <p:blipFill>
-          <a:blip r:embed="rId2"/>
-          <a:stretch>
-            <a:fillRect/>
-          </a:stretch>
-        </p:blipFill>
-        <p:spPr>
-          <a:xfrm>
-            <a:off x="926432" y="2024164"/>
-            <a:ext cx="10503568" cy="4706879"/>
-          </a:xfrm>
-          <a:prstGeom prst="rect">
-            <a:avLst/>
-          </a:prstGeom>
-          <a:ln>
-            <a:solidFill>
-              <a:schemeClr val="accent2"/>
-            </a:solidFill>
-          </a:ln>
-        </p:spPr>
-      </p:pic>
-    </p:spTree>
-    <p:extLst>
-      <p:ext uri="{BB962C8B-B14F-4D97-AF65-F5344CB8AC3E}">
-        <p14:creationId xmlns:p14="http://schemas.microsoft.com/office/powerpoint/2010/main" val="3713997872"/>
-      </p:ext>
-    </p:extLst>
-  </p:cSld>
-  <p:clrMapOvr>
-    <a:masterClrMapping/>
-  </p:clrMapOvr>
-</p:sld>
-</file>
-
-<file path=ppt/slides/slide9.xml><?xml version="1.0" encoding="utf-8"?>
-<p:sld xmlns:a="http://schemas.openxmlformats.org/drawingml/2006/main" xmlns:r="http://schemas.openxmlformats.org/officeDocument/2006/relationships" xmlns:p="http://schemas.openxmlformats.org/presentationml/2006/main">
-  <p:cSld>
-    <p:bg>
-      <p:bgPr>
-        <a:solidFill>
-          <a:schemeClr val="bg1"/>
-        </a:solidFill>
-        <a:effectLst/>
-      </p:bgPr>
-    </p:bg>
-    <p:spTree>
-      <p:nvGrpSpPr>
-        <p:cNvPr id="1" name=""/>
-        <p:cNvGrpSpPr/>
-        <p:nvPr/>
-      </p:nvGrpSpPr>
-      <p:grpSpPr>
-        <a:xfrm>
-          <a:off x="0" y="0"/>
-          <a:ext cx="0" cy="0"/>
-          <a:chOff x="0" y="0"/>
-          <a:chExt cx="0" cy="0"/>
-        </a:xfrm>
-      </p:grpSpPr>
-      <p:sp useBgFill="1">
-        <p:nvSpPr>
-          <p:cNvPr id="7" name="Rectangle 6">
-            <a:extLst>
-              <a:ext uri="{FF2B5EF4-FFF2-40B4-BE49-F238E27FC236}">
-                <a16:creationId xmlns:a16="http://schemas.microsoft.com/office/drawing/2014/main" id="{9C7E0A2C-7C0A-4AAC-B3B0-6C12B2EBAE05}"/>
-              </a:ext>
-              <a:ext uri="{C183D7F6-B498-43B3-948B-1728B52AA6E4}">
-                <adec:decorative xmlns:adec="http://schemas.microsoft.com/office/drawing/2017/decorative" val="1"/>
-              </a:ext>
-            </a:extLst>
-          </p:cNvPr>
-          <p:cNvSpPr>
-            <a:spLocks noGrp="1" noRot="1" noChangeAspect="1" noMove="1" noResize="1" noEditPoints="1" noAdjustHandles="1" noChangeArrowheads="1" noChangeShapeType="1" noTextEdit="1"/>
-          </p:cNvSpPr>
-          <p:nvPr>
-            <p:extLst>
-              <p:ext uri="{386F3935-93C4-4BCD-93E2-E3B085C9AB24}">
-                <p16:designElem xmlns:p16="http://schemas.microsoft.com/office/powerpoint/2015/main" val="1"/>
-              </p:ext>
-            </p:extLst>
-          </p:nvPr>
-        </p:nvSpPr>
-        <p:spPr>
-          <a:xfrm>
-            <a:off x="0" y="0"/>
-            <a:ext cx="12191999" cy="6857365"/>
-          </a:xfrm>
-          <a:prstGeom prst="rect">
-            <a:avLst/>
-          </a:prstGeom>
-          <a:ln>
-            <a:noFill/>
-          </a:ln>
-        </p:spPr>
-        <p:style>
-          <a:lnRef idx="2">
-            <a:schemeClr val="accent1">
-              <a:shade val="50000"/>
-            </a:schemeClr>
-          </a:lnRef>
-          <a:fillRef idx="1">
-            <a:schemeClr val="accent1"/>
-          </a:fillRef>
-          <a:effectRef idx="0">
-            <a:schemeClr val="accent1"/>
-          </a:effectRef>
-          <a:fontRef idx="minor">
-            <a:schemeClr val="lt1"/>
-          </a:fontRef>
-        </p:style>
-        <p:txBody>
-          <a:bodyPr rtlCol="0" anchor="ctr"/>
-          <a:lstStyle/>
-          <a:p>
-            <a:pPr algn="ctr"/>
-            <a:endParaRPr lang="en-US"/>
-          </a:p>
-        </p:txBody>
-      </p:sp>
-      <p:sp>
-        <p:nvSpPr>
-          <p:cNvPr id="9" name="Rectangle 8">
-            <a:extLst>
-              <a:ext uri="{FF2B5EF4-FFF2-40B4-BE49-F238E27FC236}">
-                <a16:creationId xmlns:a16="http://schemas.microsoft.com/office/drawing/2014/main" id="{5EB7D2A2-F448-44D4-938C-DC84CBCB3B1E}"/>
-              </a:ext>
-              <a:ext uri="{C183D7F6-B498-43B3-948B-1728B52AA6E4}">
-                <adec:decorative xmlns:adec="http://schemas.microsoft.com/office/drawing/2017/decorative" val="1"/>
-              </a:ext>
-            </a:extLst>
-          </p:cNvPr>
-          <p:cNvSpPr>
-            <a:spLocks noGrp="1" noRot="1" noChangeAspect="1" noMove="1" noResize="1" noEditPoints="1" noAdjustHandles="1" noChangeArrowheads="1" noChangeShapeType="1" noTextEdit="1"/>
-          </p:cNvSpPr>
-          <p:nvPr>
-            <p:extLst>
-              <p:ext uri="{386F3935-93C4-4BCD-93E2-E3B085C9AB24}">
-                <p16:designElem xmlns:p16="http://schemas.microsoft.com/office/powerpoint/2015/main" val="1"/>
-              </p:ext>
-            </p:extLst>
-          </p:nvPr>
-        </p:nvSpPr>
-        <p:spPr>
-          <a:xfrm>
-            <a:off x="0" y="1"/>
-            <a:ext cx="12192000" cy="5187142"/>
-          </a:xfrm>
-          <a:prstGeom prst="rect">
-            <a:avLst/>
-          </a:prstGeom>
-          <a:solidFill>
-            <a:schemeClr val="accent4"/>
-          </a:solidFill>
-          <a:ln>
-            <a:noFill/>
-          </a:ln>
-        </p:spPr>
-        <p:style>
-          <a:lnRef idx="2">
-            <a:schemeClr val="accent1">
-              <a:shade val="50000"/>
-            </a:schemeClr>
-          </a:lnRef>
-          <a:fillRef idx="1">
-            <a:schemeClr val="accent1"/>
-          </a:fillRef>
-          <a:effectRef idx="0">
-            <a:schemeClr val="accent1"/>
-          </a:effectRef>
-          <a:fontRef idx="minor">
-            <a:schemeClr val="lt1"/>
-          </a:fontRef>
-        </p:style>
-        <p:txBody>
-          <a:bodyPr rtlCol="0" anchor="ctr"/>
-          <a:lstStyle/>
-          <a:p>
-            <a:pPr algn="ctr"/>
-            <a:endParaRPr lang="en-US" dirty="0"/>
-          </a:p>
-        </p:txBody>
-      </p:sp>
-      <p:sp>
-        <p:nvSpPr>
-          <p:cNvPr id="11" name="Rectangle 10">
-            <a:extLst>
-              <a:ext uri="{FF2B5EF4-FFF2-40B4-BE49-F238E27FC236}">
-                <a16:creationId xmlns:a16="http://schemas.microsoft.com/office/drawing/2014/main" id="{871AEA07-1E14-44B4-8E55-64EF049CD66F}"/>
-              </a:ext>
-              <a:ext uri="{C183D7F6-B498-43B3-948B-1728B52AA6E4}">
-                <adec:decorative xmlns:adec="http://schemas.microsoft.com/office/drawing/2017/decorative" val="1"/>
-              </a:ext>
-            </a:extLst>
-          </p:cNvPr>
-          <p:cNvSpPr>
-            <a:spLocks noGrp="1" noRot="1" noChangeAspect="1" noMove="1" noResize="1" noEditPoints="1" noAdjustHandles="1" noChangeArrowheads="1" noChangeShapeType="1" noTextEdit="1"/>
-          </p:cNvSpPr>
-          <p:nvPr>
-            <p:extLst>
-              <p:ext uri="{386F3935-93C4-4BCD-93E2-E3B085C9AB24}">
-                <p16:designElem xmlns:p16="http://schemas.microsoft.com/office/powerpoint/2015/main" val="1"/>
-              </p:ext>
-            </p:extLst>
-          </p:nvPr>
-        </p:nvSpPr>
-        <p:spPr>
-          <a:xfrm>
-            <a:off x="596464" y="551961"/>
-            <a:ext cx="10999072" cy="5399950"/>
-          </a:xfrm>
-          <a:prstGeom prst="rect">
-            <a:avLst/>
-          </a:prstGeom>
-          <a:solidFill>
-            <a:schemeClr val="bg1"/>
-          </a:solidFill>
-          <a:ln>
-            <a:noFill/>
-          </a:ln>
-          <a:effectLst>
-            <a:outerShdw blurRad="139700" dist="127000" dir="5400000" algn="t" rotWithShape="0">
-              <a:prstClr val="black">
-                <a:alpha val="15000"/>
-              </a:prstClr>
-            </a:outerShdw>
-          </a:effectLst>
-        </p:spPr>
-        <p:style>
-          <a:lnRef idx="2">
-            <a:schemeClr val="accent1">
-              <a:shade val="50000"/>
-            </a:schemeClr>
-          </a:lnRef>
-          <a:fillRef idx="1">
-            <a:schemeClr val="accent1"/>
-          </a:fillRef>
-          <a:effectRef idx="0">
-            <a:schemeClr val="accent1"/>
-          </a:effectRef>
-          <a:fontRef idx="minor">
-            <a:schemeClr val="lt1"/>
-          </a:fontRef>
-        </p:style>
-        <p:txBody>
-          <a:bodyPr rtlCol="0" anchor="ctr"/>
-          <a:lstStyle/>
-          <a:p>
-            <a:pPr algn="ctr"/>
-            <a:endParaRPr lang="en-US"/>
-          </a:p>
-        </p:txBody>
-      </p:sp>
-      <p:sp>
-        <p:nvSpPr>
-          <p:cNvPr id="2" name="Title 1">
-            <a:extLst>
-              <a:ext uri="{FF2B5EF4-FFF2-40B4-BE49-F238E27FC236}">
-                <a16:creationId xmlns:a16="http://schemas.microsoft.com/office/drawing/2014/main" id="{9C9AD6B9-1CEE-7976-0BB7-22F5E9535735}"/>
-              </a:ext>
-            </a:extLst>
-          </p:cNvPr>
-          <p:cNvSpPr>
-            <a:spLocks noGrp="1"/>
-          </p:cNvSpPr>
-          <p:nvPr>
-            <p:ph type="title"/>
-          </p:nvPr>
-        </p:nvSpPr>
-        <p:spPr>
-          <a:xfrm>
-            <a:off x="1523999" y="1180494"/>
-            <a:ext cx="9144000" cy="2387600"/>
-          </a:xfrm>
-        </p:spPr>
-        <p:txBody>
-          <a:bodyPr vert="horz" lIns="91440" tIns="45720" rIns="91440" bIns="45720" rtlCol="0" anchor="b">
-            <a:normAutofit/>
-          </a:bodyPr>
-          <a:lstStyle/>
-          <a:p>
-            <a:pPr algn="ctr"/>
-            <a:r>
-              <a:rPr lang="en-US" sz="3500" kern="1200" dirty="0">
-                <a:solidFill>
-                  <a:schemeClr val="tx1"/>
-                </a:solidFill>
-                <a:latin typeface="+mj-lt"/>
-                <a:ea typeface="+mj-ea"/>
-                <a:cs typeface="+mj-cs"/>
-              </a:rPr>
-              <a:t>Website: </a:t>
-            </a:r>
-            <a:r>
-              <a:rPr lang="en-US" sz="3500" kern="1200" dirty="0">
-                <a:solidFill>
-                  <a:srgbClr val="0070C0"/>
-                </a:solidFill>
-                <a:latin typeface="+mj-lt"/>
-                <a:ea typeface="+mj-ea"/>
-                <a:cs typeface="+mj-cs"/>
-                <a:hlinkClick r:id="rId2">
-                  <a:extLst>
-                    <a:ext uri="{A12FA001-AC4F-418D-AE19-62706E023703}">
-                      <ahyp:hlinkClr xmlns:ahyp="http://schemas.microsoft.com/office/drawing/2018/hyperlinkcolor" val="tx"/>
-                    </a:ext>
-                  </a:extLst>
-                </a:hlinkClick>
-              </a:rPr>
-              <a:t>https://jjdeuce06.github.io/VulcanActivityTracker/</a:t>
-            </a:r>
-            <a:endParaRPr lang="en-US" sz="3500" kern="1200" dirty="0">
-              <a:solidFill>
-                <a:srgbClr val="0070C0"/>
-              </a:solidFill>
-              <a:latin typeface="+mj-lt"/>
-              <a:ea typeface="+mj-ea"/>
-              <a:cs typeface="+mj-cs"/>
-            </a:endParaRPr>
-          </a:p>
-        </p:txBody>
-      </p:sp>
-      <p:cxnSp>
-        <p:nvCxnSpPr>
-          <p:cNvPr id="13" name="Straight Connector 12">
-            <a:extLst>
-              <a:ext uri="{FF2B5EF4-FFF2-40B4-BE49-F238E27FC236}">
-                <a16:creationId xmlns:a16="http://schemas.microsoft.com/office/drawing/2014/main" id="{F7C8EA93-3210-4C62-99E9-153C275E3A87}"/>
-              </a:ext>
-              <a:ext uri="{C183D7F6-B498-43B3-948B-1728B52AA6E4}">
-                <adec:decorative xmlns:adec="http://schemas.microsoft.com/office/drawing/2017/decorative" val="1"/>
-              </a:ext>
-            </a:extLst>
-          </p:cNvPr>
-          <p:cNvCxnSpPr>
-            <a:cxnSpLocks noGrp="1" noRot="1" noChangeAspect="1" noMove="1" noResize="1" noEditPoints="1" noAdjustHandles="1" noChangeArrowheads="1" noChangeShapeType="1"/>
-          </p:cNvCxnSpPr>
-          <p:nvPr>
-            <p:extLst>
-              <p:ext uri="{386F3935-93C4-4BCD-93E2-E3B085C9AB24}">
-                <p16:designElem xmlns:p16="http://schemas.microsoft.com/office/powerpoint/2015/main" val="1"/>
-              </p:ext>
-            </p:extLst>
-          </p:nvPr>
-        </p:nvCxnSpPr>
-        <p:spPr>
-          <a:xfrm flipH="1">
-            <a:off x="596464" y="6329769"/>
-            <a:ext cx="11000232" cy="0"/>
-          </a:xfrm>
-          <a:prstGeom prst="line">
-            <a:avLst/>
-          </a:prstGeom>
-          <a:ln w="152400">
-            <a:solidFill>
-              <a:schemeClr val="accent4"/>
-            </a:solidFill>
-          </a:ln>
-        </p:spPr>
-        <p:style>
-          <a:lnRef idx="1">
-            <a:schemeClr val="accent1"/>
-          </a:lnRef>
-          <a:fillRef idx="0">
-            <a:schemeClr val="accent1"/>
-          </a:fillRef>
-          <a:effectRef idx="0">
-            <a:schemeClr val="accent1"/>
-          </a:effectRef>
-          <a:fontRef idx="minor">
-            <a:schemeClr val="tx1"/>
-          </a:fontRef>
-        </p:style>
-      </p:cxnSp>
-    </p:spTree>
-    <p:extLst>
-      <p:ext uri="{BB962C8B-B14F-4D97-AF65-F5344CB8AC3E}">
-        <p14:creationId xmlns:p14="http://schemas.microsoft.com/office/powerpoint/2010/main" val="3921983173"/>
       </p:ext>
     </p:extLst>
   </p:cSld>

</xml_diff>